<commit_message>
Divide flow diagram into 3 high-resolution slides with dedicated architecture callouts
</commit_message>
<xml_diff>
--- a/AI_Credit_Scoring_Conference_Master_Presentation.pptx
+++ b/AI_Credit_Scoring_Conference_Master_Presentation.pptx
@@ -19,6 +19,8 @@
     <p:sldId id="267" r:id="rId18"/>
     <p:sldId id="268" r:id="rId19"/>
     <p:sldId id="269" r:id="rId20"/>
+    <p:sldId id="270" r:id="rId21"/>
+    <p:sldId id="271" r:id="rId22"/>
   </p:sldIdLst>
   <p:sldSz cx="12191695" cy="6858000" type="screen4x3"/>
   <p:notesSz cx="6858000" cy="9144000"/>
@@ -3350,7 +3352,7 @@
               </a:defRPr>
             </a:pPr>
             <a:r>
-              <a:t>Explainable AI &amp; Adverse Action Codes (TreeSHAP)</a:t>
+              <a:t>Credit Score Calibration &amp; Rating Distribution</a:t>
             </a:r>
           </a:p>
           <a:p>
@@ -3365,7 +3367,7 @@
               </a:defRPr>
             </a:pPr>
             <a:r>
-              <a:t>Local Shapley Value Feature Attribution &amp; Regulatory Disclosures</a:t>
+              <a:t>Points to Double Odds (PDO = 20, Base = 600 @ 50:1) across 250,000 Portfolio Accounts</a:t>
             </a:r>
           </a:p>
         </p:txBody>
@@ -3389,7 +3391,7 @@
           </a:solidFill>
           <a:ln w="19050">
             <a:solidFill>
-              <a:srgbClr val="38BDF8"/>
+              <a:srgbClr val="FBBF24"/>
             </a:solidFill>
           </a:ln>
         </p:spPr>
@@ -3445,89 +3447,89 @@
               </a:defRPr>
             </a:pPr>
             <a:r>
-              <a:t>Algorithmic Transparency</a:t>
-            </a:r>
-          </a:p>
-          <a:p>
-            <a:pPr>
-              <a:spcBef>
-                <a:spcPts val="500"/>
-              </a:spcBef>
-              <a:defRPr sz="1150">
-                <a:solidFill>
-                  <a:srgbClr val="F8FAFC"/>
-                </a:solidFill>
-              </a:defRPr>
-            </a:pPr>
-            <a:r>
-              <a:t>• Game-Theoretic Attribution: Exact Shapley decomposition in &lt; 5ms.</a:t>
-            </a:r>
-          </a:p>
-          <a:p>
-            <a:pPr>
-              <a:spcBef>
-                <a:spcPts val="500"/>
-              </a:spcBef>
-              <a:defRPr sz="1150">
-                <a:solidFill>
-                  <a:srgbClr val="F8FAFC"/>
-                </a:solidFill>
-              </a:defRPr>
-            </a:pPr>
-            <a:r>
-              <a:t>• Regulatory Audit Trail: Every decision logs model version, feature vector, and SHAP vector.</a:t>
-            </a:r>
-          </a:p>
-          <a:p>
-            <a:pPr>
-              <a:spcBef>
-                <a:spcPts val="500"/>
-              </a:spcBef>
-              <a:defRPr sz="1150">
-                <a:solidFill>
-                  <a:srgbClr val="F8FAFC"/>
-                </a:solidFill>
-              </a:defRPr>
-            </a:pPr>
-            <a:r>
-              <a:t>• Positive Trust Enhancers: Highlights key driver strengths that qualified the borrower.</a:t>
-            </a:r>
-          </a:p>
-          <a:p>
-            <a:pPr>
-              <a:spcBef>
-                <a:spcPts val="500"/>
-              </a:spcBef>
-              <a:defRPr sz="1150">
-                <a:solidFill>
-                  <a:srgbClr val="F8FAFC"/>
-                </a:solidFill>
-              </a:defRPr>
-            </a:pPr>
-            <a:r>
-              <a:t>• Adverse Action Disclosures: Clear, actionable decline justifications for applicants.</a:t>
-            </a:r>
-          </a:p>
-          <a:p>
-            <a:pPr>
-              <a:spcBef>
-                <a:spcPts val="500"/>
-              </a:spcBef>
-              <a:defRPr sz="1150">
-                <a:solidFill>
-                  <a:srgbClr val="F8FAFC"/>
-                </a:solidFill>
-              </a:defRPr>
-            </a:pPr>
-            <a:r>
-              <a:t>• Eliminates Disparate Impact: Protected attributes strictly excluded.</a:t>
+              <a:t>Score Bands &amp; Acceptance Policy</a:t>
+            </a:r>
+          </a:p>
+          <a:p>
+            <a:pPr>
+              <a:spcBef>
+                <a:spcPts val="500"/>
+              </a:spcBef>
+              <a:defRPr sz="1150">
+                <a:solidFill>
+                  <a:srgbClr val="F8FAFC"/>
+                </a:solidFill>
+              </a:defRPr>
+            </a:pPr>
+            <a:r>
+              <a:t>• Grade A (780-850 | PD &lt;= 1.0%): 14.2% share. VIP Instant Auto-Approval.</a:t>
+            </a:r>
+          </a:p>
+          <a:p>
+            <a:pPr>
+              <a:spcBef>
+                <a:spcPts val="500"/>
+              </a:spcBef>
+              <a:defRPr sz="1150">
+                <a:solidFill>
+                  <a:srgbClr val="F8FAFC"/>
+                </a:solidFill>
+              </a:defRPr>
+            </a:pPr>
+            <a:r>
+              <a:t>• Grade B (700-779 | PD 1.0%-3.0%): 31.8% share. Core prime retail borrowing.</a:t>
+            </a:r>
+          </a:p>
+          <a:p>
+            <a:pPr>
+              <a:spcBef>
+                <a:spcPts val="500"/>
+              </a:spcBef>
+              <a:defRPr sz="1150">
+                <a:solidFill>
+                  <a:srgbClr val="F8FAFC"/>
+                </a:solidFill>
+              </a:defRPr>
+            </a:pPr>
+            <a:r>
+              <a:t>• Grade C (620-699 | PD 3.0%-7.0%): 28.5% share. Standard monitored terms.</a:t>
+            </a:r>
+          </a:p>
+          <a:p>
+            <a:pPr>
+              <a:spcBef>
+                <a:spcPts val="500"/>
+              </a:spcBef>
+              <a:defRPr sz="1150">
+                <a:solidFill>
+                  <a:srgbClr val="F8FAFC"/>
+                </a:solidFill>
+              </a:defRPr>
+            </a:pPr>
+            <a:r>
+              <a:t>• Grade D (550-619 | PD 7.0%-15.0%): 16.1% share. Strictly constrained limits.</a:t>
+            </a:r>
+          </a:p>
+          <a:p>
+            <a:pPr>
+              <a:spcBef>
+                <a:spcPts val="500"/>
+              </a:spcBef>
+              <a:defRPr sz="1150">
+                <a:solidFill>
+                  <a:srgbClr val="F8FAFC"/>
+                </a:solidFill>
+              </a:defRPr>
+            </a:pPr>
+            <a:r>
+              <a:t>• Grade E (300-549 | PD &gt; 15.0%): 9.4% share. Systematic Policy Decline.</a:t>
             </a:r>
           </a:p>
         </p:txBody>
       </p:sp>
       <p:pic>
         <p:nvPicPr>
-          <p:cNvPr id="6" name="Picture 5" descr="chart_shap_waterfall.png"/>
+          <p:cNvPr id="6" name="Picture 5" descr="chart_grade_distribution.png"/>
           <p:cNvPicPr>
             <a:picLocks noChangeAspect="1"/>
           </p:cNvPicPr>
@@ -3640,7 +3642,7 @@
               </a:defRPr>
             </a:pPr>
             <a:r>
-              <a:t>IFRS 9 ECL Provisioning &amp; Core Accounting Ledger</a:t>
+              <a:t>4-Bound Multi-Constraint Limit Engine</a:t>
             </a:r>
           </a:p>
           <a:p>
@@ -3655,7 +3657,7 @@
               </a:defRPr>
             </a:pPr>
             <a:r>
-              <a:t>Automated Regulatory Impairment Staging and Double-Entry Ledgering</a:t>
+              <a:t>Mathematical Capital Preservation Guarantee (min(B1, B2, B3, B4))</a:t>
             </a:r>
           </a:p>
         </p:txBody>
@@ -3669,7 +3671,162 @@
         <p:spPr>
           <a:xfrm>
             <a:off x="731520" y="1645920"/>
-            <a:ext cx="4754880" cy="4754880"/>
+            <a:ext cx="5120640" cy="4754880"/>
+          </a:xfrm>
+          <a:prstGeom prst="roundRect">
+            <a:avLst/>
+          </a:prstGeom>
+          <a:solidFill>
+            <a:srgbClr val="131E36"/>
+          </a:solidFill>
+          <a:ln w="19050">
+            <a:solidFill>
+              <a:srgbClr val="34D399"/>
+            </a:solidFill>
+          </a:ln>
+        </p:spPr>
+        <p:style>
+          <a:lnRef idx="1">
+            <a:schemeClr val="accent1"/>
+          </a:lnRef>
+          <a:fillRef idx="3">
+            <a:schemeClr val="accent1"/>
+          </a:fillRef>
+          <a:effectRef idx="2">
+            <a:schemeClr val="accent1"/>
+          </a:effectRef>
+          <a:fontRef idx="minor">
+            <a:schemeClr val="lt1"/>
+          </a:fontRef>
+        </p:style>
+        <p:txBody>
+          <a:bodyPr rtlCol="0" anchor="ctr"/>
+          <a:lstStyle/>
+          <a:p>
+            <a:pPr algn="ctr"/>
+          </a:p>
+        </p:txBody>
+      </p:sp>
+      <p:sp>
+        <p:nvSpPr>
+          <p:cNvPr id="5" name="TextBox 4"/>
+          <p:cNvSpPr txBox="1"/>
+          <p:nvPr/>
+        </p:nvSpPr>
+        <p:spPr>
+          <a:xfrm>
+            <a:off x="914400" y="1828800"/>
+            <a:ext cx="4754879" cy="4389120"/>
+          </a:xfrm>
+          <a:prstGeom prst="rect">
+            <a:avLst/>
+          </a:prstGeom>
+          <a:noFill/>
+        </p:spPr>
+        <p:txBody>
+          <a:bodyPr wrap="square">
+            <a:spAutoFit/>
+          </a:bodyPr>
+          <a:lstStyle/>
+          <a:p>
+            <a:pPr>
+              <a:defRPr sz="1600" b="1">
+                <a:solidFill>
+                  <a:srgbClr val="FBBF24"/>
+                </a:solidFill>
+              </a:defRPr>
+            </a:pPr>
+            <a:r>
+              <a:t>The 4 Sizing Boundaries</a:t>
+            </a:r>
+          </a:p>
+          <a:p>
+            <a:pPr>
+              <a:spcBef>
+                <a:spcPts val="500"/>
+              </a:spcBef>
+              <a:defRPr sz="1150">
+                <a:solidFill>
+                  <a:srgbClr val="F8FAFC"/>
+                </a:solidFill>
+              </a:defRPr>
+            </a:pPr>
+            <a:r>
+              <a:t>• Bound 1 (Affordability): Max EMI based on conservative P10 income capped at FOIR &lt;= 45%.</a:t>
+            </a:r>
+          </a:p>
+          <a:p>
+            <a:pPr>
+              <a:spcBef>
+                <a:spcPts val="500"/>
+              </a:spcBef>
+              <a:defRPr sz="1150">
+                <a:solidFill>
+                  <a:srgbClr val="F8FAFC"/>
+                </a:solidFill>
+              </a:defRPr>
+            </a:pPr>
+            <a:r>
+              <a:t>• Bound 2 (Risk Cap): k(Grade) * P50 income * 12 * 0.50 (where k = 1.5 for Grade A, down to 0.0 for Grade E).</a:t>
+            </a:r>
+          </a:p>
+          <a:p>
+            <a:pPr>
+              <a:spcBef>
+                <a:spcPts val="500"/>
+              </a:spcBef>
+              <a:defRPr sz="1150">
+                <a:solidFill>
+                  <a:srgbClr val="F8FAFC"/>
+                </a:solidFill>
+              </a:defRPr>
+            </a:pPr>
+            <a:r>
+              <a:t>• Bound 3 (Policy Cap): PKR 2,000,000 fixed institutional ceiling.</a:t>
+            </a:r>
+          </a:p>
+          <a:p>
+            <a:pPr>
+              <a:spcBef>
+                <a:spcPts val="500"/>
+              </a:spcBef>
+              <a:defRPr sz="1150">
+                <a:solidFill>
+                  <a:srgbClr val="F8FAFC"/>
+                </a:solidFill>
+              </a:defRPr>
+            </a:pPr>
+            <a:r>
+              <a:t>• Bound 4 (Progression): PKR 50,000 * 1.5^(min(Clean Cycles, 6)). Anti-Bust-Out step-up ladder.</a:t>
+            </a:r>
+          </a:p>
+          <a:p>
+            <a:pPr>
+              <a:spcBef>
+                <a:spcPts val="500"/>
+              </a:spcBef>
+              <a:defRPr sz="1150">
+                <a:solidFill>
+                  <a:srgbClr val="F8FAFC"/>
+                </a:solidFill>
+              </a:defRPr>
+            </a:pPr>
+            <a:r>
+              <a:t>• Final Approved Limit: min(Bound 1, Bound 2, Bound 3, Bound 4).</a:t>
+            </a:r>
+          </a:p>
+        </p:txBody>
+      </p:sp>
+      <p:sp>
+        <p:nvSpPr>
+          <p:cNvPr id="6" name="Rounded Rectangle 5"/>
+          <p:cNvSpPr/>
+          <p:nvPr/>
+        </p:nvSpPr>
+        <p:spPr>
+          <a:xfrm>
+            <a:off x="6217920" y="1645920"/>
+            <a:ext cx="5120640" cy="4754880"/>
           </a:xfrm>
           <a:prstGeom prst="roundRect">
             <a:avLst/>
@@ -3707,14 +3864,14 @@
       </p:sp>
       <p:sp>
         <p:nvSpPr>
-          <p:cNvPr id="5" name="TextBox 4"/>
+          <p:cNvPr id="7" name="TextBox 6"/>
           <p:cNvSpPr txBox="1"/>
           <p:nvPr/>
         </p:nvSpPr>
         <p:spPr>
           <a:xfrm>
-            <a:off x="914400" y="1828800"/>
-            <a:ext cx="4389120" cy="4389120"/>
+            <a:off x="6400800" y="1828800"/>
+            <a:ext cx="4754879" cy="4389120"/>
           </a:xfrm>
           <a:prstGeom prst="rect">
             <a:avLst/>
@@ -3735,110 +3892,86 @@
               </a:defRPr>
             </a:pPr>
             <a:r>
-              <a:t>Stage Transitions &amp; Provisioning</a:t>
-            </a:r>
-          </a:p>
-          <a:p>
-            <a:pPr>
-              <a:spcBef>
-                <a:spcPts val="500"/>
-              </a:spcBef>
-              <a:defRPr sz="1150">
-                <a:solidFill>
-                  <a:srgbClr val="F8FAFC"/>
-                </a:solidFill>
-              </a:defRPr>
-            </a:pPr>
-            <a:r>
-              <a:t>• Formula: ECL = PD * LGD * EAD * Discount Factor.</a:t>
-            </a:r>
-          </a:p>
-          <a:p>
-            <a:pPr>
-              <a:spcBef>
-                <a:spcPts val="500"/>
-              </a:spcBef>
-              <a:defRPr sz="1150">
-                <a:solidFill>
-                  <a:srgbClr val="F8FAFC"/>
-                </a:solidFill>
-              </a:defRPr>
-            </a:pPr>
-            <a:r>
-              <a:t>• Stage 1 (Normal): 12-Month ECL for loans &lt;30 DPD (ECL = PKR 18.4M on PKR 1.84B EAD).</a:t>
-            </a:r>
-          </a:p>
-          <a:p>
-            <a:pPr>
-              <a:spcBef>
-                <a:spcPts val="500"/>
-              </a:spcBef>
-              <a:defRPr sz="1150">
-                <a:solidFill>
-                  <a:srgbClr val="F8FAFC"/>
-                </a:solidFill>
-              </a:defRPr>
-            </a:pPr>
-            <a:r>
-              <a:t>• Stage 2 (SICR): Lifetime ECL for loans 30-89 DPD (ECL = PKR 44.3M on PKR 295M EAD).</a:t>
-            </a:r>
-          </a:p>
-          <a:p>
-            <a:pPr>
-              <a:spcBef>
-                <a:spcPts val="500"/>
-              </a:spcBef>
-              <a:defRPr sz="1150">
-                <a:solidFill>
-                  <a:srgbClr val="F8FAFC"/>
-                </a:solidFill>
-              </a:defRPr>
-            </a:pPr>
-            <a:r>
-              <a:t>• Stage 3 (Default): Specific Impairment &gt;=90 DPD (ECL = PKR 59.0M on PKR 84M EAD).</a:t>
-            </a:r>
-          </a:p>
-          <a:p>
-            <a:pPr>
-              <a:spcBef>
-                <a:spcPts val="500"/>
-              </a:spcBef>
-              <a:defRPr sz="1150">
-                <a:solidFill>
-                  <a:srgbClr val="F8FAFC"/>
-                </a:solidFill>
-              </a:defRPr>
-            </a:pPr>
-            <a:r>
-              <a:t>• Double-Entry Accounting: Ledger writes append-only records to disbursed_loans.parquet.</a:t>
-            </a:r>
-          </a:p>
-        </p:txBody>
-      </p:sp>
-      <p:pic>
-        <p:nvPicPr>
-          <p:cNvPr id="6" name="Picture 5" descr="chart_ifrs9_staging.png"/>
-          <p:cNvPicPr>
-            <a:picLocks noChangeAspect="1"/>
-          </p:cNvPicPr>
-          <p:nvPr/>
-        </p:nvPicPr>
-        <p:blipFill>
-          <a:blip r:embed="rId2"/>
-          <a:stretch>
-            <a:fillRect/>
-          </a:stretch>
-        </p:blipFill>
-        <p:spPr>
-          <a:xfrm>
-            <a:off x="5760720" y="1645920"/>
-            <a:ext cx="5669280" cy="4754880"/>
-          </a:xfrm>
-          <a:prstGeom prst="rect">
-            <a:avLst/>
-          </a:prstGeom>
-        </p:spPr>
-      </p:pic>
+              <a:t>Regulatory APR &amp; Pricing Engine</a:t>
+            </a:r>
+          </a:p>
+          <a:p>
+            <a:pPr>
+              <a:spcBef>
+                <a:spcPts val="500"/>
+              </a:spcBef>
+              <a:defRPr sz="1150">
+                <a:solidFill>
+                  <a:srgbClr val="F8FAFC"/>
+                </a:solidFill>
+              </a:defRPr>
+            </a:pPr>
+            <a:r>
+              <a:t>• SBP Usury Cap: Hard statutory ceiling at 36.0% per annum.</a:t>
+            </a:r>
+          </a:p>
+          <a:p>
+            <a:pPr>
+              <a:spcBef>
+                <a:spcPts val="500"/>
+              </a:spcBef>
+              <a:defRPr sz="1150">
+                <a:solidFill>
+                  <a:srgbClr val="F8FAFC"/>
+                </a:solidFill>
+              </a:defRPr>
+            </a:pPr>
+            <a:r>
+              <a:t>• Risk-Based Spread: Base KIBOR (18.5%) + Grade Risk Spread (4% to 16%).</a:t>
+            </a:r>
+          </a:p>
+          <a:p>
+            <a:pPr>
+              <a:spcBef>
+                <a:spcPts val="500"/>
+              </a:spcBef>
+              <a:defRPr sz="1150">
+                <a:solidFill>
+                  <a:srgbClr val="F8FAFC"/>
+                </a:solidFill>
+              </a:defRPr>
+            </a:pPr>
+            <a:r>
+              <a:t>• Grade A APR: 22.5% (Lowest interest rate, highest credit limit).</a:t>
+            </a:r>
+          </a:p>
+          <a:p>
+            <a:pPr>
+              <a:spcBef>
+                <a:spcPts val="500"/>
+              </a:spcBef>
+              <a:defRPr sz="1150">
+                <a:solidFill>
+                  <a:srgbClr val="F8FAFC"/>
+                </a:solidFill>
+              </a:defRPr>
+            </a:pPr>
+            <a:r>
+              <a:t>• Grade D APR: 34.5% (Compensates for elevated risk).</a:t>
+            </a:r>
+          </a:p>
+          <a:p>
+            <a:pPr>
+              <a:spcBef>
+                <a:spcPts val="500"/>
+              </a:spcBef>
+              <a:defRPr sz="1150">
+                <a:solidFill>
+                  <a:srgbClr val="F8FAFC"/>
+                </a:solidFill>
+              </a:defRPr>
+            </a:pPr>
+            <a:r>
+              <a:t>• Double-Entry Accounting: Auto-disburses to Ledger upon acceptance.</a:t>
+            </a:r>
+          </a:p>
+        </p:txBody>
+      </p:sp>
     </p:spTree>
   </p:cSld>
   <p:clrMapOvr>
@@ -3930,7 +4063,7 @@
               </a:defRPr>
             </a:pPr>
             <a:r>
-              <a:t>Enterprise Deployment: Online &amp; Offline Parity</a:t>
+              <a:t>Explainable AI &amp; Adverse Action Codes (TreeSHAP)</a:t>
             </a:r>
           </a:p>
           <a:p>
@@ -3945,7 +4078,7 @@
               </a:defRPr>
             </a:pPr>
             <a:r>
-              <a:t>Zero Cloud Lock-In | Sub-15ms Real-Time Serving | Air-Gapped Batch Processing</a:t>
+              <a:t>Local Shapley Value Feature Attribution &amp; Regulatory Disclosures</a:t>
             </a:r>
           </a:p>
         </p:txBody>
@@ -3959,162 +4092,7 @@
         <p:spPr>
           <a:xfrm>
             <a:off x="731520" y="1645920"/>
-            <a:ext cx="5120640" cy="4754880"/>
-          </a:xfrm>
-          <a:prstGeom prst="roundRect">
-            <a:avLst/>
-          </a:prstGeom>
-          <a:solidFill>
-            <a:srgbClr val="131E36"/>
-          </a:solidFill>
-          <a:ln w="19050">
-            <a:solidFill>
-              <a:srgbClr val="34D399"/>
-            </a:solidFill>
-          </a:ln>
-        </p:spPr>
-        <p:style>
-          <a:lnRef idx="1">
-            <a:schemeClr val="accent1"/>
-          </a:lnRef>
-          <a:fillRef idx="3">
-            <a:schemeClr val="accent1"/>
-          </a:fillRef>
-          <a:effectRef idx="2">
-            <a:schemeClr val="accent1"/>
-          </a:effectRef>
-          <a:fontRef idx="minor">
-            <a:schemeClr val="lt1"/>
-          </a:fontRef>
-        </p:style>
-        <p:txBody>
-          <a:bodyPr rtlCol="0" anchor="ctr"/>
-          <a:lstStyle/>
-          <a:p>
-            <a:pPr algn="ctr"/>
-          </a:p>
-        </p:txBody>
-      </p:sp>
-      <p:sp>
-        <p:nvSpPr>
-          <p:cNvPr id="5" name="TextBox 4"/>
-          <p:cNvSpPr txBox="1"/>
-          <p:nvPr/>
-        </p:nvSpPr>
-        <p:spPr>
-          <a:xfrm>
-            <a:off x="914400" y="1828800"/>
-            <a:ext cx="4754879" cy="4389120"/>
-          </a:xfrm>
-          <a:prstGeom prst="rect">
-            <a:avLst/>
-          </a:prstGeom>
-          <a:noFill/>
-        </p:spPr>
-        <p:txBody>
-          <a:bodyPr wrap="square">
-            <a:spAutoFit/>
-          </a:bodyPr>
-          <a:lstStyle/>
-          <a:p>
-            <a:pPr>
-              <a:defRPr sz="1600" b="1">
-                <a:solidFill>
-                  <a:srgbClr val="FBBF24"/>
-                </a:solidFill>
-              </a:defRPr>
-            </a:pPr>
-            <a:r>
-              <a:t>Mode 1: Online Synchronous Microservice</a:t>
-            </a:r>
-          </a:p>
-          <a:p>
-            <a:pPr>
-              <a:spcBef>
-                <a:spcPts val="500"/>
-              </a:spcBef>
-              <a:defRPr sz="1150">
-                <a:solidFill>
-                  <a:srgbClr val="F8FAFC"/>
-                </a:solidFill>
-              </a:defRPr>
-            </a:pPr>
-            <a:r>
-              <a:t>• FastAPI + Uvicorn ASGI Server (Port 8000).</a:t>
-            </a:r>
-          </a:p>
-          <a:p>
-            <a:pPr>
-              <a:spcBef>
-                <a:spcPts val="500"/>
-              </a:spcBef>
-              <a:defRPr sz="1150">
-                <a:solidFill>
-                  <a:srgbClr val="F8FAFC"/>
-                </a:solidFill>
-              </a:defRPr>
-            </a:pPr>
-            <a:r>
-              <a:t>• P99 Gateway Latency: 14.7 milliseconds per customer.</a:t>
-            </a:r>
-          </a:p>
-          <a:p>
-            <a:pPr>
-              <a:spcBef>
-                <a:spcPts val="500"/>
-              </a:spcBef>
-              <a:defRPr sz="1150">
-                <a:solidFill>
-                  <a:srgbClr val="F8FAFC"/>
-                </a:solidFill>
-              </a:defRPr>
-            </a:pPr>
-            <a:r>
-              <a:t>• Interactive OpenAPI / Swagger Docs at /docs.</a:t>
-            </a:r>
-          </a:p>
-          <a:p>
-            <a:pPr>
-              <a:spcBef>
-                <a:spcPts val="500"/>
-              </a:spcBef>
-              <a:defRPr sz="1150">
-                <a:solidFill>
-                  <a:srgbClr val="F8FAFC"/>
-                </a:solidFill>
-              </a:defRPr>
-            </a:pPr>
-            <a:r>
-              <a:t>• Endpoints: /score/customer/, /predict/customer/, /loans/disburse, /portfolio/ifrs9.</a:t>
-            </a:r>
-          </a:p>
-          <a:p>
-            <a:pPr>
-              <a:spcBef>
-                <a:spcPts val="500"/>
-              </a:spcBef>
-              <a:defRPr sz="1150">
-                <a:solidFill>
-                  <a:srgbClr val="F8FAFC"/>
-                </a:solidFill>
-              </a:defRPr>
-            </a:pPr>
-            <a:r>
-              <a:t>• Connected to Streamlit Executive Portal (Port 8501).</a:t>
-            </a:r>
-          </a:p>
-        </p:txBody>
-      </p:sp>
-      <p:sp>
-        <p:nvSpPr>
-          <p:cNvPr id="6" name="Rounded Rectangle 5"/>
-          <p:cNvSpPr/>
-          <p:nvPr/>
-        </p:nvSpPr>
-        <p:spPr>
-          <a:xfrm>
-            <a:off x="6217920" y="1645920"/>
-            <a:ext cx="5120640" cy="4754880"/>
+            <a:ext cx="4754880" cy="4754880"/>
           </a:xfrm>
           <a:prstGeom prst="roundRect">
             <a:avLst/>
@@ -4152,14 +4130,14 @@
       </p:sp>
       <p:sp>
         <p:nvSpPr>
-          <p:cNvPr id="7" name="TextBox 6"/>
+          <p:cNvPr id="5" name="TextBox 4"/>
           <p:cNvSpPr txBox="1"/>
           <p:nvPr/>
         </p:nvSpPr>
         <p:spPr>
           <a:xfrm>
-            <a:off x="6400800" y="1828800"/>
-            <a:ext cx="4754879" cy="4389120"/>
+            <a:off x="914400" y="1828800"/>
+            <a:ext cx="4389120" cy="4389120"/>
           </a:xfrm>
           <a:prstGeom prst="rect">
             <a:avLst/>
@@ -4180,86 +4158,110 @@
               </a:defRPr>
             </a:pPr>
             <a:r>
-              <a:t>Mode 2: Offline Air-Gapped Batch Engine</a:t>
-            </a:r>
-          </a:p>
-          <a:p>
-            <a:pPr>
-              <a:spcBef>
-                <a:spcPts val="500"/>
-              </a:spcBef>
-              <a:defRPr sz="1150">
-                <a:solidFill>
-                  <a:srgbClr val="F8FAFC"/>
-                </a:solidFill>
-              </a:defRPr>
-            </a:pPr>
-            <a:r>
-              <a:t>• Throughput: &gt;5,000 customers per second via vectorized multi-threading.</a:t>
-            </a:r>
-          </a:p>
-          <a:p>
-            <a:pPr>
-              <a:spcBef>
-                <a:spcPts val="500"/>
-              </a:spcBef>
-              <a:defRPr sz="1150">
-                <a:solidFill>
-                  <a:srgbClr val="F8FAFC"/>
-                </a:solidFill>
-              </a:defRPr>
-            </a:pPr>
-            <a:r>
-              <a:t>• Zero Internet Requirement: Runs 100% offline inside secure bank vaults.</a:t>
-            </a:r>
-          </a:p>
-          <a:p>
-            <a:pPr>
-              <a:spcBef>
-                <a:spcPts val="500"/>
-              </a:spcBef>
-              <a:defRPr sz="1150">
-                <a:solidFill>
-                  <a:srgbClr val="F8FAFC"/>
-                </a:solidFill>
-              </a:defRPr>
-            </a:pPr>
-            <a:r>
-              <a:t>• 1-Click Desktop Launcher: run_offline_demo.bat.</a:t>
-            </a:r>
-          </a:p>
-          <a:p>
-            <a:pPr>
-              <a:spcBef>
-                <a:spcPts val="500"/>
-              </a:spcBef>
-              <a:defRPr sz="1150">
-                <a:solidFill>
-                  <a:srgbClr val="F8FAFC"/>
-                </a:solidFill>
-              </a:defRPr>
-            </a:pPr>
-            <a:r>
-              <a:t>• Overnight Batch Script: python -m scoring.run_batch_scoring.</a:t>
-            </a:r>
-          </a:p>
-          <a:p>
-            <a:pPr>
-              <a:spcBef>
-                <a:spcPts val="500"/>
-              </a:spcBef>
-              <a:defRPr sz="1150">
-                <a:solidFill>
-                  <a:srgbClr val="F8FAFC"/>
-                </a:solidFill>
-              </a:defRPr>
-            </a:pPr>
-            <a:r>
-              <a:t>• Containerized: Docker &amp; docker-compose ready for Kubernetes.</a:t>
-            </a:r>
-          </a:p>
-        </p:txBody>
-      </p:sp>
+              <a:t>Algorithmic Transparency</a:t>
+            </a:r>
+          </a:p>
+          <a:p>
+            <a:pPr>
+              <a:spcBef>
+                <a:spcPts val="500"/>
+              </a:spcBef>
+              <a:defRPr sz="1150">
+                <a:solidFill>
+                  <a:srgbClr val="F8FAFC"/>
+                </a:solidFill>
+              </a:defRPr>
+            </a:pPr>
+            <a:r>
+              <a:t>• Game-Theoretic Attribution: Exact Shapley decomposition in &lt; 5ms.</a:t>
+            </a:r>
+          </a:p>
+          <a:p>
+            <a:pPr>
+              <a:spcBef>
+                <a:spcPts val="500"/>
+              </a:spcBef>
+              <a:defRPr sz="1150">
+                <a:solidFill>
+                  <a:srgbClr val="F8FAFC"/>
+                </a:solidFill>
+              </a:defRPr>
+            </a:pPr>
+            <a:r>
+              <a:t>• Regulatory Audit Trail: Every decision logs model version, feature vector, and SHAP vector.</a:t>
+            </a:r>
+          </a:p>
+          <a:p>
+            <a:pPr>
+              <a:spcBef>
+                <a:spcPts val="500"/>
+              </a:spcBef>
+              <a:defRPr sz="1150">
+                <a:solidFill>
+                  <a:srgbClr val="F8FAFC"/>
+                </a:solidFill>
+              </a:defRPr>
+            </a:pPr>
+            <a:r>
+              <a:t>• Positive Trust Enhancers: Highlights key driver strengths that qualified the borrower.</a:t>
+            </a:r>
+          </a:p>
+          <a:p>
+            <a:pPr>
+              <a:spcBef>
+                <a:spcPts val="500"/>
+              </a:spcBef>
+              <a:defRPr sz="1150">
+                <a:solidFill>
+                  <a:srgbClr val="F8FAFC"/>
+                </a:solidFill>
+              </a:defRPr>
+            </a:pPr>
+            <a:r>
+              <a:t>• Adverse Action Disclosures: Clear, actionable decline justifications for applicants.</a:t>
+            </a:r>
+          </a:p>
+          <a:p>
+            <a:pPr>
+              <a:spcBef>
+                <a:spcPts val="500"/>
+              </a:spcBef>
+              <a:defRPr sz="1150">
+                <a:solidFill>
+                  <a:srgbClr val="F8FAFC"/>
+                </a:solidFill>
+              </a:defRPr>
+            </a:pPr>
+            <a:r>
+              <a:t>• Eliminates Disparate Impact: Protected attributes strictly excluded.</a:t>
+            </a:r>
+          </a:p>
+        </p:txBody>
+      </p:sp>
+      <p:pic>
+        <p:nvPicPr>
+          <p:cNvPr id="6" name="Picture 5" descr="chart_shap_waterfall.png"/>
+          <p:cNvPicPr>
+            <a:picLocks noChangeAspect="1"/>
+          </p:cNvPicPr>
+          <p:nvPr/>
+        </p:nvPicPr>
+        <p:blipFill>
+          <a:blip r:embed="rId2"/>
+          <a:stretch>
+            <a:fillRect/>
+          </a:stretch>
+        </p:blipFill>
+        <p:spPr>
+          <a:xfrm>
+            <a:off x="5760720" y="1645920"/>
+            <a:ext cx="5669280" cy="4754880"/>
+          </a:xfrm>
+          <a:prstGeom prst="rect">
+            <a:avLst/>
+          </a:prstGeom>
+        </p:spPr>
+      </p:pic>
     </p:spTree>
   </p:cSld>
   <p:clrMapOvr>
@@ -4351,7 +4353,7 @@
               </a:defRPr>
             </a:pPr>
             <a:r>
-              <a:t>Production Readiness &amp; QA Stress Test Results</a:t>
+              <a:t>IFRS 9 ECL Provisioning &amp; Core Accounting Ledger</a:t>
             </a:r>
           </a:p>
           <a:p>
@@ -4366,7 +4368,7 @@
               </a:defRPr>
             </a:pPr>
             <a:r>
-              <a:t>Automated Verification Suite (10/10 Passed - 100.0% Success Rate)</a:t>
+              <a:t>Automated Regulatory Impairment Staging and Double-Entry Ledgering</a:t>
             </a:r>
           </a:p>
         </p:txBody>
@@ -4380,7 +4382,7 @@
         <p:spPr>
           <a:xfrm>
             <a:off x="731520" y="1645920"/>
-            <a:ext cx="10607040" cy="4754880"/>
+            <a:ext cx="4754880" cy="4754880"/>
           </a:xfrm>
           <a:prstGeom prst="roundRect">
             <a:avLst/>
@@ -4390,7 +4392,7 @@
           </a:solidFill>
           <a:ln w="19050">
             <a:solidFill>
-              <a:srgbClr val="34D399"/>
+              <a:srgbClr val="FBBF24"/>
             </a:solidFill>
           </a:ln>
         </p:spPr>
@@ -4425,7 +4427,7 @@
         <p:spPr>
           <a:xfrm>
             <a:off x="914400" y="1828800"/>
-            <a:ext cx="10241280" cy="4389120"/>
+            <a:ext cx="4389120" cy="4389120"/>
           </a:xfrm>
           <a:prstGeom prst="rect">
             <a:avLst/>
@@ -4446,161 +4448,110 @@
               </a:defRPr>
             </a:pPr>
             <a:r>
-              <a:t>Enterprise Test Suite Results (scripts/qa_stress_test_suite.py)</a:t>
-            </a:r>
-          </a:p>
-          <a:p>
-            <a:pPr>
-              <a:spcBef>
-                <a:spcPts val="500"/>
-              </a:spcBef>
-              <a:defRPr sz="1150">
-                <a:solidFill>
-                  <a:srgbClr val="F8FAFC"/>
-                </a:solidFill>
-              </a:defRPr>
-            </a:pPr>
-            <a:r>
-              <a:t>• TEST 01 [PASS]: Hard Stop Knockout Filters (Rooted devices &amp; emulator blocks trigger immediate 0 limit).</a:t>
-            </a:r>
-          </a:p>
-          <a:p>
-            <a:pPr>
-              <a:spcBef>
-                <a:spcPts val="500"/>
-              </a:spcBef>
-              <a:defRPr sz="1150">
-                <a:solidFill>
-                  <a:srgbClr val="F8FAFC"/>
-                </a:solidFill>
-              </a:defRPr>
-            </a:pPr>
-            <a:r>
-              <a:t>• TEST 02 [PASS]: Null &amp; Missing Value Resilience (100% missing data gracefully handled without NaN crashes).</a:t>
-            </a:r>
-          </a:p>
-          <a:p>
-            <a:pPr>
-              <a:spcBef>
-                <a:spcPts val="500"/>
-              </a:spcBef>
-              <a:defRPr sz="1150">
-                <a:solidFill>
-                  <a:srgbClr val="F8FAFC"/>
-                </a:solidFill>
-              </a:defRPr>
-            </a:pPr>
-            <a:r>
-              <a:t>• TEST 03 [PASS]: Extreme Outlier Robustness (PKR 100M extreme salaries correctly clamped by quantile P10/P50).</a:t>
-            </a:r>
-          </a:p>
-          <a:p>
-            <a:pPr>
-              <a:spcBef>
-                <a:spcPts val="500"/>
-              </a:spcBef>
-              <a:defRPr sz="1150">
-                <a:solidFill>
-                  <a:srgbClr val="F8FAFC"/>
-                </a:solidFill>
-              </a:defRPr>
-            </a:pPr>
-            <a:r>
-              <a:t>• TEST 04 [PASS]: 4-Bound Constraint Invariants (Verified min(B1, B2, B3, B4) holds across all profiles).</a:t>
-            </a:r>
-          </a:p>
-          <a:p>
-            <a:pPr>
-              <a:spcBef>
-                <a:spcPts val="500"/>
-              </a:spcBef>
-              <a:defRPr sz="1150">
-                <a:solidFill>
-                  <a:srgbClr val="F8FAFC"/>
-                </a:solidFill>
-              </a:defRPr>
-            </a:pPr>
-            <a:r>
-              <a:t>• TEST 05 [PASS]: SBP 36% Usury Cap Enforcement (Zero loans exceed statutory 36.0% interest rate).</a:t>
-            </a:r>
-          </a:p>
-          <a:p>
-            <a:pPr>
-              <a:spcBef>
-                <a:spcPts val="500"/>
-              </a:spcBef>
-              <a:defRPr sz="1150">
-                <a:solidFill>
-                  <a:srgbClr val="F8FAFC"/>
-                </a:solidFill>
-              </a:defRPr>
-            </a:pPr>
-            <a:r>
-              <a:t>• TEST 06 [PASS]: IFRS 9 Staging Mathematical Integrity (Stage 1 + Stage 2 + Stage 3 = 100% Portfolio EAD).</a:t>
-            </a:r>
-          </a:p>
-          <a:p>
-            <a:pPr>
-              <a:spcBef>
-                <a:spcPts val="500"/>
-              </a:spcBef>
-              <a:defRPr sz="1150">
-                <a:solidFill>
-                  <a:srgbClr val="F8FAFC"/>
-                </a:solidFill>
-              </a:defRPr>
-            </a:pPr>
-            <a:r>
-              <a:t>• TEST 07 [PASS]: TreeSHAP Explainability Completeness (Sum of local SHAP attributions matches predicted margin).</a:t>
-            </a:r>
-          </a:p>
-          <a:p>
-            <a:pPr>
-              <a:spcBef>
-                <a:spcPts val="500"/>
-              </a:spcBef>
-              <a:defRPr sz="1150">
-                <a:solidFill>
-                  <a:srgbClr val="F8FAFC"/>
-                </a:solidFill>
-              </a:defRPr>
-            </a:pPr>
-            <a:r>
-              <a:t>• TEST 08 [PASS]: Double-Entry Ledger Consistency (Debits strictly equal credits on every disbursement).</a:t>
-            </a:r>
-          </a:p>
-          <a:p>
-            <a:pPr>
-              <a:spcBef>
-                <a:spcPts val="500"/>
-              </a:spcBef>
-              <a:defRPr sz="1150">
-                <a:solidFill>
-                  <a:srgbClr val="F8FAFC"/>
-                </a:solidFill>
-              </a:defRPr>
-            </a:pPr>
-            <a:r>
-              <a:t>• TEST 09 [PASS]: Gateway Sub-100ms Latency SLA (Average latency 14.7ms vs 100ms enterprise budget).</a:t>
-            </a:r>
-          </a:p>
-          <a:p>
-            <a:pPr>
-              <a:spcBef>
-                <a:spcPts val="500"/>
-              </a:spcBef>
-              <a:defRPr sz="1150">
-                <a:solidFill>
-                  <a:srgbClr val="F8FAFC"/>
-                </a:solidFill>
-              </a:defRPr>
-            </a:pPr>
-            <a:r>
-              <a:t>• TEST 10 [PASS]: Streamlit Executive Portal Health (HTTP 200 OK across all underwriter screens).</a:t>
-            </a:r>
-          </a:p>
-        </p:txBody>
-      </p:sp>
+              <a:t>Stage Transitions &amp; Provisioning</a:t>
+            </a:r>
+          </a:p>
+          <a:p>
+            <a:pPr>
+              <a:spcBef>
+                <a:spcPts val="500"/>
+              </a:spcBef>
+              <a:defRPr sz="1150">
+                <a:solidFill>
+                  <a:srgbClr val="F8FAFC"/>
+                </a:solidFill>
+              </a:defRPr>
+            </a:pPr>
+            <a:r>
+              <a:t>• Formula: ECL = PD * LGD * EAD * Discount Factor.</a:t>
+            </a:r>
+          </a:p>
+          <a:p>
+            <a:pPr>
+              <a:spcBef>
+                <a:spcPts val="500"/>
+              </a:spcBef>
+              <a:defRPr sz="1150">
+                <a:solidFill>
+                  <a:srgbClr val="F8FAFC"/>
+                </a:solidFill>
+              </a:defRPr>
+            </a:pPr>
+            <a:r>
+              <a:t>• Stage 1 (Normal): 12-Month ECL for loans &lt;30 DPD (ECL = PKR 18.4M on PKR 1.84B EAD).</a:t>
+            </a:r>
+          </a:p>
+          <a:p>
+            <a:pPr>
+              <a:spcBef>
+                <a:spcPts val="500"/>
+              </a:spcBef>
+              <a:defRPr sz="1150">
+                <a:solidFill>
+                  <a:srgbClr val="F8FAFC"/>
+                </a:solidFill>
+              </a:defRPr>
+            </a:pPr>
+            <a:r>
+              <a:t>• Stage 2 (SICR): Lifetime ECL for loans 30-89 DPD (ECL = PKR 44.3M on PKR 295M EAD).</a:t>
+            </a:r>
+          </a:p>
+          <a:p>
+            <a:pPr>
+              <a:spcBef>
+                <a:spcPts val="500"/>
+              </a:spcBef>
+              <a:defRPr sz="1150">
+                <a:solidFill>
+                  <a:srgbClr val="F8FAFC"/>
+                </a:solidFill>
+              </a:defRPr>
+            </a:pPr>
+            <a:r>
+              <a:t>• Stage 3 (Default): Specific Impairment &gt;=90 DPD (ECL = PKR 59.0M on PKR 84M EAD).</a:t>
+            </a:r>
+          </a:p>
+          <a:p>
+            <a:pPr>
+              <a:spcBef>
+                <a:spcPts val="500"/>
+              </a:spcBef>
+              <a:defRPr sz="1150">
+                <a:solidFill>
+                  <a:srgbClr val="F8FAFC"/>
+                </a:solidFill>
+              </a:defRPr>
+            </a:pPr>
+            <a:r>
+              <a:t>• Double-Entry Accounting: Ledger writes append-only records to disbursed_loans.parquet.</a:t>
+            </a:r>
+          </a:p>
+        </p:txBody>
+      </p:sp>
+      <p:pic>
+        <p:nvPicPr>
+          <p:cNvPr id="6" name="Picture 5" descr="chart_ifrs9_staging.png"/>
+          <p:cNvPicPr>
+            <a:picLocks noChangeAspect="1"/>
+          </p:cNvPicPr>
+          <p:nvPr/>
+        </p:nvPicPr>
+        <p:blipFill>
+          <a:blip r:embed="rId2"/>
+          <a:stretch>
+            <a:fillRect/>
+          </a:stretch>
+        </p:blipFill>
+        <p:spPr>
+          <a:xfrm>
+            <a:off x="5760720" y="1645920"/>
+            <a:ext cx="5669280" cy="4754880"/>
+          </a:xfrm>
+          <a:prstGeom prst="rect">
+            <a:avLst/>
+          </a:prstGeom>
+        </p:spPr>
+      </p:pic>
     </p:spTree>
   </p:cSld>
   <p:clrMapOvr>
@@ -4692,6 +4643,768 @@
               </a:defRPr>
             </a:pPr>
             <a:r>
+              <a:t>Enterprise Deployment: Online &amp; Offline Parity</a:t>
+            </a:r>
+          </a:p>
+          <a:p>
+            <a:pPr>
+              <a:spcBef>
+                <a:spcPts val="400"/>
+              </a:spcBef>
+              <a:defRPr sz="1300">
+                <a:solidFill>
+                  <a:srgbClr val="94A3B8"/>
+                </a:solidFill>
+              </a:defRPr>
+            </a:pPr>
+            <a:r>
+              <a:t>Zero Cloud Lock-In | Sub-15ms Real-Time Serving | Air-Gapped Batch Processing</a:t>
+            </a:r>
+          </a:p>
+        </p:txBody>
+      </p:sp>
+      <p:sp>
+        <p:nvSpPr>
+          <p:cNvPr id="4" name="Rounded Rectangle 3"/>
+          <p:cNvSpPr/>
+          <p:nvPr/>
+        </p:nvSpPr>
+        <p:spPr>
+          <a:xfrm>
+            <a:off x="731520" y="1645920"/>
+            <a:ext cx="5120640" cy="4754880"/>
+          </a:xfrm>
+          <a:prstGeom prst="roundRect">
+            <a:avLst/>
+          </a:prstGeom>
+          <a:solidFill>
+            <a:srgbClr val="131E36"/>
+          </a:solidFill>
+          <a:ln w="19050">
+            <a:solidFill>
+              <a:srgbClr val="34D399"/>
+            </a:solidFill>
+          </a:ln>
+        </p:spPr>
+        <p:style>
+          <a:lnRef idx="1">
+            <a:schemeClr val="accent1"/>
+          </a:lnRef>
+          <a:fillRef idx="3">
+            <a:schemeClr val="accent1"/>
+          </a:fillRef>
+          <a:effectRef idx="2">
+            <a:schemeClr val="accent1"/>
+          </a:effectRef>
+          <a:fontRef idx="minor">
+            <a:schemeClr val="lt1"/>
+          </a:fontRef>
+        </p:style>
+        <p:txBody>
+          <a:bodyPr rtlCol="0" anchor="ctr"/>
+          <a:lstStyle/>
+          <a:p>
+            <a:pPr algn="ctr"/>
+          </a:p>
+        </p:txBody>
+      </p:sp>
+      <p:sp>
+        <p:nvSpPr>
+          <p:cNvPr id="5" name="TextBox 4"/>
+          <p:cNvSpPr txBox="1"/>
+          <p:nvPr/>
+        </p:nvSpPr>
+        <p:spPr>
+          <a:xfrm>
+            <a:off x="914400" y="1828800"/>
+            <a:ext cx="4754879" cy="4389120"/>
+          </a:xfrm>
+          <a:prstGeom prst="rect">
+            <a:avLst/>
+          </a:prstGeom>
+          <a:noFill/>
+        </p:spPr>
+        <p:txBody>
+          <a:bodyPr wrap="square">
+            <a:spAutoFit/>
+          </a:bodyPr>
+          <a:lstStyle/>
+          <a:p>
+            <a:pPr>
+              <a:defRPr sz="1600" b="1">
+                <a:solidFill>
+                  <a:srgbClr val="FBBF24"/>
+                </a:solidFill>
+              </a:defRPr>
+            </a:pPr>
+            <a:r>
+              <a:t>Mode 1: Online Synchronous Microservice</a:t>
+            </a:r>
+          </a:p>
+          <a:p>
+            <a:pPr>
+              <a:spcBef>
+                <a:spcPts val="500"/>
+              </a:spcBef>
+              <a:defRPr sz="1150">
+                <a:solidFill>
+                  <a:srgbClr val="F8FAFC"/>
+                </a:solidFill>
+              </a:defRPr>
+            </a:pPr>
+            <a:r>
+              <a:t>• FastAPI + Uvicorn ASGI Server (Port 8000).</a:t>
+            </a:r>
+          </a:p>
+          <a:p>
+            <a:pPr>
+              <a:spcBef>
+                <a:spcPts val="500"/>
+              </a:spcBef>
+              <a:defRPr sz="1150">
+                <a:solidFill>
+                  <a:srgbClr val="F8FAFC"/>
+                </a:solidFill>
+              </a:defRPr>
+            </a:pPr>
+            <a:r>
+              <a:t>• P99 Gateway Latency: 14.7 milliseconds per customer.</a:t>
+            </a:r>
+          </a:p>
+          <a:p>
+            <a:pPr>
+              <a:spcBef>
+                <a:spcPts val="500"/>
+              </a:spcBef>
+              <a:defRPr sz="1150">
+                <a:solidFill>
+                  <a:srgbClr val="F8FAFC"/>
+                </a:solidFill>
+              </a:defRPr>
+            </a:pPr>
+            <a:r>
+              <a:t>• Interactive OpenAPI / Swagger Docs at /docs.</a:t>
+            </a:r>
+          </a:p>
+          <a:p>
+            <a:pPr>
+              <a:spcBef>
+                <a:spcPts val="500"/>
+              </a:spcBef>
+              <a:defRPr sz="1150">
+                <a:solidFill>
+                  <a:srgbClr val="F8FAFC"/>
+                </a:solidFill>
+              </a:defRPr>
+            </a:pPr>
+            <a:r>
+              <a:t>• Endpoints: /score/customer/, /predict/customer/, /loans/disburse, /portfolio/ifrs9.</a:t>
+            </a:r>
+          </a:p>
+          <a:p>
+            <a:pPr>
+              <a:spcBef>
+                <a:spcPts val="500"/>
+              </a:spcBef>
+              <a:defRPr sz="1150">
+                <a:solidFill>
+                  <a:srgbClr val="F8FAFC"/>
+                </a:solidFill>
+              </a:defRPr>
+            </a:pPr>
+            <a:r>
+              <a:t>• Connected to Streamlit Executive Portal (Port 8501).</a:t>
+            </a:r>
+          </a:p>
+        </p:txBody>
+      </p:sp>
+      <p:sp>
+        <p:nvSpPr>
+          <p:cNvPr id="6" name="Rounded Rectangle 5"/>
+          <p:cNvSpPr/>
+          <p:nvPr/>
+        </p:nvSpPr>
+        <p:spPr>
+          <a:xfrm>
+            <a:off x="6217920" y="1645920"/>
+            <a:ext cx="5120640" cy="4754880"/>
+          </a:xfrm>
+          <a:prstGeom prst="roundRect">
+            <a:avLst/>
+          </a:prstGeom>
+          <a:solidFill>
+            <a:srgbClr val="131E36"/>
+          </a:solidFill>
+          <a:ln w="19050">
+            <a:solidFill>
+              <a:srgbClr val="38BDF8"/>
+            </a:solidFill>
+          </a:ln>
+        </p:spPr>
+        <p:style>
+          <a:lnRef idx="1">
+            <a:schemeClr val="accent1"/>
+          </a:lnRef>
+          <a:fillRef idx="3">
+            <a:schemeClr val="accent1"/>
+          </a:fillRef>
+          <a:effectRef idx="2">
+            <a:schemeClr val="accent1"/>
+          </a:effectRef>
+          <a:fontRef idx="minor">
+            <a:schemeClr val="lt1"/>
+          </a:fontRef>
+        </p:style>
+        <p:txBody>
+          <a:bodyPr rtlCol="0" anchor="ctr"/>
+          <a:lstStyle/>
+          <a:p>
+            <a:pPr algn="ctr"/>
+          </a:p>
+        </p:txBody>
+      </p:sp>
+      <p:sp>
+        <p:nvSpPr>
+          <p:cNvPr id="7" name="TextBox 6"/>
+          <p:cNvSpPr txBox="1"/>
+          <p:nvPr/>
+        </p:nvSpPr>
+        <p:spPr>
+          <a:xfrm>
+            <a:off x="6400800" y="1828800"/>
+            <a:ext cx="4754879" cy="4389120"/>
+          </a:xfrm>
+          <a:prstGeom prst="rect">
+            <a:avLst/>
+          </a:prstGeom>
+          <a:noFill/>
+        </p:spPr>
+        <p:txBody>
+          <a:bodyPr wrap="square">
+            <a:spAutoFit/>
+          </a:bodyPr>
+          <a:lstStyle/>
+          <a:p>
+            <a:pPr>
+              <a:defRPr sz="1600" b="1">
+                <a:solidFill>
+                  <a:srgbClr val="FBBF24"/>
+                </a:solidFill>
+              </a:defRPr>
+            </a:pPr>
+            <a:r>
+              <a:t>Mode 2: Offline Air-Gapped Batch Engine</a:t>
+            </a:r>
+          </a:p>
+          <a:p>
+            <a:pPr>
+              <a:spcBef>
+                <a:spcPts val="500"/>
+              </a:spcBef>
+              <a:defRPr sz="1150">
+                <a:solidFill>
+                  <a:srgbClr val="F8FAFC"/>
+                </a:solidFill>
+              </a:defRPr>
+            </a:pPr>
+            <a:r>
+              <a:t>• Throughput: &gt;5,000 customers per second via vectorized multi-threading.</a:t>
+            </a:r>
+          </a:p>
+          <a:p>
+            <a:pPr>
+              <a:spcBef>
+                <a:spcPts val="500"/>
+              </a:spcBef>
+              <a:defRPr sz="1150">
+                <a:solidFill>
+                  <a:srgbClr val="F8FAFC"/>
+                </a:solidFill>
+              </a:defRPr>
+            </a:pPr>
+            <a:r>
+              <a:t>• Zero Internet Requirement: Runs 100% offline inside secure bank vaults.</a:t>
+            </a:r>
+          </a:p>
+          <a:p>
+            <a:pPr>
+              <a:spcBef>
+                <a:spcPts val="500"/>
+              </a:spcBef>
+              <a:defRPr sz="1150">
+                <a:solidFill>
+                  <a:srgbClr val="F8FAFC"/>
+                </a:solidFill>
+              </a:defRPr>
+            </a:pPr>
+            <a:r>
+              <a:t>• 1-Click Desktop Launcher: run_offline_demo.bat.</a:t>
+            </a:r>
+          </a:p>
+          <a:p>
+            <a:pPr>
+              <a:spcBef>
+                <a:spcPts val="500"/>
+              </a:spcBef>
+              <a:defRPr sz="1150">
+                <a:solidFill>
+                  <a:srgbClr val="F8FAFC"/>
+                </a:solidFill>
+              </a:defRPr>
+            </a:pPr>
+            <a:r>
+              <a:t>• Overnight Batch Script: python -m scoring.run_batch_scoring.</a:t>
+            </a:r>
+          </a:p>
+          <a:p>
+            <a:pPr>
+              <a:spcBef>
+                <a:spcPts val="500"/>
+              </a:spcBef>
+              <a:defRPr sz="1150">
+                <a:solidFill>
+                  <a:srgbClr val="F8FAFC"/>
+                </a:solidFill>
+              </a:defRPr>
+            </a:pPr>
+            <a:r>
+              <a:t>• Containerized: Docker &amp; docker-compose ready for Kubernetes.</a:t>
+            </a:r>
+          </a:p>
+        </p:txBody>
+      </p:sp>
+    </p:spTree>
+  </p:cSld>
+  <p:clrMapOvr>
+    <a:masterClrMapping/>
+  </p:clrMapOvr>
+</p:sld>
+</file>
+
+<file path=ppt/slides/slide15.xml><?xml version="1.0" encoding="utf-8"?>
+<p:sld xmlns:a="http://schemas.openxmlformats.org/drawingml/2006/main" xmlns:p="http://schemas.openxmlformats.org/presentationml/2006/main" xmlns:r="http://schemas.openxmlformats.org/officeDocument/2006/relationships">
+  <p:cSld>
+    <p:spTree>
+      <p:nvGrpSpPr>
+        <p:cNvPr id="1" name=""/>
+        <p:cNvGrpSpPr/>
+        <p:nvPr/>
+      </p:nvGrpSpPr>
+      <p:grpSpPr/>
+      <p:sp>
+        <p:nvSpPr>
+          <p:cNvPr id="2" name="Rectangle 1"/>
+          <p:cNvSpPr/>
+          <p:nvPr/>
+        </p:nvSpPr>
+        <p:spPr>
+          <a:xfrm>
+            <a:off x="0" y="0"/>
+            <a:ext cx="12191695" cy="6858000"/>
+          </a:xfrm>
+          <a:prstGeom prst="rect">
+            <a:avLst/>
+          </a:prstGeom>
+          <a:solidFill>
+            <a:srgbClr val="0B1120"/>
+          </a:solidFill>
+          <a:ln>
+            <a:noFill/>
+          </a:ln>
+        </p:spPr>
+        <p:style>
+          <a:lnRef idx="1">
+            <a:schemeClr val="accent1"/>
+          </a:lnRef>
+          <a:fillRef idx="3">
+            <a:schemeClr val="accent1"/>
+          </a:fillRef>
+          <a:effectRef idx="2">
+            <a:schemeClr val="accent1"/>
+          </a:effectRef>
+          <a:fontRef idx="minor">
+            <a:schemeClr val="lt1"/>
+          </a:fontRef>
+        </p:style>
+        <p:txBody>
+          <a:bodyPr rtlCol="0" anchor="ctr"/>
+          <a:lstStyle/>
+          <a:p>
+            <a:pPr algn="ctr"/>
+          </a:p>
+        </p:txBody>
+      </p:sp>
+      <p:sp>
+        <p:nvSpPr>
+          <p:cNvPr id="3" name="TextBox 2"/>
+          <p:cNvSpPr txBox="1"/>
+          <p:nvPr/>
+        </p:nvSpPr>
+        <p:spPr>
+          <a:xfrm>
+            <a:off x="731520" y="365760"/>
+            <a:ext cx="10698480" cy="1005840"/>
+          </a:xfrm>
+          <a:prstGeom prst="rect">
+            <a:avLst/>
+          </a:prstGeom>
+          <a:noFill/>
+        </p:spPr>
+        <p:txBody>
+          <a:bodyPr wrap="square">
+            <a:spAutoFit/>
+          </a:bodyPr>
+          <a:lstStyle/>
+          <a:p>
+            <a:pPr>
+              <a:defRPr sz="2600" b="1">
+                <a:solidFill>
+                  <a:srgbClr val="38BDF8"/>
+                </a:solidFill>
+              </a:defRPr>
+            </a:pPr>
+            <a:r>
+              <a:t>Production Readiness &amp; QA Stress Test Results</a:t>
+            </a:r>
+          </a:p>
+          <a:p>
+            <a:pPr>
+              <a:spcBef>
+                <a:spcPts val="400"/>
+              </a:spcBef>
+              <a:defRPr sz="1300">
+                <a:solidFill>
+                  <a:srgbClr val="94A3B8"/>
+                </a:solidFill>
+              </a:defRPr>
+            </a:pPr>
+            <a:r>
+              <a:t>Automated Verification Suite (10/10 Passed - 100.0% Success Rate)</a:t>
+            </a:r>
+          </a:p>
+        </p:txBody>
+      </p:sp>
+      <p:sp>
+        <p:nvSpPr>
+          <p:cNvPr id="4" name="Rounded Rectangle 3"/>
+          <p:cNvSpPr/>
+          <p:nvPr/>
+        </p:nvSpPr>
+        <p:spPr>
+          <a:xfrm>
+            <a:off x="731520" y="1645920"/>
+            <a:ext cx="10607040" cy="4754880"/>
+          </a:xfrm>
+          <a:prstGeom prst="roundRect">
+            <a:avLst/>
+          </a:prstGeom>
+          <a:solidFill>
+            <a:srgbClr val="131E36"/>
+          </a:solidFill>
+          <a:ln w="19050">
+            <a:solidFill>
+              <a:srgbClr val="34D399"/>
+            </a:solidFill>
+          </a:ln>
+        </p:spPr>
+        <p:style>
+          <a:lnRef idx="1">
+            <a:schemeClr val="accent1"/>
+          </a:lnRef>
+          <a:fillRef idx="3">
+            <a:schemeClr val="accent1"/>
+          </a:fillRef>
+          <a:effectRef idx="2">
+            <a:schemeClr val="accent1"/>
+          </a:effectRef>
+          <a:fontRef idx="minor">
+            <a:schemeClr val="lt1"/>
+          </a:fontRef>
+        </p:style>
+        <p:txBody>
+          <a:bodyPr rtlCol="0" anchor="ctr"/>
+          <a:lstStyle/>
+          <a:p>
+            <a:pPr algn="ctr"/>
+          </a:p>
+        </p:txBody>
+      </p:sp>
+      <p:sp>
+        <p:nvSpPr>
+          <p:cNvPr id="5" name="TextBox 4"/>
+          <p:cNvSpPr txBox="1"/>
+          <p:nvPr/>
+        </p:nvSpPr>
+        <p:spPr>
+          <a:xfrm>
+            <a:off x="914400" y="1828800"/>
+            <a:ext cx="10241280" cy="4389120"/>
+          </a:xfrm>
+          <a:prstGeom prst="rect">
+            <a:avLst/>
+          </a:prstGeom>
+          <a:noFill/>
+        </p:spPr>
+        <p:txBody>
+          <a:bodyPr wrap="square">
+            <a:spAutoFit/>
+          </a:bodyPr>
+          <a:lstStyle/>
+          <a:p>
+            <a:pPr>
+              <a:defRPr sz="1600" b="1">
+                <a:solidFill>
+                  <a:srgbClr val="FBBF24"/>
+                </a:solidFill>
+              </a:defRPr>
+            </a:pPr>
+            <a:r>
+              <a:t>Enterprise Test Suite Results (scripts/qa_stress_test_suite.py)</a:t>
+            </a:r>
+          </a:p>
+          <a:p>
+            <a:pPr>
+              <a:spcBef>
+                <a:spcPts val="500"/>
+              </a:spcBef>
+              <a:defRPr sz="1150">
+                <a:solidFill>
+                  <a:srgbClr val="F8FAFC"/>
+                </a:solidFill>
+              </a:defRPr>
+            </a:pPr>
+            <a:r>
+              <a:t>• TEST 01 [PASS]: Hard Stop Knockout Filters (Rooted devices &amp; emulator blocks trigger immediate 0 limit).</a:t>
+            </a:r>
+          </a:p>
+          <a:p>
+            <a:pPr>
+              <a:spcBef>
+                <a:spcPts val="500"/>
+              </a:spcBef>
+              <a:defRPr sz="1150">
+                <a:solidFill>
+                  <a:srgbClr val="F8FAFC"/>
+                </a:solidFill>
+              </a:defRPr>
+            </a:pPr>
+            <a:r>
+              <a:t>• TEST 02 [PASS]: Null &amp; Missing Value Resilience (100% missing data gracefully handled without NaN crashes).</a:t>
+            </a:r>
+          </a:p>
+          <a:p>
+            <a:pPr>
+              <a:spcBef>
+                <a:spcPts val="500"/>
+              </a:spcBef>
+              <a:defRPr sz="1150">
+                <a:solidFill>
+                  <a:srgbClr val="F8FAFC"/>
+                </a:solidFill>
+              </a:defRPr>
+            </a:pPr>
+            <a:r>
+              <a:t>• TEST 03 [PASS]: Extreme Outlier Robustness (PKR 100M extreme salaries correctly clamped by quantile P10/P50).</a:t>
+            </a:r>
+          </a:p>
+          <a:p>
+            <a:pPr>
+              <a:spcBef>
+                <a:spcPts val="500"/>
+              </a:spcBef>
+              <a:defRPr sz="1150">
+                <a:solidFill>
+                  <a:srgbClr val="F8FAFC"/>
+                </a:solidFill>
+              </a:defRPr>
+            </a:pPr>
+            <a:r>
+              <a:t>• TEST 04 [PASS]: 4-Bound Constraint Invariants (Verified min(B1, B2, B3, B4) holds across all profiles).</a:t>
+            </a:r>
+          </a:p>
+          <a:p>
+            <a:pPr>
+              <a:spcBef>
+                <a:spcPts val="500"/>
+              </a:spcBef>
+              <a:defRPr sz="1150">
+                <a:solidFill>
+                  <a:srgbClr val="F8FAFC"/>
+                </a:solidFill>
+              </a:defRPr>
+            </a:pPr>
+            <a:r>
+              <a:t>• TEST 05 [PASS]: SBP 36% Usury Cap Enforcement (Zero loans exceed statutory 36.0% interest rate).</a:t>
+            </a:r>
+          </a:p>
+          <a:p>
+            <a:pPr>
+              <a:spcBef>
+                <a:spcPts val="500"/>
+              </a:spcBef>
+              <a:defRPr sz="1150">
+                <a:solidFill>
+                  <a:srgbClr val="F8FAFC"/>
+                </a:solidFill>
+              </a:defRPr>
+            </a:pPr>
+            <a:r>
+              <a:t>• TEST 06 [PASS]: IFRS 9 Staging Mathematical Integrity (Stage 1 + Stage 2 + Stage 3 = 100% Portfolio EAD).</a:t>
+            </a:r>
+          </a:p>
+          <a:p>
+            <a:pPr>
+              <a:spcBef>
+                <a:spcPts val="500"/>
+              </a:spcBef>
+              <a:defRPr sz="1150">
+                <a:solidFill>
+                  <a:srgbClr val="F8FAFC"/>
+                </a:solidFill>
+              </a:defRPr>
+            </a:pPr>
+            <a:r>
+              <a:t>• TEST 07 [PASS]: TreeSHAP Explainability Completeness (Sum of local SHAP attributions matches predicted margin).</a:t>
+            </a:r>
+          </a:p>
+          <a:p>
+            <a:pPr>
+              <a:spcBef>
+                <a:spcPts val="500"/>
+              </a:spcBef>
+              <a:defRPr sz="1150">
+                <a:solidFill>
+                  <a:srgbClr val="F8FAFC"/>
+                </a:solidFill>
+              </a:defRPr>
+            </a:pPr>
+            <a:r>
+              <a:t>• TEST 08 [PASS]: Double-Entry Ledger Consistency (Debits strictly equal credits on every disbursement).</a:t>
+            </a:r>
+          </a:p>
+          <a:p>
+            <a:pPr>
+              <a:spcBef>
+                <a:spcPts val="500"/>
+              </a:spcBef>
+              <a:defRPr sz="1150">
+                <a:solidFill>
+                  <a:srgbClr val="F8FAFC"/>
+                </a:solidFill>
+              </a:defRPr>
+            </a:pPr>
+            <a:r>
+              <a:t>• TEST 09 [PASS]: Gateway Sub-100ms Latency SLA (Average latency 14.7ms vs 100ms enterprise budget).</a:t>
+            </a:r>
+          </a:p>
+          <a:p>
+            <a:pPr>
+              <a:spcBef>
+                <a:spcPts val="500"/>
+              </a:spcBef>
+              <a:defRPr sz="1150">
+                <a:solidFill>
+                  <a:srgbClr val="F8FAFC"/>
+                </a:solidFill>
+              </a:defRPr>
+            </a:pPr>
+            <a:r>
+              <a:t>• TEST 10 [PASS]: Streamlit Executive Portal Health (HTTP 200 OK across all underwriter screens).</a:t>
+            </a:r>
+          </a:p>
+        </p:txBody>
+      </p:sp>
+    </p:spTree>
+  </p:cSld>
+  <p:clrMapOvr>
+    <a:masterClrMapping/>
+  </p:clrMapOvr>
+</p:sld>
+</file>
+
+<file path=ppt/slides/slide16.xml><?xml version="1.0" encoding="utf-8"?>
+<p:sld xmlns:a="http://schemas.openxmlformats.org/drawingml/2006/main" xmlns:p="http://schemas.openxmlformats.org/presentationml/2006/main" xmlns:r="http://schemas.openxmlformats.org/officeDocument/2006/relationships">
+  <p:cSld>
+    <p:spTree>
+      <p:nvGrpSpPr>
+        <p:cNvPr id="1" name=""/>
+        <p:cNvGrpSpPr/>
+        <p:nvPr/>
+      </p:nvGrpSpPr>
+      <p:grpSpPr/>
+      <p:sp>
+        <p:nvSpPr>
+          <p:cNvPr id="2" name="Rectangle 1"/>
+          <p:cNvSpPr/>
+          <p:nvPr/>
+        </p:nvSpPr>
+        <p:spPr>
+          <a:xfrm>
+            <a:off x="0" y="0"/>
+            <a:ext cx="12191695" cy="6858000"/>
+          </a:xfrm>
+          <a:prstGeom prst="rect">
+            <a:avLst/>
+          </a:prstGeom>
+          <a:solidFill>
+            <a:srgbClr val="0B1120"/>
+          </a:solidFill>
+          <a:ln>
+            <a:noFill/>
+          </a:ln>
+        </p:spPr>
+        <p:style>
+          <a:lnRef idx="1">
+            <a:schemeClr val="accent1"/>
+          </a:lnRef>
+          <a:fillRef idx="3">
+            <a:schemeClr val="accent1"/>
+          </a:fillRef>
+          <a:effectRef idx="2">
+            <a:schemeClr val="accent1"/>
+          </a:effectRef>
+          <a:fontRef idx="minor">
+            <a:schemeClr val="lt1"/>
+          </a:fontRef>
+        </p:style>
+        <p:txBody>
+          <a:bodyPr rtlCol="0" anchor="ctr"/>
+          <a:lstStyle/>
+          <a:p>
+            <a:pPr algn="ctr"/>
+          </a:p>
+        </p:txBody>
+      </p:sp>
+      <p:sp>
+        <p:nvSpPr>
+          <p:cNvPr id="3" name="TextBox 2"/>
+          <p:cNvSpPr txBox="1"/>
+          <p:nvPr/>
+        </p:nvSpPr>
+        <p:spPr>
+          <a:xfrm>
+            <a:off x="731520" y="365760"/>
+            <a:ext cx="10698480" cy="1005840"/>
+          </a:xfrm>
+          <a:prstGeom prst="rect">
+            <a:avLst/>
+          </a:prstGeom>
+          <a:noFill/>
+        </p:spPr>
+        <p:txBody>
+          <a:bodyPr wrap="square">
+            <a:spAutoFit/>
+          </a:bodyPr>
+          <a:lstStyle/>
+          <a:p>
+            <a:pPr>
+              <a:defRPr sz="2600" b="1">
+                <a:solidFill>
+                  <a:srgbClr val="38BDF8"/>
+                </a:solidFill>
+              </a:defRPr>
+            </a:pPr>
+            <a:r>
               <a:t>Summary &amp; Strategic Value Proposition</a:t>
             </a:r>
           </a:p>
@@ -5644,7 +6357,7 @@
               </a:defRPr>
             </a:pPr>
             <a:r>
-              <a:t>High-Level Solution Context: Ciihive ERP &amp; AI Decisioning Flow</a:t>
+              <a:t>System Flow (Part 1 of 3): Channels, Gateway &amp; Orchestration</a:t>
             </a:r>
           </a:p>
           <a:p>
@@ -5659,14 +6372,169 @@
               </a:defRPr>
             </a:pPr>
             <a:r>
-              <a:t>End-to-End Operational Lifecycle Across Channel, Core Banking LMS, and AI Decisioning Core</a:t>
+              <a:t>Borrower Mobile PWA, Spring Cloud Gateway Edge, and Asynchronous Fan-Out Ingestion</a:t>
+            </a:r>
+          </a:p>
+        </p:txBody>
+      </p:sp>
+      <p:sp>
+        <p:nvSpPr>
+          <p:cNvPr id="4" name="Rounded Rectangle 3"/>
+          <p:cNvSpPr/>
+          <p:nvPr/>
+        </p:nvSpPr>
+        <p:spPr>
+          <a:xfrm>
+            <a:off x="731520" y="1645920"/>
+            <a:ext cx="4572000" cy="4754880"/>
+          </a:xfrm>
+          <a:prstGeom prst="roundRect">
+            <a:avLst/>
+          </a:prstGeom>
+          <a:solidFill>
+            <a:srgbClr val="131E36"/>
+          </a:solidFill>
+          <a:ln w="19050">
+            <a:solidFill>
+              <a:srgbClr val="38BDF8"/>
+            </a:solidFill>
+          </a:ln>
+        </p:spPr>
+        <p:style>
+          <a:lnRef idx="1">
+            <a:schemeClr val="accent1"/>
+          </a:lnRef>
+          <a:fillRef idx="3">
+            <a:schemeClr val="accent1"/>
+          </a:fillRef>
+          <a:effectRef idx="2">
+            <a:schemeClr val="accent1"/>
+          </a:effectRef>
+          <a:fontRef idx="minor">
+            <a:schemeClr val="lt1"/>
+          </a:fontRef>
+        </p:style>
+        <p:txBody>
+          <a:bodyPr rtlCol="0" anchor="ctr"/>
+          <a:lstStyle/>
+          <a:p>
+            <a:pPr algn="ctr"/>
+          </a:p>
+        </p:txBody>
+      </p:sp>
+      <p:sp>
+        <p:nvSpPr>
+          <p:cNvPr id="5" name="TextBox 4"/>
+          <p:cNvSpPr txBox="1"/>
+          <p:nvPr/>
+        </p:nvSpPr>
+        <p:spPr>
+          <a:xfrm>
+            <a:off x="914400" y="1828800"/>
+            <a:ext cx="4206240" cy="4389120"/>
+          </a:xfrm>
+          <a:prstGeom prst="rect">
+            <a:avLst/>
+          </a:prstGeom>
+          <a:noFill/>
+        </p:spPr>
+        <p:txBody>
+          <a:bodyPr wrap="square">
+            <a:spAutoFit/>
+          </a:bodyPr>
+          <a:lstStyle/>
+          <a:p>
+            <a:pPr>
+              <a:defRPr sz="1600" b="1">
+                <a:solidFill>
+                  <a:srgbClr val="FBBF24"/>
+                </a:solidFill>
+              </a:defRPr>
+            </a:pPr>
+            <a:r>
+              <a:t>Stage 1 Architecture Highlights</a:t>
+            </a:r>
+          </a:p>
+          <a:p>
+            <a:pPr>
+              <a:spcBef>
+                <a:spcPts val="500"/>
+              </a:spcBef>
+              <a:defRPr sz="1150">
+                <a:solidFill>
+                  <a:srgbClr val="F8FAFC"/>
+                </a:solidFill>
+              </a:defRPr>
+            </a:pPr>
+            <a:r>
+              <a:t>• Channel Ingestion: Angular Borrower PWA (&lt;3 min journey) &amp; Ops Console.</a:t>
+            </a:r>
+          </a:p>
+          <a:p>
+            <a:pPr>
+              <a:spcBef>
+                <a:spcPts val="500"/>
+              </a:spcBef>
+              <a:defRPr sz="1150">
+                <a:solidFill>
+                  <a:srgbClr val="F8FAFC"/>
+                </a:solidFill>
+              </a:defRPr>
+            </a:pPr>
+            <a:r>
+              <a:t>• Security Edge: Spring Cloud Gateway with OAuth2, JWT validation, and mTLS.</a:t>
+            </a:r>
+          </a:p>
+          <a:p>
+            <a:pPr>
+              <a:spcBef>
+                <a:spcPts val="500"/>
+              </a:spcBef>
+              <a:defRPr sz="1150">
+                <a:solidFill>
+                  <a:srgbClr val="F8FAFC"/>
+                </a:solidFill>
+              </a:defRPr>
+            </a:pPr>
+            <a:r>
+              <a:t>• Onboarding Orchestrator: Spring Boot WebFlux drives non-blocking parallel calls.</a:t>
+            </a:r>
+          </a:p>
+          <a:p>
+            <a:pPr>
+              <a:spcBef>
+                <a:spcPts val="500"/>
+              </a:spcBef>
+              <a:defRPr sz="1150">
+                <a:solidFill>
+                  <a:srgbClr val="F8FAFC"/>
+                </a:solidFill>
+              </a:defRPr>
+            </a:pPr>
+            <a:r>
+              <a:t>• Consent &amp; Privacy: Cryptographically signed borrower consent management.</a:t>
+            </a:r>
+          </a:p>
+          <a:p>
+            <a:pPr>
+              <a:spcBef>
+                <a:spcPts val="500"/>
+              </a:spcBef>
+              <a:defRPr sz="1150">
+                <a:solidFill>
+                  <a:srgbClr val="F8FAFC"/>
+                </a:solidFill>
+              </a:defRPr>
+            </a:pPr>
+            <a:r>
+              <a:t>• Data Connectors: Parallel asynchronous calls to NADRA, Telcos, and 1Link banks.</a:t>
             </a:r>
           </a:p>
         </p:txBody>
       </p:sp>
       <p:pic>
         <p:nvPicPr>
-          <p:cNvPr id="4" name="Picture 3" descr="flow.png"/>
+          <p:cNvPr id="6" name="Picture 5" descr="flow_part1_channels.png"/>
           <p:cNvPicPr>
             <a:picLocks noChangeAspect="1"/>
           </p:cNvPicPr>
@@ -5680,8 +6548,8 @@
         </p:blipFill>
         <p:spPr>
           <a:xfrm>
-            <a:off x="1097280" y="1645920"/>
-            <a:ext cx="9966960" cy="4754880"/>
+            <a:off x="5577840" y="1645920"/>
+            <a:ext cx="5852160" cy="4754880"/>
           </a:xfrm>
           <a:prstGeom prst="rect">
             <a:avLst/>
@@ -5779,7 +6647,7 @@
               </a:defRPr>
             </a:pPr>
             <a:r>
-              <a:t>End-to-End Decisioning Pipeline &amp; Data Flow</a:t>
+              <a:t>System Flow (Part 2 of 3): Feature Store &amp; AI Scoring Core</a:t>
             </a:r>
           </a:p>
           <a:p>
@@ -5794,14 +6662,169 @@
               </a:defRPr>
             </a:pPr>
             <a:r>
-              <a:t>From 15 Raw Data Families (Bronze) to 4-Bound Limits &amp; Ledger (Gold)</a:t>
+              <a:t>Point-in-Time Correctness, Redis Online Features, and 12 Sub-Pillar Execution</a:t>
+            </a:r>
+          </a:p>
+        </p:txBody>
+      </p:sp>
+      <p:sp>
+        <p:nvSpPr>
+          <p:cNvPr id="4" name="Rounded Rectangle 3"/>
+          <p:cNvSpPr/>
+          <p:nvPr/>
+        </p:nvSpPr>
+        <p:spPr>
+          <a:xfrm>
+            <a:off x="731520" y="1645920"/>
+            <a:ext cx="4572000" cy="4754880"/>
+          </a:xfrm>
+          <a:prstGeom prst="roundRect">
+            <a:avLst/>
+          </a:prstGeom>
+          <a:solidFill>
+            <a:srgbClr val="131E36"/>
+          </a:solidFill>
+          <a:ln w="19050">
+            <a:solidFill>
+              <a:srgbClr val="FBBF24"/>
+            </a:solidFill>
+          </a:ln>
+        </p:spPr>
+        <p:style>
+          <a:lnRef idx="1">
+            <a:schemeClr val="accent1"/>
+          </a:lnRef>
+          <a:fillRef idx="3">
+            <a:schemeClr val="accent1"/>
+          </a:fillRef>
+          <a:effectRef idx="2">
+            <a:schemeClr val="accent1"/>
+          </a:effectRef>
+          <a:fontRef idx="minor">
+            <a:schemeClr val="lt1"/>
+          </a:fontRef>
+        </p:style>
+        <p:txBody>
+          <a:bodyPr rtlCol="0" anchor="ctr"/>
+          <a:lstStyle/>
+          <a:p>
+            <a:pPr algn="ctr"/>
+          </a:p>
+        </p:txBody>
+      </p:sp>
+      <p:sp>
+        <p:nvSpPr>
+          <p:cNvPr id="5" name="TextBox 4"/>
+          <p:cNvSpPr txBox="1"/>
+          <p:nvPr/>
+        </p:nvSpPr>
+        <p:spPr>
+          <a:xfrm>
+            <a:off x="914400" y="1828800"/>
+            <a:ext cx="4206240" cy="4389120"/>
+          </a:xfrm>
+          <a:prstGeom prst="rect">
+            <a:avLst/>
+          </a:prstGeom>
+          <a:noFill/>
+        </p:spPr>
+        <p:txBody>
+          <a:bodyPr wrap="square">
+            <a:spAutoFit/>
+          </a:bodyPr>
+          <a:lstStyle/>
+          <a:p>
+            <a:pPr>
+              <a:defRPr sz="1600" b="1">
+                <a:solidFill>
+                  <a:srgbClr val="FBBF24"/>
+                </a:solidFill>
+              </a:defRPr>
+            </a:pPr>
+            <a:r>
+              <a:t>Stage 2 Architecture Highlights</a:t>
+            </a:r>
+          </a:p>
+          <a:p>
+            <a:pPr>
+              <a:spcBef>
+                <a:spcPts val="500"/>
+              </a:spcBef>
+              <a:defRPr sz="1150">
+                <a:solidFill>
+                  <a:srgbClr val="F8FAFC"/>
+                </a:solidFill>
+              </a:defRPr>
+            </a:pPr>
+            <a:r>
+              <a:t>• Feature Store: Redis for sub-10ms online retrieval + Parquet for offline training.</a:t>
+            </a:r>
+          </a:p>
+          <a:p>
+            <a:pPr>
+              <a:spcBef>
+                <a:spcPts val="500"/>
+              </a:spcBef>
+              <a:defRPr sz="1150">
+                <a:solidFill>
+                  <a:srgbClr val="F8FAFC"/>
+                </a:solidFill>
+              </a:defRPr>
+            </a:pPr>
+            <a:r>
+              <a:t>• Feature Hydration: Entity alignment joins 27 signals without data leakage.</a:t>
+            </a:r>
+          </a:p>
+          <a:p>
+            <a:pPr>
+              <a:spcBef>
+                <a:spcPts val="500"/>
+              </a:spcBef>
+              <a:defRPr sz="1150">
+                <a:solidFill>
+                  <a:srgbClr val="F8FAFC"/>
+                </a:solidFill>
+              </a:defRPr>
+            </a:pPr>
+            <a:r>
+              <a:t>• Scoring Core: 12 domain sub-pillars execute in parallel (Identity, Fraud, Cash Flow).</a:t>
+            </a:r>
+          </a:p>
+          <a:p>
+            <a:pPr>
+              <a:spcBef>
+                <a:spcPts val="500"/>
+              </a:spcBef>
+              <a:defRPr sz="1150">
+                <a:solidFill>
+                  <a:srgbClr val="F8FAFC"/>
+                </a:solidFill>
+              </a:defRPr>
+            </a:pPr>
+            <a:r>
+              <a:t>• Quantile Income Engine: Machine-learned P10, P50, and P90 income quantiles.</a:t>
+            </a:r>
+          </a:p>
+          <a:p>
+            <a:pPr>
+              <a:spcBef>
+                <a:spcPts val="500"/>
+              </a:spcBef>
+              <a:defRPr sz="1150">
+                <a:solidFill>
+                  <a:srgbClr val="F8FAFC"/>
+                </a:solidFill>
+              </a:defRPr>
+            </a:pPr>
+            <a:r>
+              <a:t>• Meta-Stacking: Logistic + LightGBM + XGBoost outputs calibrated 12-month PD.</a:t>
             </a:r>
           </a:p>
         </p:txBody>
       </p:sp>
       <p:pic>
         <p:nvPicPr>
-          <p:cNvPr id="4" name="Picture 3" descr="ai_credit_scoring_flowchart.jpg"/>
+          <p:cNvPr id="6" name="Picture 5" descr="flow_part2_decisioning.png"/>
           <p:cNvPicPr>
             <a:picLocks noChangeAspect="1"/>
           </p:cNvPicPr>
@@ -5815,8 +6838,8 @@
         </p:blipFill>
         <p:spPr>
           <a:xfrm>
-            <a:off x="1371600" y="1645920"/>
-            <a:ext cx="9418320" cy="4754880"/>
+            <a:off x="5577840" y="1645920"/>
+            <a:ext cx="5852160" cy="4754880"/>
           </a:xfrm>
           <a:prstGeom prst="rect">
             <a:avLst/>
@@ -5914,7 +6937,7 @@
               </a:defRPr>
             </a:pPr>
             <a:r>
-              <a:t>Lakehouse Data Architecture: 15 Data Families</a:t>
+              <a:t>System Flow (Part 3 of 3): Limit Policy &amp; Core Ledger</a:t>
             </a:r>
           </a:p>
           <a:p>
@@ -5929,7 +6952,7 @@
               </a:defRPr>
             </a:pPr>
             <a:r>
-              <a:t>Medallion Architecture (Bronze Ingestion -&gt; Silver Feature Store -&gt; Gold Accounting Ledger)</a:t>
+              <a:t>4-Bound Constraint Sizing, TreeSHAP Explainability, and Double-Entry LMS Posting</a:t>
             </a:r>
           </a:p>
         </p:txBody>
@@ -5943,207 +6966,7 @@
         <p:spPr>
           <a:xfrm>
             <a:off x="731520" y="1645920"/>
-            <a:ext cx="3291840" cy="4754880"/>
-          </a:xfrm>
-          <a:prstGeom prst="roundRect">
-            <a:avLst/>
-          </a:prstGeom>
-          <a:solidFill>
-            <a:srgbClr val="131E36"/>
-          </a:solidFill>
-          <a:ln w="19050">
-            <a:solidFill>
-              <a:srgbClr val="38BDF8"/>
-            </a:solidFill>
-          </a:ln>
-        </p:spPr>
-        <p:style>
-          <a:lnRef idx="1">
-            <a:schemeClr val="accent1"/>
-          </a:lnRef>
-          <a:fillRef idx="3">
-            <a:schemeClr val="accent1"/>
-          </a:fillRef>
-          <a:effectRef idx="2">
-            <a:schemeClr val="accent1"/>
-          </a:effectRef>
-          <a:fontRef idx="minor">
-            <a:schemeClr val="lt1"/>
-          </a:fontRef>
-        </p:style>
-        <p:txBody>
-          <a:bodyPr rtlCol="0" anchor="ctr"/>
-          <a:lstStyle/>
-          <a:p>
-            <a:pPr algn="ctr"/>
-          </a:p>
-        </p:txBody>
-      </p:sp>
-      <p:sp>
-        <p:nvSpPr>
-          <p:cNvPr id="5" name="TextBox 4"/>
-          <p:cNvSpPr txBox="1"/>
-          <p:nvPr/>
-        </p:nvSpPr>
-        <p:spPr>
-          <a:xfrm>
-            <a:off x="914400" y="1828800"/>
-            <a:ext cx="2926080" cy="4389120"/>
-          </a:xfrm>
-          <a:prstGeom prst="rect">
-            <a:avLst/>
-          </a:prstGeom>
-          <a:noFill/>
-        </p:spPr>
-        <p:txBody>
-          <a:bodyPr wrap="square">
-            <a:spAutoFit/>
-          </a:bodyPr>
-          <a:lstStyle/>
-          <a:p>
-            <a:pPr>
-              <a:defRPr sz="1600" b="1">
-                <a:solidFill>
-                  <a:srgbClr val="FBBF24"/>
-                </a:solidFill>
-              </a:defRPr>
-            </a:pPr>
-            <a:r>
-              <a:t>Bronze: Raw Ingestion Lake</a:t>
-            </a:r>
-          </a:p>
-          <a:p>
-            <a:pPr>
-              <a:spcBef>
-                <a:spcPts val="500"/>
-              </a:spcBef>
-              <a:defRPr sz="1150">
-                <a:solidFill>
-                  <a:srgbClr val="F8FAFC"/>
-                </a:solidFill>
-              </a:defRPr>
-            </a:pPr>
-            <a:r>
-              <a:t>• Family 01: NADRA / Demographics</a:t>
-            </a:r>
-          </a:p>
-          <a:p>
-            <a:pPr>
-              <a:spcBef>
-                <a:spcPts val="500"/>
-              </a:spcBef>
-              <a:defRPr sz="1150">
-                <a:solidFill>
-                  <a:srgbClr val="F8FAFC"/>
-                </a:solidFill>
-              </a:defRPr>
-            </a:pPr>
-            <a:r>
-              <a:t>• Family 02: Mobile Device Telemetry</a:t>
-            </a:r>
-          </a:p>
-          <a:p>
-            <a:pPr>
-              <a:spcBef>
-                <a:spcPts val="500"/>
-              </a:spcBef>
-              <a:defRPr sz="1150">
-                <a:solidFill>
-                  <a:srgbClr val="F8FAFC"/>
-                </a:solidFill>
-              </a:defRPr>
-            </a:pPr>
-            <a:r>
-              <a:t>• Family 03: In-App Application Meta</a:t>
-            </a:r>
-          </a:p>
-          <a:p>
-            <a:pPr>
-              <a:spcBef>
-                <a:spcPts val="500"/>
-              </a:spcBef>
-              <a:defRPr sz="1150">
-                <a:solidFill>
-                  <a:srgbClr val="F8FAFC"/>
-                </a:solidFill>
-              </a:defRPr>
-            </a:pPr>
-            <a:r>
-              <a:t>• Family 04: Employer &amp; 1Link Payroll</a:t>
-            </a:r>
-          </a:p>
-          <a:p>
-            <a:pPr>
-              <a:spcBef>
-                <a:spcPts val="500"/>
-              </a:spcBef>
-              <a:defRPr sz="1150">
-                <a:solidFill>
-                  <a:srgbClr val="F8FAFC"/>
-                </a:solidFill>
-              </a:defRPr>
-            </a:pPr>
-            <a:r>
-              <a:t>• Family 05: Declared / Ingested Salary</a:t>
-            </a:r>
-          </a:p>
-          <a:p>
-            <a:pPr>
-              <a:spcBef>
-                <a:spcPts val="500"/>
-              </a:spcBef>
-              <a:defRPr sz="1150">
-                <a:solidFill>
-                  <a:srgbClr val="F8FAFC"/>
-                </a:solidFill>
-              </a:defRPr>
-            </a:pPr>
-            <a:r>
-              <a:t>• Family 06: Banking Statement Velocity</a:t>
-            </a:r>
-          </a:p>
-          <a:p>
-            <a:pPr>
-              <a:spcBef>
-                <a:spcPts val="500"/>
-              </a:spcBef>
-              <a:defRPr sz="1150">
-                <a:solidFill>
-                  <a:srgbClr val="F8FAFC"/>
-                </a:solidFill>
-              </a:defRPr>
-            </a:pPr>
-            <a:r>
-              <a:t>• Family 07: JazzCash / Easypaisa Wallets</a:t>
-            </a:r>
-          </a:p>
-          <a:p>
-            <a:pPr>
-              <a:spcBef>
-                <a:spcPts val="500"/>
-              </a:spcBef>
-              <a:defRPr sz="1150">
-                <a:solidFill>
-                  <a:srgbClr val="F8FAFC"/>
-                </a:solidFill>
-              </a:defRPr>
-            </a:pPr>
-            <a:r>
-              <a:t>• Family 08: Telco Recharge &amp; SIM Tenure</a:t>
-            </a:r>
-          </a:p>
-        </p:txBody>
-      </p:sp>
-      <p:sp>
-        <p:nvSpPr>
-          <p:cNvPr id="6" name="Rounded Rectangle 5"/>
-          <p:cNvSpPr/>
-          <p:nvPr/>
-        </p:nvSpPr>
-        <p:spPr>
-          <a:xfrm>
-            <a:off x="4389120" y="1645920"/>
-            <a:ext cx="3291840" cy="4754880"/>
+            <a:ext cx="4572000" cy="4754880"/>
           </a:xfrm>
           <a:prstGeom prst="roundRect">
             <a:avLst/>
@@ -6181,14 +7004,14 @@
       </p:sp>
       <p:sp>
         <p:nvSpPr>
-          <p:cNvPr id="7" name="TextBox 6"/>
+          <p:cNvPr id="5" name="TextBox 4"/>
           <p:cNvSpPr txBox="1"/>
           <p:nvPr/>
         </p:nvSpPr>
         <p:spPr>
           <a:xfrm>
-            <a:off x="4572000" y="1828800"/>
-            <a:ext cx="2926080" cy="4389120"/>
+            <a:off x="914400" y="1828800"/>
+            <a:ext cx="4206240" cy="4389120"/>
           </a:xfrm>
           <a:prstGeom prst="rect">
             <a:avLst/>
@@ -6209,286 +7032,110 @@
               </a:defRPr>
             </a:pPr>
             <a:r>
-              <a:t>Silver: Curated Feature Store</a:t>
-            </a:r>
-          </a:p>
-          <a:p>
-            <a:pPr>
-              <a:spcBef>
-                <a:spcPts val="500"/>
-              </a:spcBef>
-              <a:defRPr sz="1150">
-                <a:solidFill>
-                  <a:srgbClr val="F8FAFC"/>
-                </a:solidFill>
-              </a:defRPr>
-            </a:pPr>
-            <a:r>
-              <a:t>• 250,000 Unified Entity Profiles</a:t>
-            </a:r>
-          </a:p>
-          <a:p>
-            <a:pPr>
-              <a:spcBef>
-                <a:spcPts val="500"/>
-              </a:spcBef>
-              <a:defRPr sz="1150">
-                <a:solidFill>
-                  <a:srgbClr val="F8FAFC"/>
-                </a:solidFill>
-              </a:defRPr>
-            </a:pPr>
-            <a:r>
-              <a:t>• Curated in customer_features_v2.parquet</a:t>
-            </a:r>
-          </a:p>
-          <a:p>
-            <a:pPr>
-              <a:spcBef>
-                <a:spcPts val="500"/>
-              </a:spcBef>
-              <a:defRPr sz="1150">
-                <a:solidFill>
-                  <a:srgbClr val="F8FAFC"/>
-                </a:solidFill>
-              </a:defRPr>
-            </a:pPr>
-            <a:r>
-              <a:t>• Snappy Columnar Compression (88 MB)</a:t>
-            </a:r>
-          </a:p>
-          <a:p>
-            <a:pPr>
-              <a:spcBef>
-                <a:spcPts val="500"/>
-              </a:spcBef>
-              <a:defRPr sz="1150">
-                <a:solidFill>
-                  <a:srgbClr val="F8FAFC"/>
-                </a:solidFill>
-              </a:defRPr>
-            </a:pPr>
-            <a:r>
-              <a:t>• 27 Engineered Real-Time Signals</a:t>
-            </a:r>
-          </a:p>
-          <a:p>
-            <a:pPr>
-              <a:spcBef>
-                <a:spcPts val="500"/>
-              </a:spcBef>
-              <a:defRPr sz="1150">
-                <a:solidFill>
-                  <a:srgbClr val="F8FAFC"/>
-                </a:solidFill>
-              </a:defRPr>
-            </a:pPr>
-            <a:r>
-              <a:t>• Point-in-time correctness (Zero Leakage)</a:t>
-            </a:r>
-          </a:p>
-          <a:p>
-            <a:pPr>
-              <a:spcBef>
-                <a:spcPts val="500"/>
-              </a:spcBef>
-              <a:defRPr sz="1150">
-                <a:solidFill>
-                  <a:srgbClr val="F8FAFC"/>
-                </a:solidFill>
-              </a:defRPr>
-            </a:pPr>
-            <a:r>
-              <a:t>• Eliminates Training-Serving Skew</a:t>
-            </a:r>
-          </a:p>
-          <a:p>
-            <a:pPr>
-              <a:spcBef>
-                <a:spcPts val="500"/>
-              </a:spcBef>
-              <a:defRPr sz="1150">
-                <a:solidFill>
-                  <a:srgbClr val="F8FAFC"/>
-                </a:solidFill>
-              </a:defRPr>
-            </a:pPr>
-            <a:r>
-              <a:t>• Queried simultaneously by API &amp; Batch</a:t>
-            </a:r>
-          </a:p>
-        </p:txBody>
-      </p:sp>
-      <p:sp>
-        <p:nvSpPr>
-          <p:cNvPr id="8" name="Rounded Rectangle 7"/>
-          <p:cNvSpPr/>
+              <a:t>Stage 3 Architecture Highlights</a:t>
+            </a:r>
+          </a:p>
+          <a:p>
+            <a:pPr>
+              <a:spcBef>
+                <a:spcPts val="500"/>
+              </a:spcBef>
+              <a:defRPr sz="1150">
+                <a:solidFill>
+                  <a:srgbClr val="F8FAFC"/>
+                </a:solidFill>
+              </a:defRPr>
+            </a:pPr>
+            <a:r>
+              <a:t>• Policy Engine: min(Affordability, Risk Cap, Policy Cap, Clean Cycles Ladder).</a:t>
+            </a:r>
+          </a:p>
+          <a:p>
+            <a:pPr>
+              <a:spcBef>
+                <a:spcPts val="500"/>
+              </a:spcBef>
+              <a:defRPr sz="1150">
+                <a:solidFill>
+                  <a:srgbClr val="F8FAFC"/>
+                </a:solidFill>
+              </a:defRPr>
+            </a:pPr>
+            <a:r>
+              <a:t>• Regulatory APR: Capped at 36.0% statutory ceiling (KIBOR + Grade Risk Spread).</a:t>
+            </a:r>
+          </a:p>
+          <a:p>
+            <a:pPr>
+              <a:spcBef>
+                <a:spcPts val="500"/>
+              </a:spcBef>
+              <a:defRPr sz="1150">
+                <a:solidFill>
+                  <a:srgbClr val="F8FAFC"/>
+                </a:solidFill>
+              </a:defRPr>
+            </a:pPr>
+            <a:r>
+              <a:t>• TreeSHAP Explainer: Computes exact local Shapley feature attributions.</a:t>
+            </a:r>
+          </a:p>
+          <a:p>
+            <a:pPr>
+              <a:spcBef>
+                <a:spcPts val="500"/>
+              </a:spcBef>
+              <a:defRPr sz="1150">
+                <a:solidFill>
+                  <a:srgbClr val="F8FAFC"/>
+                </a:solidFill>
+              </a:defRPr>
+            </a:pPr>
+            <a:r>
+              <a:t>• Ciihive LMS Core: Automated double-entry disbursement and journal postings.</a:t>
+            </a:r>
+          </a:p>
+          <a:p>
+            <a:pPr>
+              <a:spcBef>
+                <a:spcPts val="500"/>
+              </a:spcBef>
+              <a:defRPr sz="1150">
+                <a:solidFill>
+                  <a:srgbClr val="F8FAFC"/>
+                </a:solidFill>
+              </a:defRPr>
+            </a:pPr>
+            <a:r>
+              <a:t>• IFRS 9 Provisioning: Automatic staging (Stage 1, Stage 2 SICR, Stage 3 Default).</a:t>
+            </a:r>
+          </a:p>
+        </p:txBody>
+      </p:sp>
+      <p:pic>
+        <p:nvPicPr>
+          <p:cNvPr id="6" name="Picture 5" descr="flow_part3_ledger.png"/>
+          <p:cNvPicPr>
+            <a:picLocks noChangeAspect="1"/>
+          </p:cNvPicPr>
           <p:nvPr/>
-        </p:nvSpPr>
-        <p:spPr>
-          <a:xfrm>
-            <a:off x="8046720" y="1645920"/>
-            <a:ext cx="3291840" cy="4754880"/>
-          </a:xfrm>
-          <a:prstGeom prst="roundRect">
-            <a:avLst/>
-          </a:prstGeom>
-          <a:solidFill>
-            <a:srgbClr val="131E36"/>
-          </a:solidFill>
-          <a:ln w="19050">
-            <a:solidFill>
-              <a:srgbClr val="FBBF24"/>
-            </a:solidFill>
-          </a:ln>
-        </p:spPr>
-        <p:style>
-          <a:lnRef idx="1">
-            <a:schemeClr val="accent1"/>
-          </a:lnRef>
-          <a:fillRef idx="3">
-            <a:schemeClr val="accent1"/>
-          </a:fillRef>
-          <a:effectRef idx="2">
-            <a:schemeClr val="accent1"/>
-          </a:effectRef>
-          <a:fontRef idx="minor">
-            <a:schemeClr val="lt1"/>
-          </a:fontRef>
-        </p:style>
-        <p:txBody>
-          <a:bodyPr rtlCol="0" anchor="ctr"/>
-          <a:lstStyle/>
-          <a:p>
-            <a:pPr algn="ctr"/>
-          </a:p>
-        </p:txBody>
-      </p:sp>
-      <p:sp>
-        <p:nvSpPr>
-          <p:cNvPr id="9" name="TextBox 8"/>
-          <p:cNvSpPr txBox="1"/>
-          <p:nvPr/>
-        </p:nvSpPr>
-        <p:spPr>
-          <a:xfrm>
-            <a:off x="8229600" y="1828800"/>
-            <a:ext cx="2926080" cy="4389120"/>
+        </p:nvPicPr>
+        <p:blipFill>
+          <a:blip r:embed="rId2"/>
+          <a:stretch>
+            <a:fillRect/>
+          </a:stretch>
+        </p:blipFill>
+        <p:spPr>
+          <a:xfrm>
+            <a:off x="5577840" y="1645920"/>
+            <a:ext cx="5852160" cy="4754880"/>
           </a:xfrm>
           <a:prstGeom prst="rect">
             <a:avLst/>
           </a:prstGeom>
-          <a:noFill/>
-        </p:spPr>
-        <p:txBody>
-          <a:bodyPr wrap="square">
-            <a:spAutoFit/>
-          </a:bodyPr>
-          <a:lstStyle/>
-          <a:p>
-            <a:pPr>
-              <a:defRPr sz="1600" b="1">
-                <a:solidFill>
-                  <a:srgbClr val="FBBF24"/>
-                </a:solidFill>
-              </a:defRPr>
-            </a:pPr>
-            <a:r>
-              <a:t>Gold: Business &amp; Audit Layer</a:t>
-            </a:r>
-          </a:p>
-          <a:p>
-            <a:pPr>
-              <a:spcBef>
-                <a:spcPts val="500"/>
-              </a:spcBef>
-              <a:defRPr sz="1150">
-                <a:solidFill>
-                  <a:srgbClr val="F8FAFC"/>
-                </a:solidFill>
-              </a:defRPr>
-            </a:pPr>
-            <a:r>
-              <a:t>• credit_scores_250k.parquet (Scored Universe)</a:t>
-            </a:r>
-          </a:p>
-          <a:p>
-            <a:pPr>
-              <a:spcBef>
-                <a:spcPts val="500"/>
-              </a:spcBef>
-              <a:defRPr sz="1150">
-                <a:solidFill>
-                  <a:srgbClr val="F8FAFC"/>
-                </a:solidFill>
-              </a:defRPr>
-            </a:pPr>
-            <a:r>
-              <a:t>• disbursed_loans.parquet (Core Ledger)</a:t>
-            </a:r>
-          </a:p>
-          <a:p>
-            <a:pPr>
-              <a:spcBef>
-                <a:spcPts val="500"/>
-              </a:spcBef>
-              <a:defRPr sz="1150">
-                <a:solidFill>
-                  <a:srgbClr val="F8FAFC"/>
-                </a:solidFill>
-              </a:defRPr>
-            </a:pPr>
-            <a:r>
-              <a:t>• grade_a_customers.csv (Super-Prime VIPs)</a:t>
-            </a:r>
-          </a:p>
-          <a:p>
-            <a:pPr>
-              <a:spcBef>
-                <a:spcPts val="500"/>
-              </a:spcBef>
-              <a:defRPr sz="1150">
-                <a:solidFill>
-                  <a:srgbClr val="F8FAFC"/>
-                </a:solidFill>
-              </a:defRPr>
-            </a:pPr>
-            <a:r>
-              <a:t>• Double-Entry Accounting Ledger</a:t>
-            </a:r>
-          </a:p>
-          <a:p>
-            <a:pPr>
-              <a:spcBef>
-                <a:spcPts val="500"/>
-              </a:spcBef>
-              <a:defRPr sz="1150">
-                <a:solidFill>
-                  <a:srgbClr val="F8FAFC"/>
-                </a:solidFill>
-              </a:defRPr>
-            </a:pPr>
-            <a:r>
-              <a:t>• Real-Time IFRS 9 ECL Provisioning</a:t>
-            </a:r>
-          </a:p>
-          <a:p>
-            <a:pPr>
-              <a:spcBef>
-                <a:spcPts val="500"/>
-              </a:spcBef>
-              <a:defRPr sz="1150">
-                <a:solidFill>
-                  <a:srgbClr val="F8FAFC"/>
-                </a:solidFill>
-              </a:defRPr>
-            </a:pPr>
-            <a:r>
-              <a:t>• Population Stability Index (PSI) Drift Monitor</a:t>
-            </a:r>
-          </a:p>
-        </p:txBody>
-      </p:sp>
+        </p:spPr>
+      </p:pic>
     </p:spTree>
   </p:cSld>
   <p:clrMapOvr>
@@ -6580,7 +7227,7 @@
               </a:defRPr>
             </a:pPr>
             <a:r>
-              <a:t>The 12 Sub-Pillar AI Models</a:t>
+              <a:t>Complete Machine Learning Decision Pipeline</a:t>
             </a:r>
           </a:p>
           <a:p>
@@ -6595,351 +7242,35 @@
               </a:defRPr>
             </a:pPr>
             <a:r>
-              <a:t>Specialized Machine Learning Architecture for Multidimensional Credit Intelligence</a:t>
-            </a:r>
-          </a:p>
-        </p:txBody>
-      </p:sp>
-      <p:sp>
-        <p:nvSpPr>
-          <p:cNvPr id="4" name="Rounded Rectangle 3"/>
-          <p:cNvSpPr/>
+              <a:t>From 15 Raw Data Families (Bronze) to 4-Bound Limits &amp; Ledger (Gold)</a:t>
+            </a:r>
+          </a:p>
+        </p:txBody>
+      </p:sp>
+      <p:pic>
+        <p:nvPicPr>
+          <p:cNvPr id="4" name="Picture 3" descr="ai_credit_scoring_flowchart.jpg"/>
+          <p:cNvPicPr>
+            <a:picLocks noChangeAspect="1"/>
+          </p:cNvPicPr>
           <p:nvPr/>
-        </p:nvSpPr>
-        <p:spPr>
-          <a:xfrm>
-            <a:off x="731520" y="1645920"/>
-            <a:ext cx="5120640" cy="4754880"/>
-          </a:xfrm>
-          <a:prstGeom prst="roundRect">
-            <a:avLst/>
-          </a:prstGeom>
-          <a:solidFill>
-            <a:srgbClr val="131E36"/>
-          </a:solidFill>
-          <a:ln w="19050">
-            <a:solidFill>
-              <a:srgbClr val="38BDF8"/>
-            </a:solidFill>
-          </a:ln>
-        </p:spPr>
-        <p:style>
-          <a:lnRef idx="1">
-            <a:schemeClr val="accent1"/>
-          </a:lnRef>
-          <a:fillRef idx="3">
-            <a:schemeClr val="accent1"/>
-          </a:fillRef>
-          <a:effectRef idx="2">
-            <a:schemeClr val="accent1"/>
-          </a:effectRef>
-          <a:fontRef idx="minor">
-            <a:schemeClr val="lt1"/>
-          </a:fontRef>
-        </p:style>
-        <p:txBody>
-          <a:bodyPr rtlCol="0" anchor="ctr"/>
-          <a:lstStyle/>
-          <a:p>
-            <a:pPr algn="ctr"/>
-          </a:p>
-        </p:txBody>
-      </p:sp>
-      <p:sp>
-        <p:nvSpPr>
-          <p:cNvPr id="5" name="TextBox 4"/>
-          <p:cNvSpPr txBox="1"/>
-          <p:nvPr/>
-        </p:nvSpPr>
-        <p:spPr>
-          <a:xfrm>
-            <a:off x="914400" y="1828800"/>
-            <a:ext cx="4754879" cy="4389120"/>
+        </p:nvPicPr>
+        <p:blipFill>
+          <a:blip r:embed="rId2"/>
+          <a:stretch>
+            <a:fillRect/>
+          </a:stretch>
+        </p:blipFill>
+        <p:spPr>
+          <a:xfrm>
+            <a:off x="1371600" y="1645920"/>
+            <a:ext cx="9418320" cy="4754880"/>
           </a:xfrm>
           <a:prstGeom prst="rect">
             <a:avLst/>
           </a:prstGeom>
-          <a:noFill/>
-        </p:spPr>
-        <p:txBody>
-          <a:bodyPr wrap="square">
-            <a:spAutoFit/>
-          </a:bodyPr>
-          <a:lstStyle/>
-          <a:p>
-            <a:pPr>
-              <a:defRPr sz="1600" b="1">
-                <a:solidFill>
-                  <a:srgbClr val="FBBF24"/>
-                </a:solidFill>
-              </a:defRPr>
-            </a:pPr>
-            <a:r>
-              <a:t>P01 to P06 Models</a:t>
-            </a:r>
-          </a:p>
-          <a:p>
-            <a:pPr>
-              <a:spcBef>
-                <a:spcPts val="500"/>
-              </a:spcBef>
-              <a:defRPr sz="1150">
-                <a:solidFill>
-                  <a:srgbClr val="F8FAFC"/>
-                </a:solidFill>
-              </a:defRPr>
-            </a:pPr>
-            <a:r>
-              <a:t>• P01 Identity Trust: Rules + Gradient Boosting (CNIC match, age integrity).</a:t>
-            </a:r>
-          </a:p>
-          <a:p>
-            <a:pPr>
-              <a:spcBef>
-                <a:spcPts val="500"/>
-              </a:spcBef>
-              <a:defRPr sz="1150">
-                <a:solidFill>
-                  <a:srgbClr val="F8FAFC"/>
-                </a:solidFill>
-              </a:defRPr>
-            </a:pPr>
-            <a:r>
-              <a:t>• P02 Fraud Risk: Isolation Forest + GNN + GBM (Rooted &amp; emulator knockouts).</a:t>
-            </a:r>
-          </a:p>
-          <a:p>
-            <a:pPr>
-              <a:spcBef>
-                <a:spcPts val="500"/>
-              </a:spcBef>
-              <a:defRPr sz="1150">
-                <a:solidFill>
-                  <a:srgbClr val="F8FAFC"/>
-                </a:solidFill>
-              </a:defRPr>
-            </a:pPr>
-            <a:r>
-              <a:t>• P03 Income Estimation: LightGBM Pinball Quantile Regressors (P10, P50, P90).</a:t>
-            </a:r>
-          </a:p>
-          <a:p>
-            <a:pPr>
-              <a:spcBef>
-                <a:spcPts val="500"/>
-              </a:spcBef>
-              <a:defRPr sz="1150">
-                <a:solidFill>
-                  <a:srgbClr val="F8FAFC"/>
-                </a:solidFill>
-              </a:defRPr>
-            </a:pPr>
-            <a:r>
-              <a:t>• P04 Cash Flow Health: GBM on rolling inflow/outflow liquidity volatility.</a:t>
-            </a:r>
-          </a:p>
-          <a:p>
-            <a:pPr>
-              <a:spcBef>
-                <a:spcPts val="500"/>
-              </a:spcBef>
-              <a:defRPr sz="1150">
-                <a:solidFill>
-                  <a:srgbClr val="F8FAFC"/>
-                </a:solidFill>
-              </a:defRPr>
-            </a:pPr>
-            <a:r>
-              <a:t>• P05 Affordability: SBP FOIR &lt;= 45% statutory ceiling + disposable margin.</a:t>
-            </a:r>
-          </a:p>
-          <a:p>
-            <a:pPr>
-              <a:spcBef>
-                <a:spcPts val="500"/>
-              </a:spcBef>
-              <a:defRPr sz="1150">
-                <a:solidFill>
-                  <a:srgbClr val="F8FAFC"/>
-                </a:solidFill>
-              </a:defRPr>
-            </a:pPr>
-            <a:r>
-              <a:t>• P06 Stability: GBM on employment duration &amp; residential persistence.</a:t>
-            </a:r>
-          </a:p>
-        </p:txBody>
-      </p:sp>
-      <p:sp>
-        <p:nvSpPr>
-          <p:cNvPr id="6" name="Rounded Rectangle 5"/>
-          <p:cNvSpPr/>
-          <p:nvPr/>
-        </p:nvSpPr>
-        <p:spPr>
-          <a:xfrm>
-            <a:off x="6217920" y="1645920"/>
-            <a:ext cx="5120640" cy="4754880"/>
-          </a:xfrm>
-          <a:prstGeom prst="roundRect">
-            <a:avLst/>
-          </a:prstGeom>
-          <a:solidFill>
-            <a:srgbClr val="131E36"/>
-          </a:solidFill>
-          <a:ln w="19050">
-            <a:solidFill>
-              <a:srgbClr val="38BDF8"/>
-            </a:solidFill>
-          </a:ln>
-        </p:spPr>
-        <p:style>
-          <a:lnRef idx="1">
-            <a:schemeClr val="accent1"/>
-          </a:lnRef>
-          <a:fillRef idx="3">
-            <a:schemeClr val="accent1"/>
-          </a:fillRef>
-          <a:effectRef idx="2">
-            <a:schemeClr val="accent1"/>
-          </a:effectRef>
-          <a:fontRef idx="minor">
-            <a:schemeClr val="lt1"/>
-          </a:fontRef>
-        </p:style>
-        <p:txBody>
-          <a:bodyPr rtlCol="0" anchor="ctr"/>
-          <a:lstStyle/>
-          <a:p>
-            <a:pPr algn="ctr"/>
-          </a:p>
-        </p:txBody>
-      </p:sp>
-      <p:sp>
-        <p:nvSpPr>
-          <p:cNvPr id="7" name="TextBox 6"/>
-          <p:cNvSpPr txBox="1"/>
-          <p:nvPr/>
-        </p:nvSpPr>
-        <p:spPr>
-          <a:xfrm>
-            <a:off x="6400800" y="1828800"/>
-            <a:ext cx="4754879" cy="4389120"/>
-          </a:xfrm>
-          <a:prstGeom prst="rect">
-            <a:avLst/>
-          </a:prstGeom>
-          <a:noFill/>
-        </p:spPr>
-        <p:txBody>
-          <a:bodyPr wrap="square">
-            <a:spAutoFit/>
-          </a:bodyPr>
-          <a:lstStyle/>
-          <a:p>
-            <a:pPr>
-              <a:defRPr sz="1600" b="1">
-                <a:solidFill>
-                  <a:srgbClr val="FBBF24"/>
-                </a:solidFill>
-              </a:defRPr>
-            </a:pPr>
-            <a:r>
-              <a:t>P07 to P12 Models</a:t>
-            </a:r>
-          </a:p>
-          <a:p>
-            <a:pPr>
-              <a:spcBef>
-                <a:spcPts val="500"/>
-              </a:spcBef>
-              <a:defRPr sz="1150">
-                <a:solidFill>
-                  <a:srgbClr val="F8FAFC"/>
-                </a:solidFill>
-              </a:defRPr>
-            </a:pPr>
-            <a:r>
-              <a:t>• P07 Behavioral Risk: GRU Keystroke Sequence + Hesitation Score GBM.</a:t>
-            </a:r>
-          </a:p>
-          <a:p>
-            <a:pPr>
-              <a:spcBef>
-                <a:spcPts val="500"/>
-              </a:spcBef>
-              <a:defRPr sz="1150">
-                <a:solidFill>
-                  <a:srgbClr val="F8FAFC"/>
-                </a:solidFill>
-              </a:defRPr>
-            </a:pPr>
-            <a:r>
-              <a:t>• P08 Digital Footprint: Alternative Telco SIM age &amp; digital maturity GBM.</a:t>
-            </a:r>
-          </a:p>
-          <a:p>
-            <a:pPr>
-              <a:spcBef>
-                <a:spcPts val="500"/>
-              </a:spcBef>
-              <a:defRPr sz="1150">
-                <a:solidFill>
-                  <a:srgbClr val="F8FAFC"/>
-                </a:solidFill>
-              </a:defRPr>
-            </a:pPr>
-            <a:r>
-              <a:t>• P09 Bureau Proxy: Weight of Evidence (WoE) Scorecard + Cross-Inquiry GBM.</a:t>
-            </a:r>
-          </a:p>
-          <a:p>
-            <a:pPr>
-              <a:spcBef>
-                <a:spcPts val="500"/>
-              </a:spcBef>
-              <a:defRPr sz="1150">
-                <a:solidFill>
-                  <a:srgbClr val="F8FAFC"/>
-                </a:solidFill>
-              </a:defRPr>
-            </a:pPr>
-            <a:r>
-              <a:t>• P10 Relationship &amp; Loyalty: Survival Analysis (Cox Hazards) + Clean Cycles.</a:t>
-            </a:r>
-          </a:p>
-          <a:p>
-            <a:pPr>
-              <a:spcBef>
-                <a:spcPts val="500"/>
-              </a:spcBef>
-              <a:defRPr sz="1150">
-                <a:solidFill>
-                  <a:srgbClr val="F8FAFC"/>
-                </a:solidFill>
-              </a:defRPr>
-            </a:pPr>
-            <a:r>
-              <a:t>• P11 Collection Risk: Markov Chain Roll-Rate Matrix (30-&gt;60-&gt;90 DPD Cure).</a:t>
-            </a:r>
-          </a:p>
-          <a:p>
-            <a:pPr>
-              <a:spcBef>
-                <a:spcPts val="500"/>
-              </a:spcBef>
-              <a:defRPr sz="1150">
-                <a:solidFill>
-                  <a:srgbClr val="F8FAFC"/>
-                </a:solidFill>
-              </a:defRPr>
-            </a:pPr>
-            <a:r>
-              <a:t>• P12 Statutory Compliance: Deterministic AML / PEP / NACTA Sanction Rules.</a:t>
-            </a:r>
-          </a:p>
-        </p:txBody>
-      </p:sp>
+        </p:spPr>
+      </p:pic>
     </p:spTree>
   </p:cSld>
   <p:clrMapOvr>
@@ -7031,7 +7362,7 @@
               </a:defRPr>
             </a:pPr>
             <a:r>
-              <a:t>Meta-Stacking Ensemble Performance &amp; ROC Curves</a:t>
+              <a:t>Lakehouse Data Architecture: 15 Data Families</a:t>
             </a:r>
           </a:p>
           <a:p>
@@ -7046,7 +7377,7 @@
               </a:defRPr>
             </a:pPr>
             <a:r>
-              <a:t>Level-0 Model Diversity Synthesized into a Monotonically Constrained Meta-Learner</a:t>
+              <a:t>Medallion Architecture (Bronze Ingestion -&gt; Silver Feature Store -&gt; Gold Accounting Ledger)</a:t>
             </a:r>
           </a:p>
         </p:txBody>
@@ -7060,7 +7391,7 @@
         <p:spPr>
           <a:xfrm>
             <a:off x="731520" y="1645920"/>
-            <a:ext cx="4754880" cy="4754880"/>
+            <a:ext cx="3291840" cy="4754880"/>
           </a:xfrm>
           <a:prstGeom prst="roundRect">
             <a:avLst/>
@@ -7105,7 +7436,7 @@
         <p:spPr>
           <a:xfrm>
             <a:off x="914400" y="1828800"/>
-            <a:ext cx="4389120" cy="4389120"/>
+            <a:ext cx="2926080" cy="4389120"/>
           </a:xfrm>
           <a:prstGeom prst="rect">
             <a:avLst/>
@@ -7126,110 +7457,486 @@
               </a:defRPr>
             </a:pPr>
             <a:r>
-              <a:t>Model Validation &amp; Discrimination</a:t>
-            </a:r>
-          </a:p>
-          <a:p>
-            <a:pPr>
-              <a:spcBef>
-                <a:spcPts val="500"/>
-              </a:spcBef>
-              <a:defRPr sz="1150">
-                <a:solidFill>
-                  <a:srgbClr val="F8FAFC"/>
-                </a:solidFill>
-              </a:defRPr>
-            </a:pPr>
-            <a:r>
-              <a:t>• Level-0 Diversity: Logistic Regression, LightGBM, and XGBoost.</a:t>
-            </a:r>
-          </a:p>
-          <a:p>
-            <a:pPr>
-              <a:spcBef>
-                <a:spcPts val="500"/>
-              </a:spcBef>
-              <a:defRPr sz="1150">
-                <a:solidFill>
-                  <a:srgbClr val="F8FAFC"/>
-                </a:solidFill>
-              </a:defRPr>
-            </a:pPr>
-            <a:r>
-              <a:t>• Constrained Meta-Learner: Enforces monotonic penalties (mono_constraints = -1).</a:t>
-            </a:r>
-          </a:p>
-          <a:p>
-            <a:pPr>
-              <a:spcBef>
-                <a:spcPts val="500"/>
-              </a:spcBef>
-              <a:defRPr sz="1150">
-                <a:solidFill>
-                  <a:srgbClr val="F8FAFC"/>
-                </a:solidFill>
-              </a:defRPr>
-            </a:pPr>
-            <a:r>
-              <a:t>• Discriminatory Power: Meta-Stacking achieves AUC-ROC = 0.892 and Gini = 0.784.</a:t>
-            </a:r>
-          </a:p>
-          <a:p>
-            <a:pPr>
-              <a:spcBef>
-                <a:spcPts val="500"/>
-              </a:spcBef>
-              <a:defRPr sz="1150">
-                <a:solidFill>
-                  <a:srgbClr val="F8FAFC"/>
-                </a:solidFill>
-              </a:defRPr>
-            </a:pPr>
-            <a:r>
-              <a:t>• Substantial Uplift: Outperforms standalone LightGBM (0.865) and XGBoost (0.854).</a:t>
-            </a:r>
-          </a:p>
-          <a:p>
-            <a:pPr>
-              <a:spcBef>
-                <a:spcPts val="500"/>
-              </a:spcBef>
-              <a:defRPr sz="1150">
-                <a:solidFill>
-                  <a:srgbClr val="F8FAFC"/>
-                </a:solidFill>
-              </a:defRPr>
-            </a:pPr>
-            <a:r>
-              <a:t>• Probability Calibration: Brier score = 0.042 ensuring un-skewed 12-month PD.</a:t>
-            </a:r>
-          </a:p>
-        </p:txBody>
-      </p:sp>
-      <p:pic>
-        <p:nvPicPr>
-          <p:cNvPr id="6" name="Picture 5" descr="chart_roc_curve.png"/>
-          <p:cNvPicPr>
-            <a:picLocks noChangeAspect="1"/>
-          </p:cNvPicPr>
+              <a:t>Bronze: Raw Ingestion Lake</a:t>
+            </a:r>
+          </a:p>
+          <a:p>
+            <a:pPr>
+              <a:spcBef>
+                <a:spcPts val="500"/>
+              </a:spcBef>
+              <a:defRPr sz="1150">
+                <a:solidFill>
+                  <a:srgbClr val="F8FAFC"/>
+                </a:solidFill>
+              </a:defRPr>
+            </a:pPr>
+            <a:r>
+              <a:t>• Family 01: NADRA / Demographics</a:t>
+            </a:r>
+          </a:p>
+          <a:p>
+            <a:pPr>
+              <a:spcBef>
+                <a:spcPts val="500"/>
+              </a:spcBef>
+              <a:defRPr sz="1150">
+                <a:solidFill>
+                  <a:srgbClr val="F8FAFC"/>
+                </a:solidFill>
+              </a:defRPr>
+            </a:pPr>
+            <a:r>
+              <a:t>• Family 02: Mobile Device Telemetry</a:t>
+            </a:r>
+          </a:p>
+          <a:p>
+            <a:pPr>
+              <a:spcBef>
+                <a:spcPts val="500"/>
+              </a:spcBef>
+              <a:defRPr sz="1150">
+                <a:solidFill>
+                  <a:srgbClr val="F8FAFC"/>
+                </a:solidFill>
+              </a:defRPr>
+            </a:pPr>
+            <a:r>
+              <a:t>• Family 03: In-App Application Meta</a:t>
+            </a:r>
+          </a:p>
+          <a:p>
+            <a:pPr>
+              <a:spcBef>
+                <a:spcPts val="500"/>
+              </a:spcBef>
+              <a:defRPr sz="1150">
+                <a:solidFill>
+                  <a:srgbClr val="F8FAFC"/>
+                </a:solidFill>
+              </a:defRPr>
+            </a:pPr>
+            <a:r>
+              <a:t>• Family 04: Employer &amp; 1Link Payroll</a:t>
+            </a:r>
+          </a:p>
+          <a:p>
+            <a:pPr>
+              <a:spcBef>
+                <a:spcPts val="500"/>
+              </a:spcBef>
+              <a:defRPr sz="1150">
+                <a:solidFill>
+                  <a:srgbClr val="F8FAFC"/>
+                </a:solidFill>
+              </a:defRPr>
+            </a:pPr>
+            <a:r>
+              <a:t>• Family 05: Declared / Ingested Salary</a:t>
+            </a:r>
+          </a:p>
+          <a:p>
+            <a:pPr>
+              <a:spcBef>
+                <a:spcPts val="500"/>
+              </a:spcBef>
+              <a:defRPr sz="1150">
+                <a:solidFill>
+                  <a:srgbClr val="F8FAFC"/>
+                </a:solidFill>
+              </a:defRPr>
+            </a:pPr>
+            <a:r>
+              <a:t>• Family 06: Banking Statement Velocity</a:t>
+            </a:r>
+          </a:p>
+          <a:p>
+            <a:pPr>
+              <a:spcBef>
+                <a:spcPts val="500"/>
+              </a:spcBef>
+              <a:defRPr sz="1150">
+                <a:solidFill>
+                  <a:srgbClr val="F8FAFC"/>
+                </a:solidFill>
+              </a:defRPr>
+            </a:pPr>
+            <a:r>
+              <a:t>• Family 07: JazzCash / Easypaisa Wallets</a:t>
+            </a:r>
+          </a:p>
+          <a:p>
+            <a:pPr>
+              <a:spcBef>
+                <a:spcPts val="500"/>
+              </a:spcBef>
+              <a:defRPr sz="1150">
+                <a:solidFill>
+                  <a:srgbClr val="F8FAFC"/>
+                </a:solidFill>
+              </a:defRPr>
+            </a:pPr>
+            <a:r>
+              <a:t>• Family 08: Telco Recharge &amp; SIM Tenure</a:t>
+            </a:r>
+          </a:p>
+        </p:txBody>
+      </p:sp>
+      <p:sp>
+        <p:nvSpPr>
+          <p:cNvPr id="6" name="Rounded Rectangle 5"/>
+          <p:cNvSpPr/>
           <p:nvPr/>
-        </p:nvPicPr>
-        <p:blipFill>
-          <a:blip r:embed="rId2"/>
-          <a:stretch>
-            <a:fillRect/>
-          </a:stretch>
-        </p:blipFill>
-        <p:spPr>
-          <a:xfrm>
-            <a:off x="5760720" y="1645920"/>
-            <a:ext cx="5669280" cy="4754880"/>
+        </p:nvSpPr>
+        <p:spPr>
+          <a:xfrm>
+            <a:off x="4389120" y="1645920"/>
+            <a:ext cx="3291840" cy="4754880"/>
+          </a:xfrm>
+          <a:prstGeom prst="roundRect">
+            <a:avLst/>
+          </a:prstGeom>
+          <a:solidFill>
+            <a:srgbClr val="131E36"/>
+          </a:solidFill>
+          <a:ln w="19050">
+            <a:solidFill>
+              <a:srgbClr val="34D399"/>
+            </a:solidFill>
+          </a:ln>
+        </p:spPr>
+        <p:style>
+          <a:lnRef idx="1">
+            <a:schemeClr val="accent1"/>
+          </a:lnRef>
+          <a:fillRef idx="3">
+            <a:schemeClr val="accent1"/>
+          </a:fillRef>
+          <a:effectRef idx="2">
+            <a:schemeClr val="accent1"/>
+          </a:effectRef>
+          <a:fontRef idx="minor">
+            <a:schemeClr val="lt1"/>
+          </a:fontRef>
+        </p:style>
+        <p:txBody>
+          <a:bodyPr rtlCol="0" anchor="ctr"/>
+          <a:lstStyle/>
+          <a:p>
+            <a:pPr algn="ctr"/>
+          </a:p>
+        </p:txBody>
+      </p:sp>
+      <p:sp>
+        <p:nvSpPr>
+          <p:cNvPr id="7" name="TextBox 6"/>
+          <p:cNvSpPr txBox="1"/>
+          <p:nvPr/>
+        </p:nvSpPr>
+        <p:spPr>
+          <a:xfrm>
+            <a:off x="4572000" y="1828800"/>
+            <a:ext cx="2926080" cy="4389120"/>
           </a:xfrm>
           <a:prstGeom prst="rect">
             <a:avLst/>
           </a:prstGeom>
-        </p:spPr>
-      </p:pic>
+          <a:noFill/>
+        </p:spPr>
+        <p:txBody>
+          <a:bodyPr wrap="square">
+            <a:spAutoFit/>
+          </a:bodyPr>
+          <a:lstStyle/>
+          <a:p>
+            <a:pPr>
+              <a:defRPr sz="1600" b="1">
+                <a:solidFill>
+                  <a:srgbClr val="FBBF24"/>
+                </a:solidFill>
+              </a:defRPr>
+            </a:pPr>
+            <a:r>
+              <a:t>Silver: Curated Feature Store</a:t>
+            </a:r>
+          </a:p>
+          <a:p>
+            <a:pPr>
+              <a:spcBef>
+                <a:spcPts val="500"/>
+              </a:spcBef>
+              <a:defRPr sz="1150">
+                <a:solidFill>
+                  <a:srgbClr val="F8FAFC"/>
+                </a:solidFill>
+              </a:defRPr>
+            </a:pPr>
+            <a:r>
+              <a:t>• 250,000 Unified Entity Profiles</a:t>
+            </a:r>
+          </a:p>
+          <a:p>
+            <a:pPr>
+              <a:spcBef>
+                <a:spcPts val="500"/>
+              </a:spcBef>
+              <a:defRPr sz="1150">
+                <a:solidFill>
+                  <a:srgbClr val="F8FAFC"/>
+                </a:solidFill>
+              </a:defRPr>
+            </a:pPr>
+            <a:r>
+              <a:t>• Curated in customer_features_v2.parquet</a:t>
+            </a:r>
+          </a:p>
+          <a:p>
+            <a:pPr>
+              <a:spcBef>
+                <a:spcPts val="500"/>
+              </a:spcBef>
+              <a:defRPr sz="1150">
+                <a:solidFill>
+                  <a:srgbClr val="F8FAFC"/>
+                </a:solidFill>
+              </a:defRPr>
+            </a:pPr>
+            <a:r>
+              <a:t>• Snappy Columnar Compression (88 MB)</a:t>
+            </a:r>
+          </a:p>
+          <a:p>
+            <a:pPr>
+              <a:spcBef>
+                <a:spcPts val="500"/>
+              </a:spcBef>
+              <a:defRPr sz="1150">
+                <a:solidFill>
+                  <a:srgbClr val="F8FAFC"/>
+                </a:solidFill>
+              </a:defRPr>
+            </a:pPr>
+            <a:r>
+              <a:t>• 27 Engineered Real-Time Signals</a:t>
+            </a:r>
+          </a:p>
+          <a:p>
+            <a:pPr>
+              <a:spcBef>
+                <a:spcPts val="500"/>
+              </a:spcBef>
+              <a:defRPr sz="1150">
+                <a:solidFill>
+                  <a:srgbClr val="F8FAFC"/>
+                </a:solidFill>
+              </a:defRPr>
+            </a:pPr>
+            <a:r>
+              <a:t>• Point-in-time correctness (Zero Leakage)</a:t>
+            </a:r>
+          </a:p>
+          <a:p>
+            <a:pPr>
+              <a:spcBef>
+                <a:spcPts val="500"/>
+              </a:spcBef>
+              <a:defRPr sz="1150">
+                <a:solidFill>
+                  <a:srgbClr val="F8FAFC"/>
+                </a:solidFill>
+              </a:defRPr>
+            </a:pPr>
+            <a:r>
+              <a:t>• Eliminates Training-Serving Skew</a:t>
+            </a:r>
+          </a:p>
+          <a:p>
+            <a:pPr>
+              <a:spcBef>
+                <a:spcPts val="500"/>
+              </a:spcBef>
+              <a:defRPr sz="1150">
+                <a:solidFill>
+                  <a:srgbClr val="F8FAFC"/>
+                </a:solidFill>
+              </a:defRPr>
+            </a:pPr>
+            <a:r>
+              <a:t>• Queried simultaneously by API &amp; Batch</a:t>
+            </a:r>
+          </a:p>
+        </p:txBody>
+      </p:sp>
+      <p:sp>
+        <p:nvSpPr>
+          <p:cNvPr id="8" name="Rounded Rectangle 7"/>
+          <p:cNvSpPr/>
+          <p:nvPr/>
+        </p:nvSpPr>
+        <p:spPr>
+          <a:xfrm>
+            <a:off x="8046720" y="1645920"/>
+            <a:ext cx="3291840" cy="4754880"/>
+          </a:xfrm>
+          <a:prstGeom prst="roundRect">
+            <a:avLst/>
+          </a:prstGeom>
+          <a:solidFill>
+            <a:srgbClr val="131E36"/>
+          </a:solidFill>
+          <a:ln w="19050">
+            <a:solidFill>
+              <a:srgbClr val="FBBF24"/>
+            </a:solidFill>
+          </a:ln>
+        </p:spPr>
+        <p:style>
+          <a:lnRef idx="1">
+            <a:schemeClr val="accent1"/>
+          </a:lnRef>
+          <a:fillRef idx="3">
+            <a:schemeClr val="accent1"/>
+          </a:fillRef>
+          <a:effectRef idx="2">
+            <a:schemeClr val="accent1"/>
+          </a:effectRef>
+          <a:fontRef idx="minor">
+            <a:schemeClr val="lt1"/>
+          </a:fontRef>
+        </p:style>
+        <p:txBody>
+          <a:bodyPr rtlCol="0" anchor="ctr"/>
+          <a:lstStyle/>
+          <a:p>
+            <a:pPr algn="ctr"/>
+          </a:p>
+        </p:txBody>
+      </p:sp>
+      <p:sp>
+        <p:nvSpPr>
+          <p:cNvPr id="9" name="TextBox 8"/>
+          <p:cNvSpPr txBox="1"/>
+          <p:nvPr/>
+        </p:nvSpPr>
+        <p:spPr>
+          <a:xfrm>
+            <a:off x="8229600" y="1828800"/>
+            <a:ext cx="2926080" cy="4389120"/>
+          </a:xfrm>
+          <a:prstGeom prst="rect">
+            <a:avLst/>
+          </a:prstGeom>
+          <a:noFill/>
+        </p:spPr>
+        <p:txBody>
+          <a:bodyPr wrap="square">
+            <a:spAutoFit/>
+          </a:bodyPr>
+          <a:lstStyle/>
+          <a:p>
+            <a:pPr>
+              <a:defRPr sz="1600" b="1">
+                <a:solidFill>
+                  <a:srgbClr val="FBBF24"/>
+                </a:solidFill>
+              </a:defRPr>
+            </a:pPr>
+            <a:r>
+              <a:t>Gold: Business &amp; Audit Layer</a:t>
+            </a:r>
+          </a:p>
+          <a:p>
+            <a:pPr>
+              <a:spcBef>
+                <a:spcPts val="500"/>
+              </a:spcBef>
+              <a:defRPr sz="1150">
+                <a:solidFill>
+                  <a:srgbClr val="F8FAFC"/>
+                </a:solidFill>
+              </a:defRPr>
+            </a:pPr>
+            <a:r>
+              <a:t>• credit_scores_250k.parquet (Scored Universe)</a:t>
+            </a:r>
+          </a:p>
+          <a:p>
+            <a:pPr>
+              <a:spcBef>
+                <a:spcPts val="500"/>
+              </a:spcBef>
+              <a:defRPr sz="1150">
+                <a:solidFill>
+                  <a:srgbClr val="F8FAFC"/>
+                </a:solidFill>
+              </a:defRPr>
+            </a:pPr>
+            <a:r>
+              <a:t>• disbursed_loans.parquet (Core Ledger)</a:t>
+            </a:r>
+          </a:p>
+          <a:p>
+            <a:pPr>
+              <a:spcBef>
+                <a:spcPts val="500"/>
+              </a:spcBef>
+              <a:defRPr sz="1150">
+                <a:solidFill>
+                  <a:srgbClr val="F8FAFC"/>
+                </a:solidFill>
+              </a:defRPr>
+            </a:pPr>
+            <a:r>
+              <a:t>• grade_a_customers.csv (Super-Prime VIPs)</a:t>
+            </a:r>
+          </a:p>
+          <a:p>
+            <a:pPr>
+              <a:spcBef>
+                <a:spcPts val="500"/>
+              </a:spcBef>
+              <a:defRPr sz="1150">
+                <a:solidFill>
+                  <a:srgbClr val="F8FAFC"/>
+                </a:solidFill>
+              </a:defRPr>
+            </a:pPr>
+            <a:r>
+              <a:t>• Double-Entry Accounting Ledger</a:t>
+            </a:r>
+          </a:p>
+          <a:p>
+            <a:pPr>
+              <a:spcBef>
+                <a:spcPts val="500"/>
+              </a:spcBef>
+              <a:defRPr sz="1150">
+                <a:solidFill>
+                  <a:srgbClr val="F8FAFC"/>
+                </a:solidFill>
+              </a:defRPr>
+            </a:pPr>
+            <a:r>
+              <a:t>• Real-Time IFRS 9 ECL Provisioning</a:t>
+            </a:r>
+          </a:p>
+          <a:p>
+            <a:pPr>
+              <a:spcBef>
+                <a:spcPts val="500"/>
+              </a:spcBef>
+              <a:defRPr sz="1150">
+                <a:solidFill>
+                  <a:srgbClr val="F8FAFC"/>
+                </a:solidFill>
+              </a:defRPr>
+            </a:pPr>
+            <a:r>
+              <a:t>• Population Stability Index (PSI) Drift Monitor</a:t>
+            </a:r>
+          </a:p>
+        </p:txBody>
+      </p:sp>
     </p:spTree>
   </p:cSld>
   <p:clrMapOvr>
@@ -7321,7 +8028,7 @@
               </a:defRPr>
             </a:pPr>
             <a:r>
-              <a:t>Credit Score Calibration &amp; Rating Distribution</a:t>
+              <a:t>The 12 Sub-Pillar AI Models</a:t>
             </a:r>
           </a:p>
           <a:p>
@@ -7336,7 +8043,7 @@
               </a:defRPr>
             </a:pPr>
             <a:r>
-              <a:t>Points to Double Odds (PDO = 20, Base = 600 @ 50:1) across 250,000 Portfolio Accounts</a:t>
+              <a:t>Specialized Machine Learning Architecture for Multidimensional Credit Intelligence</a:t>
             </a:r>
           </a:p>
         </p:txBody>
@@ -7350,7 +8057,7 @@
         <p:spPr>
           <a:xfrm>
             <a:off x="731520" y="1645920"/>
-            <a:ext cx="4754880" cy="4754880"/>
+            <a:ext cx="5120640" cy="4754880"/>
           </a:xfrm>
           <a:prstGeom prst="roundRect">
             <a:avLst/>
@@ -7360,7 +8067,7 @@
           </a:solidFill>
           <a:ln w="19050">
             <a:solidFill>
-              <a:srgbClr val="FBBF24"/>
+              <a:srgbClr val="38BDF8"/>
             </a:solidFill>
           </a:ln>
         </p:spPr>
@@ -7395,7 +8102,7 @@
         <p:spPr>
           <a:xfrm>
             <a:off x="914400" y="1828800"/>
-            <a:ext cx="4389120" cy="4389120"/>
+            <a:ext cx="4754879" cy="4389120"/>
           </a:xfrm>
           <a:prstGeom prst="rect">
             <a:avLst/>
@@ -7416,110 +8123,271 @@
               </a:defRPr>
             </a:pPr>
             <a:r>
-              <a:t>Score Bands &amp; Acceptance Policy</a:t>
-            </a:r>
-          </a:p>
-          <a:p>
-            <a:pPr>
-              <a:spcBef>
-                <a:spcPts val="500"/>
-              </a:spcBef>
-              <a:defRPr sz="1150">
-                <a:solidFill>
-                  <a:srgbClr val="F8FAFC"/>
-                </a:solidFill>
-              </a:defRPr>
-            </a:pPr>
-            <a:r>
-              <a:t>• Grade A (780-850 | PD &lt;= 1.0%): 14.2% share. VIP Instant Auto-Approval.</a:t>
-            </a:r>
-          </a:p>
-          <a:p>
-            <a:pPr>
-              <a:spcBef>
-                <a:spcPts val="500"/>
-              </a:spcBef>
-              <a:defRPr sz="1150">
-                <a:solidFill>
-                  <a:srgbClr val="F8FAFC"/>
-                </a:solidFill>
-              </a:defRPr>
-            </a:pPr>
-            <a:r>
-              <a:t>• Grade B (700-779 | PD 1.0%-3.0%): 31.8% share. Core prime retail borrowing.</a:t>
-            </a:r>
-          </a:p>
-          <a:p>
-            <a:pPr>
-              <a:spcBef>
-                <a:spcPts val="500"/>
-              </a:spcBef>
-              <a:defRPr sz="1150">
-                <a:solidFill>
-                  <a:srgbClr val="F8FAFC"/>
-                </a:solidFill>
-              </a:defRPr>
-            </a:pPr>
-            <a:r>
-              <a:t>• Grade C (620-699 | PD 3.0%-7.0%): 28.5% share. Standard monitored terms.</a:t>
-            </a:r>
-          </a:p>
-          <a:p>
-            <a:pPr>
-              <a:spcBef>
-                <a:spcPts val="500"/>
-              </a:spcBef>
-              <a:defRPr sz="1150">
-                <a:solidFill>
-                  <a:srgbClr val="F8FAFC"/>
-                </a:solidFill>
-              </a:defRPr>
-            </a:pPr>
-            <a:r>
-              <a:t>• Grade D (550-619 | PD 7.0%-15.0%): 16.1% share. Strictly constrained limits.</a:t>
-            </a:r>
-          </a:p>
-          <a:p>
-            <a:pPr>
-              <a:spcBef>
-                <a:spcPts val="500"/>
-              </a:spcBef>
-              <a:defRPr sz="1150">
-                <a:solidFill>
-                  <a:srgbClr val="F8FAFC"/>
-                </a:solidFill>
-              </a:defRPr>
-            </a:pPr>
-            <a:r>
-              <a:t>• Grade E (300-549 | PD &gt; 15.0%): 9.4% share. Systematic Policy Decline.</a:t>
-            </a:r>
-          </a:p>
-        </p:txBody>
-      </p:sp>
-      <p:pic>
-        <p:nvPicPr>
-          <p:cNvPr id="6" name="Picture 5" descr="chart_grade_distribution.png"/>
-          <p:cNvPicPr>
-            <a:picLocks noChangeAspect="1"/>
-          </p:cNvPicPr>
+              <a:t>P01 to P06 Models</a:t>
+            </a:r>
+          </a:p>
+          <a:p>
+            <a:pPr>
+              <a:spcBef>
+                <a:spcPts val="500"/>
+              </a:spcBef>
+              <a:defRPr sz="1150">
+                <a:solidFill>
+                  <a:srgbClr val="F8FAFC"/>
+                </a:solidFill>
+              </a:defRPr>
+            </a:pPr>
+            <a:r>
+              <a:t>• P01 Identity Trust: Rules + Gradient Boosting (CNIC match, age integrity).</a:t>
+            </a:r>
+          </a:p>
+          <a:p>
+            <a:pPr>
+              <a:spcBef>
+                <a:spcPts val="500"/>
+              </a:spcBef>
+              <a:defRPr sz="1150">
+                <a:solidFill>
+                  <a:srgbClr val="F8FAFC"/>
+                </a:solidFill>
+              </a:defRPr>
+            </a:pPr>
+            <a:r>
+              <a:t>• P02 Fraud Risk: Isolation Forest + GNN + GBM (Rooted &amp; emulator knockouts).</a:t>
+            </a:r>
+          </a:p>
+          <a:p>
+            <a:pPr>
+              <a:spcBef>
+                <a:spcPts val="500"/>
+              </a:spcBef>
+              <a:defRPr sz="1150">
+                <a:solidFill>
+                  <a:srgbClr val="F8FAFC"/>
+                </a:solidFill>
+              </a:defRPr>
+            </a:pPr>
+            <a:r>
+              <a:t>• P03 Income Estimation: LightGBM Pinball Quantile Regressors (P10, P50, P90).</a:t>
+            </a:r>
+          </a:p>
+          <a:p>
+            <a:pPr>
+              <a:spcBef>
+                <a:spcPts val="500"/>
+              </a:spcBef>
+              <a:defRPr sz="1150">
+                <a:solidFill>
+                  <a:srgbClr val="F8FAFC"/>
+                </a:solidFill>
+              </a:defRPr>
+            </a:pPr>
+            <a:r>
+              <a:t>• P04 Cash Flow Health: GBM on rolling inflow/outflow liquidity volatility.</a:t>
+            </a:r>
+          </a:p>
+          <a:p>
+            <a:pPr>
+              <a:spcBef>
+                <a:spcPts val="500"/>
+              </a:spcBef>
+              <a:defRPr sz="1150">
+                <a:solidFill>
+                  <a:srgbClr val="F8FAFC"/>
+                </a:solidFill>
+              </a:defRPr>
+            </a:pPr>
+            <a:r>
+              <a:t>• P05 Affordability: SBP FOIR &lt;= 45% statutory ceiling + disposable margin.</a:t>
+            </a:r>
+          </a:p>
+          <a:p>
+            <a:pPr>
+              <a:spcBef>
+                <a:spcPts val="500"/>
+              </a:spcBef>
+              <a:defRPr sz="1150">
+                <a:solidFill>
+                  <a:srgbClr val="F8FAFC"/>
+                </a:solidFill>
+              </a:defRPr>
+            </a:pPr>
+            <a:r>
+              <a:t>• P06 Stability: GBM on employment duration &amp; residential persistence.</a:t>
+            </a:r>
+          </a:p>
+        </p:txBody>
+      </p:sp>
+      <p:sp>
+        <p:nvSpPr>
+          <p:cNvPr id="6" name="Rounded Rectangle 5"/>
+          <p:cNvSpPr/>
           <p:nvPr/>
-        </p:nvPicPr>
-        <p:blipFill>
-          <a:blip r:embed="rId2"/>
-          <a:stretch>
-            <a:fillRect/>
-          </a:stretch>
-        </p:blipFill>
-        <p:spPr>
-          <a:xfrm>
-            <a:off x="5760720" y="1645920"/>
-            <a:ext cx="5669280" cy="4754880"/>
+        </p:nvSpPr>
+        <p:spPr>
+          <a:xfrm>
+            <a:off x="6217920" y="1645920"/>
+            <a:ext cx="5120640" cy="4754880"/>
+          </a:xfrm>
+          <a:prstGeom prst="roundRect">
+            <a:avLst/>
+          </a:prstGeom>
+          <a:solidFill>
+            <a:srgbClr val="131E36"/>
+          </a:solidFill>
+          <a:ln w="19050">
+            <a:solidFill>
+              <a:srgbClr val="38BDF8"/>
+            </a:solidFill>
+          </a:ln>
+        </p:spPr>
+        <p:style>
+          <a:lnRef idx="1">
+            <a:schemeClr val="accent1"/>
+          </a:lnRef>
+          <a:fillRef idx="3">
+            <a:schemeClr val="accent1"/>
+          </a:fillRef>
+          <a:effectRef idx="2">
+            <a:schemeClr val="accent1"/>
+          </a:effectRef>
+          <a:fontRef idx="minor">
+            <a:schemeClr val="lt1"/>
+          </a:fontRef>
+        </p:style>
+        <p:txBody>
+          <a:bodyPr rtlCol="0" anchor="ctr"/>
+          <a:lstStyle/>
+          <a:p>
+            <a:pPr algn="ctr"/>
+          </a:p>
+        </p:txBody>
+      </p:sp>
+      <p:sp>
+        <p:nvSpPr>
+          <p:cNvPr id="7" name="TextBox 6"/>
+          <p:cNvSpPr txBox="1"/>
+          <p:nvPr/>
+        </p:nvSpPr>
+        <p:spPr>
+          <a:xfrm>
+            <a:off x="6400800" y="1828800"/>
+            <a:ext cx="4754879" cy="4389120"/>
           </a:xfrm>
           <a:prstGeom prst="rect">
             <a:avLst/>
           </a:prstGeom>
-        </p:spPr>
-      </p:pic>
+          <a:noFill/>
+        </p:spPr>
+        <p:txBody>
+          <a:bodyPr wrap="square">
+            <a:spAutoFit/>
+          </a:bodyPr>
+          <a:lstStyle/>
+          <a:p>
+            <a:pPr>
+              <a:defRPr sz="1600" b="1">
+                <a:solidFill>
+                  <a:srgbClr val="FBBF24"/>
+                </a:solidFill>
+              </a:defRPr>
+            </a:pPr>
+            <a:r>
+              <a:t>P07 to P12 Models</a:t>
+            </a:r>
+          </a:p>
+          <a:p>
+            <a:pPr>
+              <a:spcBef>
+                <a:spcPts val="500"/>
+              </a:spcBef>
+              <a:defRPr sz="1150">
+                <a:solidFill>
+                  <a:srgbClr val="F8FAFC"/>
+                </a:solidFill>
+              </a:defRPr>
+            </a:pPr>
+            <a:r>
+              <a:t>• P07 Behavioral Risk: GRU Keystroke Sequence + Hesitation Score GBM.</a:t>
+            </a:r>
+          </a:p>
+          <a:p>
+            <a:pPr>
+              <a:spcBef>
+                <a:spcPts val="500"/>
+              </a:spcBef>
+              <a:defRPr sz="1150">
+                <a:solidFill>
+                  <a:srgbClr val="F8FAFC"/>
+                </a:solidFill>
+              </a:defRPr>
+            </a:pPr>
+            <a:r>
+              <a:t>• P08 Digital Footprint: Alternative Telco SIM age &amp; digital maturity GBM.</a:t>
+            </a:r>
+          </a:p>
+          <a:p>
+            <a:pPr>
+              <a:spcBef>
+                <a:spcPts val="500"/>
+              </a:spcBef>
+              <a:defRPr sz="1150">
+                <a:solidFill>
+                  <a:srgbClr val="F8FAFC"/>
+                </a:solidFill>
+              </a:defRPr>
+            </a:pPr>
+            <a:r>
+              <a:t>• P09 Bureau Proxy: Weight of Evidence (WoE) Scorecard + Cross-Inquiry GBM.</a:t>
+            </a:r>
+          </a:p>
+          <a:p>
+            <a:pPr>
+              <a:spcBef>
+                <a:spcPts val="500"/>
+              </a:spcBef>
+              <a:defRPr sz="1150">
+                <a:solidFill>
+                  <a:srgbClr val="F8FAFC"/>
+                </a:solidFill>
+              </a:defRPr>
+            </a:pPr>
+            <a:r>
+              <a:t>• P10 Relationship &amp; Loyalty: Survival Analysis (Cox Hazards) + Clean Cycles.</a:t>
+            </a:r>
+          </a:p>
+          <a:p>
+            <a:pPr>
+              <a:spcBef>
+                <a:spcPts val="500"/>
+              </a:spcBef>
+              <a:defRPr sz="1150">
+                <a:solidFill>
+                  <a:srgbClr val="F8FAFC"/>
+                </a:solidFill>
+              </a:defRPr>
+            </a:pPr>
+            <a:r>
+              <a:t>• P11 Collection Risk: Markov Chain Roll-Rate Matrix (30-&gt;60-&gt;90 DPD Cure).</a:t>
+            </a:r>
+          </a:p>
+          <a:p>
+            <a:pPr>
+              <a:spcBef>
+                <a:spcPts val="500"/>
+              </a:spcBef>
+              <a:defRPr sz="1150">
+                <a:solidFill>
+                  <a:srgbClr val="F8FAFC"/>
+                </a:solidFill>
+              </a:defRPr>
+            </a:pPr>
+            <a:r>
+              <a:t>• P12 Statutory Compliance: Deterministic AML / PEP / NACTA Sanction Rules.</a:t>
+            </a:r>
+          </a:p>
+        </p:txBody>
+      </p:sp>
     </p:spTree>
   </p:cSld>
   <p:clrMapOvr>
@@ -7611,7 +8479,7 @@
               </a:defRPr>
             </a:pPr>
             <a:r>
-              <a:t>4-Bound Multi-Constraint Limit Engine</a:t>
+              <a:t>Meta-Stacking Ensemble Performance &amp; ROC Curves</a:t>
             </a:r>
           </a:p>
           <a:p>
@@ -7626,7 +8494,7 @@
               </a:defRPr>
             </a:pPr>
             <a:r>
-              <a:t>Mathematical Capital Preservation Guarantee (min(B1, B2, B3, B4))</a:t>
+              <a:t>Level-0 Model Diversity Synthesized into a Monotonically Constrained Meta-Learner</a:t>
             </a:r>
           </a:p>
         </p:txBody>
@@ -7640,7 +8508,7 @@
         <p:spPr>
           <a:xfrm>
             <a:off x="731520" y="1645920"/>
-            <a:ext cx="5120640" cy="4754880"/>
+            <a:ext cx="4754880" cy="4754880"/>
           </a:xfrm>
           <a:prstGeom prst="roundRect">
             <a:avLst/>
@@ -7650,7 +8518,7 @@
           </a:solidFill>
           <a:ln w="19050">
             <a:solidFill>
-              <a:srgbClr val="34D399"/>
+              <a:srgbClr val="38BDF8"/>
             </a:solidFill>
           </a:ln>
         </p:spPr>
@@ -7685,7 +8553,7 @@
         <p:spPr>
           <a:xfrm>
             <a:off x="914400" y="1828800"/>
-            <a:ext cx="4754879" cy="4389120"/>
+            <a:ext cx="4389120" cy="4389120"/>
           </a:xfrm>
           <a:prstGeom prst="rect">
             <a:avLst/>
@@ -7706,241 +8574,110 @@
               </a:defRPr>
             </a:pPr>
             <a:r>
-              <a:t>The 4 Sizing Boundaries</a:t>
-            </a:r>
-          </a:p>
-          <a:p>
-            <a:pPr>
-              <a:spcBef>
-                <a:spcPts val="500"/>
-              </a:spcBef>
-              <a:defRPr sz="1150">
-                <a:solidFill>
-                  <a:srgbClr val="F8FAFC"/>
-                </a:solidFill>
-              </a:defRPr>
-            </a:pPr>
-            <a:r>
-              <a:t>• Bound 1 (Affordability): Max EMI based on conservative P10 income capped at FOIR &lt;= 45%.</a:t>
-            </a:r>
-          </a:p>
-          <a:p>
-            <a:pPr>
-              <a:spcBef>
-                <a:spcPts val="500"/>
-              </a:spcBef>
-              <a:defRPr sz="1150">
-                <a:solidFill>
-                  <a:srgbClr val="F8FAFC"/>
-                </a:solidFill>
-              </a:defRPr>
-            </a:pPr>
-            <a:r>
-              <a:t>• Bound 2 (Risk Cap): k(Grade) * P50 income * 12 * 0.50 (where k = 1.5 for Grade A, down to 0.0 for Grade E).</a:t>
-            </a:r>
-          </a:p>
-          <a:p>
-            <a:pPr>
-              <a:spcBef>
-                <a:spcPts val="500"/>
-              </a:spcBef>
-              <a:defRPr sz="1150">
-                <a:solidFill>
-                  <a:srgbClr val="F8FAFC"/>
-                </a:solidFill>
-              </a:defRPr>
-            </a:pPr>
-            <a:r>
-              <a:t>• Bound 3 (Policy Cap): PKR 2,000,000 fixed institutional ceiling.</a:t>
-            </a:r>
-          </a:p>
-          <a:p>
-            <a:pPr>
-              <a:spcBef>
-                <a:spcPts val="500"/>
-              </a:spcBef>
-              <a:defRPr sz="1150">
-                <a:solidFill>
-                  <a:srgbClr val="F8FAFC"/>
-                </a:solidFill>
-              </a:defRPr>
-            </a:pPr>
-            <a:r>
-              <a:t>• Bound 4 (Progression): PKR 50,000 * 1.5^(min(Clean Cycles, 6)). Anti-Bust-Out step-up ladder.</a:t>
-            </a:r>
-          </a:p>
-          <a:p>
-            <a:pPr>
-              <a:spcBef>
-                <a:spcPts val="500"/>
-              </a:spcBef>
-              <a:defRPr sz="1150">
-                <a:solidFill>
-                  <a:srgbClr val="F8FAFC"/>
-                </a:solidFill>
-              </a:defRPr>
-            </a:pPr>
-            <a:r>
-              <a:t>• Final Approved Limit: min(Bound 1, Bound 2, Bound 3, Bound 4).</a:t>
-            </a:r>
-          </a:p>
-        </p:txBody>
-      </p:sp>
-      <p:sp>
-        <p:nvSpPr>
-          <p:cNvPr id="6" name="Rounded Rectangle 5"/>
-          <p:cNvSpPr/>
+              <a:t>Model Validation &amp; Discrimination</a:t>
+            </a:r>
+          </a:p>
+          <a:p>
+            <a:pPr>
+              <a:spcBef>
+                <a:spcPts val="500"/>
+              </a:spcBef>
+              <a:defRPr sz="1150">
+                <a:solidFill>
+                  <a:srgbClr val="F8FAFC"/>
+                </a:solidFill>
+              </a:defRPr>
+            </a:pPr>
+            <a:r>
+              <a:t>• Level-0 Diversity: Logistic Regression, LightGBM, and XGBoost.</a:t>
+            </a:r>
+          </a:p>
+          <a:p>
+            <a:pPr>
+              <a:spcBef>
+                <a:spcPts val="500"/>
+              </a:spcBef>
+              <a:defRPr sz="1150">
+                <a:solidFill>
+                  <a:srgbClr val="F8FAFC"/>
+                </a:solidFill>
+              </a:defRPr>
+            </a:pPr>
+            <a:r>
+              <a:t>• Constrained Meta-Learner: Enforces monotonic penalties (mono_constraints = -1).</a:t>
+            </a:r>
+          </a:p>
+          <a:p>
+            <a:pPr>
+              <a:spcBef>
+                <a:spcPts val="500"/>
+              </a:spcBef>
+              <a:defRPr sz="1150">
+                <a:solidFill>
+                  <a:srgbClr val="F8FAFC"/>
+                </a:solidFill>
+              </a:defRPr>
+            </a:pPr>
+            <a:r>
+              <a:t>• Discriminatory Power: Meta-Stacking achieves AUC-ROC = 0.892 and Gini = 0.784.</a:t>
+            </a:r>
+          </a:p>
+          <a:p>
+            <a:pPr>
+              <a:spcBef>
+                <a:spcPts val="500"/>
+              </a:spcBef>
+              <a:defRPr sz="1150">
+                <a:solidFill>
+                  <a:srgbClr val="F8FAFC"/>
+                </a:solidFill>
+              </a:defRPr>
+            </a:pPr>
+            <a:r>
+              <a:t>• Substantial Uplift: Outperforms standalone LightGBM (0.865) and XGBoost (0.854).</a:t>
+            </a:r>
+          </a:p>
+          <a:p>
+            <a:pPr>
+              <a:spcBef>
+                <a:spcPts val="500"/>
+              </a:spcBef>
+              <a:defRPr sz="1150">
+                <a:solidFill>
+                  <a:srgbClr val="F8FAFC"/>
+                </a:solidFill>
+              </a:defRPr>
+            </a:pPr>
+            <a:r>
+              <a:t>• Probability Calibration: Brier score = 0.042 ensuring un-skewed 12-month PD.</a:t>
+            </a:r>
+          </a:p>
+        </p:txBody>
+      </p:sp>
+      <p:pic>
+        <p:nvPicPr>
+          <p:cNvPr id="6" name="Picture 5" descr="chart_roc_curve.png"/>
+          <p:cNvPicPr>
+            <a:picLocks noChangeAspect="1"/>
+          </p:cNvPicPr>
           <p:nvPr/>
-        </p:nvSpPr>
-        <p:spPr>
-          <a:xfrm>
-            <a:off x="6217920" y="1645920"/>
-            <a:ext cx="5120640" cy="4754880"/>
-          </a:xfrm>
-          <a:prstGeom prst="roundRect">
-            <a:avLst/>
-          </a:prstGeom>
-          <a:solidFill>
-            <a:srgbClr val="131E36"/>
-          </a:solidFill>
-          <a:ln w="19050">
-            <a:solidFill>
-              <a:srgbClr val="FBBF24"/>
-            </a:solidFill>
-          </a:ln>
-        </p:spPr>
-        <p:style>
-          <a:lnRef idx="1">
-            <a:schemeClr val="accent1"/>
-          </a:lnRef>
-          <a:fillRef idx="3">
-            <a:schemeClr val="accent1"/>
-          </a:fillRef>
-          <a:effectRef idx="2">
-            <a:schemeClr val="accent1"/>
-          </a:effectRef>
-          <a:fontRef idx="minor">
-            <a:schemeClr val="lt1"/>
-          </a:fontRef>
-        </p:style>
-        <p:txBody>
-          <a:bodyPr rtlCol="0" anchor="ctr"/>
-          <a:lstStyle/>
-          <a:p>
-            <a:pPr algn="ctr"/>
-          </a:p>
-        </p:txBody>
-      </p:sp>
-      <p:sp>
-        <p:nvSpPr>
-          <p:cNvPr id="7" name="TextBox 6"/>
-          <p:cNvSpPr txBox="1"/>
-          <p:nvPr/>
-        </p:nvSpPr>
-        <p:spPr>
-          <a:xfrm>
-            <a:off x="6400800" y="1828800"/>
-            <a:ext cx="4754879" cy="4389120"/>
+        </p:nvPicPr>
+        <p:blipFill>
+          <a:blip r:embed="rId2"/>
+          <a:stretch>
+            <a:fillRect/>
+          </a:stretch>
+        </p:blipFill>
+        <p:spPr>
+          <a:xfrm>
+            <a:off x="5760720" y="1645920"/>
+            <a:ext cx="5669280" cy="4754880"/>
           </a:xfrm>
           <a:prstGeom prst="rect">
             <a:avLst/>
           </a:prstGeom>
-          <a:noFill/>
-        </p:spPr>
-        <p:txBody>
-          <a:bodyPr wrap="square">
-            <a:spAutoFit/>
-          </a:bodyPr>
-          <a:lstStyle/>
-          <a:p>
-            <a:pPr>
-              <a:defRPr sz="1600" b="1">
-                <a:solidFill>
-                  <a:srgbClr val="FBBF24"/>
-                </a:solidFill>
-              </a:defRPr>
-            </a:pPr>
-            <a:r>
-              <a:t>Regulatory APR &amp; Pricing Engine</a:t>
-            </a:r>
-          </a:p>
-          <a:p>
-            <a:pPr>
-              <a:spcBef>
-                <a:spcPts val="500"/>
-              </a:spcBef>
-              <a:defRPr sz="1150">
-                <a:solidFill>
-                  <a:srgbClr val="F8FAFC"/>
-                </a:solidFill>
-              </a:defRPr>
-            </a:pPr>
-            <a:r>
-              <a:t>• SBP Usury Cap: Hard statutory ceiling at 36.0% per annum.</a:t>
-            </a:r>
-          </a:p>
-          <a:p>
-            <a:pPr>
-              <a:spcBef>
-                <a:spcPts val="500"/>
-              </a:spcBef>
-              <a:defRPr sz="1150">
-                <a:solidFill>
-                  <a:srgbClr val="F8FAFC"/>
-                </a:solidFill>
-              </a:defRPr>
-            </a:pPr>
-            <a:r>
-              <a:t>• Risk-Based Spread: Base KIBOR (18.5%) + Grade Risk Spread (4% to 16%).</a:t>
-            </a:r>
-          </a:p>
-          <a:p>
-            <a:pPr>
-              <a:spcBef>
-                <a:spcPts val="500"/>
-              </a:spcBef>
-              <a:defRPr sz="1150">
-                <a:solidFill>
-                  <a:srgbClr val="F8FAFC"/>
-                </a:solidFill>
-              </a:defRPr>
-            </a:pPr>
-            <a:r>
-              <a:t>• Grade A APR: 22.5% (Lowest interest rate, highest credit limit).</a:t>
-            </a:r>
-          </a:p>
-          <a:p>
-            <a:pPr>
-              <a:spcBef>
-                <a:spcPts val="500"/>
-              </a:spcBef>
-              <a:defRPr sz="1150">
-                <a:solidFill>
-                  <a:srgbClr val="F8FAFC"/>
-                </a:solidFill>
-              </a:defRPr>
-            </a:pPr>
-            <a:r>
-              <a:t>• Grade D APR: 34.5% (Compensates for elevated risk).</a:t>
-            </a:r>
-          </a:p>
-          <a:p>
-            <a:pPr>
-              <a:spcBef>
-                <a:spcPts val="500"/>
-              </a:spcBef>
-              <a:defRPr sz="1150">
-                <a:solidFill>
-                  <a:srgbClr val="F8FAFC"/>
-                </a:solidFill>
-              </a:defRPr>
-            </a:pPr>
-            <a:r>
-              <a:t>• Double-Entry Accounting: Auto-disburses to Ledger upon acceptance.</a:t>
-            </a:r>
-          </a:p>
-        </p:txBody>
-      </p:sp>
+        </p:spPr>
+      </p:pic>
     </p:spTree>
   </p:cSld>
   <p:clrMapOvr>

</xml_diff>

<commit_message>
Dedicate clean full-screen flow diagrams across 3 presentation slides without text clutter
</commit_message>
<xml_diff>
--- a/AI_Credit_Scoring_Conference_Master_Presentation.pptx
+++ b/AI_Credit_Scoring_Conference_Master_Presentation.pptx
@@ -3154,8 +3154,8 @@
         </p:nvSpPr>
         <p:spPr>
           <a:xfrm>
-            <a:off x="731520" y="365760"/>
-            <a:ext cx="10698480" cy="1005840"/>
+            <a:off x="731520" y="274320"/>
+            <a:ext cx="10698480" cy="822960"/>
           </a:xfrm>
           <a:prstGeom prst="rect">
             <a:avLst/>
@@ -3169,7 +3169,7 @@
           <a:lstStyle/>
           <a:p>
             <a:pPr>
-              <a:defRPr sz="2600" b="1">
+              <a:defRPr sz="2400" b="1">
                 <a:solidFill>
                   <a:srgbClr val="38BDF8"/>
                 </a:solidFill>
@@ -3182,9 +3182,9 @@
           <a:p>
             <a:pPr>
               <a:spcBef>
-                <a:spcPts val="400"/>
-              </a:spcBef>
-              <a:defRPr sz="1300">
+                <a:spcPts val="300"/>
+              </a:spcBef>
+              <a:defRPr sz="1200">
                 <a:solidFill>
                   <a:srgbClr val="94A3B8"/>
                 </a:solidFill>
@@ -3330,8 +3330,8 @@
         </p:nvSpPr>
         <p:spPr>
           <a:xfrm>
-            <a:off x="731520" y="365760"/>
-            <a:ext cx="10698480" cy="1005840"/>
+            <a:off x="731520" y="274320"/>
+            <a:ext cx="10698480" cy="822960"/>
           </a:xfrm>
           <a:prstGeom prst="rect">
             <a:avLst/>
@@ -3345,7 +3345,7 @@
           <a:lstStyle/>
           <a:p>
             <a:pPr>
-              <a:defRPr sz="2600" b="1">
+              <a:defRPr sz="2400" b="1">
                 <a:solidFill>
                   <a:srgbClr val="38BDF8"/>
                 </a:solidFill>
@@ -3358,9 +3358,9 @@
           <a:p>
             <a:pPr>
               <a:spcBef>
-                <a:spcPts val="400"/>
-              </a:spcBef>
-              <a:defRPr sz="1300">
+                <a:spcPts val="300"/>
+              </a:spcBef>
+              <a:defRPr sz="1200">
                 <a:solidFill>
                   <a:srgbClr val="94A3B8"/>
                 </a:solidFill>
@@ -3620,8 +3620,8 @@
         </p:nvSpPr>
         <p:spPr>
           <a:xfrm>
-            <a:off x="731520" y="365760"/>
-            <a:ext cx="10698480" cy="1005840"/>
+            <a:off x="731520" y="274320"/>
+            <a:ext cx="10698480" cy="822960"/>
           </a:xfrm>
           <a:prstGeom prst="rect">
             <a:avLst/>
@@ -3635,7 +3635,7 @@
           <a:lstStyle/>
           <a:p>
             <a:pPr>
-              <a:defRPr sz="2600" b="1">
+              <a:defRPr sz="2400" b="1">
                 <a:solidFill>
                   <a:srgbClr val="38BDF8"/>
                 </a:solidFill>
@@ -3648,9 +3648,9 @@
           <a:p>
             <a:pPr>
               <a:spcBef>
-                <a:spcPts val="400"/>
-              </a:spcBef>
-              <a:defRPr sz="1300">
+                <a:spcPts val="300"/>
+              </a:spcBef>
+              <a:defRPr sz="1200">
                 <a:solidFill>
                   <a:srgbClr val="94A3B8"/>
                 </a:solidFill>
@@ -4041,8 +4041,8 @@
         </p:nvSpPr>
         <p:spPr>
           <a:xfrm>
-            <a:off x="731520" y="365760"/>
-            <a:ext cx="10698480" cy="1005840"/>
+            <a:off x="731520" y="274320"/>
+            <a:ext cx="10698480" cy="822960"/>
           </a:xfrm>
           <a:prstGeom prst="rect">
             <a:avLst/>
@@ -4056,7 +4056,7 @@
           <a:lstStyle/>
           <a:p>
             <a:pPr>
-              <a:defRPr sz="2600" b="1">
+              <a:defRPr sz="2400" b="1">
                 <a:solidFill>
                   <a:srgbClr val="38BDF8"/>
                 </a:solidFill>
@@ -4069,9 +4069,9 @@
           <a:p>
             <a:pPr>
               <a:spcBef>
-                <a:spcPts val="400"/>
-              </a:spcBef>
-              <a:defRPr sz="1300">
+                <a:spcPts val="300"/>
+              </a:spcBef>
+              <a:defRPr sz="1200">
                 <a:solidFill>
                   <a:srgbClr val="94A3B8"/>
                 </a:solidFill>
@@ -4331,8 +4331,8 @@
         </p:nvSpPr>
         <p:spPr>
           <a:xfrm>
-            <a:off x="731520" y="365760"/>
-            <a:ext cx="10698480" cy="1005840"/>
+            <a:off x="731520" y="274320"/>
+            <a:ext cx="10698480" cy="822960"/>
           </a:xfrm>
           <a:prstGeom prst="rect">
             <a:avLst/>
@@ -4346,7 +4346,7 @@
           <a:lstStyle/>
           <a:p>
             <a:pPr>
-              <a:defRPr sz="2600" b="1">
+              <a:defRPr sz="2400" b="1">
                 <a:solidFill>
                   <a:srgbClr val="38BDF8"/>
                 </a:solidFill>
@@ -4359,9 +4359,9 @@
           <a:p>
             <a:pPr>
               <a:spcBef>
-                <a:spcPts val="400"/>
-              </a:spcBef>
-              <a:defRPr sz="1300">
+                <a:spcPts val="300"/>
+              </a:spcBef>
+              <a:defRPr sz="1200">
                 <a:solidFill>
                   <a:srgbClr val="94A3B8"/>
                 </a:solidFill>
@@ -4621,8 +4621,8 @@
         </p:nvSpPr>
         <p:spPr>
           <a:xfrm>
-            <a:off x="731520" y="365760"/>
-            <a:ext cx="10698480" cy="1005840"/>
+            <a:off x="731520" y="274320"/>
+            <a:ext cx="10698480" cy="822960"/>
           </a:xfrm>
           <a:prstGeom prst="rect">
             <a:avLst/>
@@ -4636,7 +4636,7 @@
           <a:lstStyle/>
           <a:p>
             <a:pPr>
-              <a:defRPr sz="2600" b="1">
+              <a:defRPr sz="2400" b="1">
                 <a:solidFill>
                   <a:srgbClr val="38BDF8"/>
                 </a:solidFill>
@@ -4649,9 +4649,9 @@
           <a:p>
             <a:pPr>
               <a:spcBef>
-                <a:spcPts val="400"/>
-              </a:spcBef>
-              <a:defRPr sz="1300">
+                <a:spcPts val="300"/>
+              </a:spcBef>
+              <a:defRPr sz="1200">
                 <a:solidFill>
                   <a:srgbClr val="94A3B8"/>
                 </a:solidFill>
@@ -5042,8 +5042,8 @@
         </p:nvSpPr>
         <p:spPr>
           <a:xfrm>
-            <a:off x="731520" y="365760"/>
-            <a:ext cx="10698480" cy="1005840"/>
+            <a:off x="731520" y="274320"/>
+            <a:ext cx="10698480" cy="822960"/>
           </a:xfrm>
           <a:prstGeom prst="rect">
             <a:avLst/>
@@ -5057,7 +5057,7 @@
           <a:lstStyle/>
           <a:p>
             <a:pPr>
-              <a:defRPr sz="2600" b="1">
+              <a:defRPr sz="2400" b="1">
                 <a:solidFill>
                   <a:srgbClr val="38BDF8"/>
                 </a:solidFill>
@@ -5070,9 +5070,9 @@
           <a:p>
             <a:pPr>
               <a:spcBef>
-                <a:spcPts val="400"/>
-              </a:spcBef>
-              <a:defRPr sz="1300">
+                <a:spcPts val="300"/>
+              </a:spcBef>
+              <a:defRPr sz="1200">
                 <a:solidFill>
                   <a:srgbClr val="94A3B8"/>
                 </a:solidFill>
@@ -5383,8 +5383,8 @@
         </p:nvSpPr>
         <p:spPr>
           <a:xfrm>
-            <a:off x="731520" y="365760"/>
-            <a:ext cx="10698480" cy="1005840"/>
+            <a:off x="731520" y="274320"/>
+            <a:ext cx="10698480" cy="822960"/>
           </a:xfrm>
           <a:prstGeom prst="rect">
             <a:avLst/>
@@ -5398,7 +5398,7 @@
           <a:lstStyle/>
           <a:p>
             <a:pPr>
-              <a:defRPr sz="2600" b="1">
+              <a:defRPr sz="2400" b="1">
                 <a:solidFill>
                   <a:srgbClr val="38BDF8"/>
                 </a:solidFill>
@@ -5411,9 +5411,9 @@
           <a:p>
             <a:pPr>
               <a:spcBef>
-                <a:spcPts val="400"/>
-              </a:spcBef>
-              <a:defRPr sz="1300">
+                <a:spcPts val="300"/>
+              </a:spcBef>
+              <a:defRPr sz="1200">
                 <a:solidFill>
                   <a:srgbClr val="94A3B8"/>
                 </a:solidFill>
@@ -5914,8 +5914,8 @@
         </p:nvSpPr>
         <p:spPr>
           <a:xfrm>
-            <a:off x="731520" y="365760"/>
-            <a:ext cx="10698480" cy="1005840"/>
+            <a:off x="731520" y="274320"/>
+            <a:ext cx="10698480" cy="822960"/>
           </a:xfrm>
           <a:prstGeom prst="rect">
             <a:avLst/>
@@ -5929,7 +5929,7 @@
           <a:lstStyle/>
           <a:p>
             <a:pPr>
-              <a:defRPr sz="2600" b="1">
+              <a:defRPr sz="2400" b="1">
                 <a:solidFill>
                   <a:srgbClr val="38BDF8"/>
                 </a:solidFill>
@@ -5942,9 +5942,9 @@
           <a:p>
             <a:pPr>
               <a:spcBef>
-                <a:spcPts val="400"/>
-              </a:spcBef>
-              <a:defRPr sz="1300">
+                <a:spcPts val="300"/>
+              </a:spcBef>
+              <a:defRPr sz="1200">
                 <a:solidFill>
                   <a:srgbClr val="94A3B8"/>
                 </a:solidFill>
@@ -6335,8 +6335,8 @@
         </p:nvSpPr>
         <p:spPr>
           <a:xfrm>
-            <a:off x="731520" y="365760"/>
-            <a:ext cx="10698480" cy="1005840"/>
+            <a:off x="731520" y="274320"/>
+            <a:ext cx="10698480" cy="822960"/>
           </a:xfrm>
           <a:prstGeom prst="rect">
             <a:avLst/>
@@ -6350,22 +6350,22 @@
           <a:lstStyle/>
           <a:p>
             <a:pPr>
-              <a:defRPr sz="2600" b="1">
+              <a:defRPr sz="2400" b="1">
                 <a:solidFill>
                   <a:srgbClr val="38BDF8"/>
                 </a:solidFill>
               </a:defRPr>
             </a:pPr>
             <a:r>
-              <a:t>System Flow (Part 1 of 3): Channels, Gateway &amp; Orchestration</a:t>
-            </a:r>
-          </a:p>
-          <a:p>
-            <a:pPr>
-              <a:spcBef>
-                <a:spcPts val="400"/>
-              </a:spcBef>
-              <a:defRPr sz="1300">
+              <a:t>System Flow (Part 1 of 3): Channels, Gateway &amp; Orchestration Layer</a:t>
+            </a:r>
+          </a:p>
+          <a:p>
+            <a:pPr>
+              <a:spcBef>
+                <a:spcPts val="300"/>
+              </a:spcBef>
+              <a:defRPr sz="1200">
                 <a:solidFill>
                   <a:srgbClr val="94A3B8"/>
                 </a:solidFill>
@@ -6373,168 +6373,13 @@
             </a:pPr>
             <a:r>
               <a:t>Borrower Mobile PWA, Spring Cloud Gateway Edge, and Asynchronous Fan-Out Ingestion</a:t>
-            </a:r>
-          </a:p>
-        </p:txBody>
-      </p:sp>
-      <p:sp>
-        <p:nvSpPr>
-          <p:cNvPr id="4" name="Rounded Rectangle 3"/>
-          <p:cNvSpPr/>
-          <p:nvPr/>
-        </p:nvSpPr>
-        <p:spPr>
-          <a:xfrm>
-            <a:off x="731520" y="1645920"/>
-            <a:ext cx="4572000" cy="4754880"/>
-          </a:xfrm>
-          <a:prstGeom prst="roundRect">
-            <a:avLst/>
-          </a:prstGeom>
-          <a:solidFill>
-            <a:srgbClr val="131E36"/>
-          </a:solidFill>
-          <a:ln w="19050">
-            <a:solidFill>
-              <a:srgbClr val="38BDF8"/>
-            </a:solidFill>
-          </a:ln>
-        </p:spPr>
-        <p:style>
-          <a:lnRef idx="1">
-            <a:schemeClr val="accent1"/>
-          </a:lnRef>
-          <a:fillRef idx="3">
-            <a:schemeClr val="accent1"/>
-          </a:fillRef>
-          <a:effectRef idx="2">
-            <a:schemeClr val="accent1"/>
-          </a:effectRef>
-          <a:fontRef idx="minor">
-            <a:schemeClr val="lt1"/>
-          </a:fontRef>
-        </p:style>
-        <p:txBody>
-          <a:bodyPr rtlCol="0" anchor="ctr"/>
-          <a:lstStyle/>
-          <a:p>
-            <a:pPr algn="ctr"/>
-          </a:p>
-        </p:txBody>
-      </p:sp>
-      <p:sp>
-        <p:nvSpPr>
-          <p:cNvPr id="5" name="TextBox 4"/>
-          <p:cNvSpPr txBox="1"/>
-          <p:nvPr/>
-        </p:nvSpPr>
-        <p:spPr>
-          <a:xfrm>
-            <a:off x="914400" y="1828800"/>
-            <a:ext cx="4206240" cy="4389120"/>
-          </a:xfrm>
-          <a:prstGeom prst="rect">
-            <a:avLst/>
-          </a:prstGeom>
-          <a:noFill/>
-        </p:spPr>
-        <p:txBody>
-          <a:bodyPr wrap="square">
-            <a:spAutoFit/>
-          </a:bodyPr>
-          <a:lstStyle/>
-          <a:p>
-            <a:pPr>
-              <a:defRPr sz="1600" b="1">
-                <a:solidFill>
-                  <a:srgbClr val="FBBF24"/>
-                </a:solidFill>
-              </a:defRPr>
-            </a:pPr>
-            <a:r>
-              <a:t>Stage 1 Architecture Highlights</a:t>
-            </a:r>
-          </a:p>
-          <a:p>
-            <a:pPr>
-              <a:spcBef>
-                <a:spcPts val="500"/>
-              </a:spcBef>
-              <a:defRPr sz="1150">
-                <a:solidFill>
-                  <a:srgbClr val="F8FAFC"/>
-                </a:solidFill>
-              </a:defRPr>
-            </a:pPr>
-            <a:r>
-              <a:t>• Channel Ingestion: Angular Borrower PWA (&lt;3 min journey) &amp; Ops Console.</a:t>
-            </a:r>
-          </a:p>
-          <a:p>
-            <a:pPr>
-              <a:spcBef>
-                <a:spcPts val="500"/>
-              </a:spcBef>
-              <a:defRPr sz="1150">
-                <a:solidFill>
-                  <a:srgbClr val="F8FAFC"/>
-                </a:solidFill>
-              </a:defRPr>
-            </a:pPr>
-            <a:r>
-              <a:t>• Security Edge: Spring Cloud Gateway with OAuth2, JWT validation, and mTLS.</a:t>
-            </a:r>
-          </a:p>
-          <a:p>
-            <a:pPr>
-              <a:spcBef>
-                <a:spcPts val="500"/>
-              </a:spcBef>
-              <a:defRPr sz="1150">
-                <a:solidFill>
-                  <a:srgbClr val="F8FAFC"/>
-                </a:solidFill>
-              </a:defRPr>
-            </a:pPr>
-            <a:r>
-              <a:t>• Onboarding Orchestrator: Spring Boot WebFlux drives non-blocking parallel calls.</a:t>
-            </a:r>
-          </a:p>
-          <a:p>
-            <a:pPr>
-              <a:spcBef>
-                <a:spcPts val="500"/>
-              </a:spcBef>
-              <a:defRPr sz="1150">
-                <a:solidFill>
-                  <a:srgbClr val="F8FAFC"/>
-                </a:solidFill>
-              </a:defRPr>
-            </a:pPr>
-            <a:r>
-              <a:t>• Consent &amp; Privacy: Cryptographically signed borrower consent management.</a:t>
-            </a:r>
-          </a:p>
-          <a:p>
-            <a:pPr>
-              <a:spcBef>
-                <a:spcPts val="500"/>
-              </a:spcBef>
-              <a:defRPr sz="1150">
-                <a:solidFill>
-                  <a:srgbClr val="F8FAFC"/>
-                </a:solidFill>
-              </a:defRPr>
-            </a:pPr>
-            <a:r>
-              <a:t>• Data Connectors: Parallel asynchronous calls to NADRA, Telcos, and 1Link banks.</a:t>
             </a:r>
           </a:p>
         </p:txBody>
       </p:sp>
       <p:pic>
         <p:nvPicPr>
-          <p:cNvPr id="6" name="Picture 5" descr="flow_part1_channels.png"/>
+          <p:cNvPr id="4" name="Picture 3" descr="flow_part1_channels.png"/>
           <p:cNvPicPr>
             <a:picLocks noChangeAspect="1"/>
           </p:cNvPicPr>
@@ -6548,8 +6393,8 @@
         </p:blipFill>
         <p:spPr>
           <a:xfrm>
-            <a:off x="5577840" y="1645920"/>
-            <a:ext cx="5852160" cy="4754880"/>
+            <a:off x="1645920" y="1188720"/>
+            <a:ext cx="8869680" cy="5394960"/>
           </a:xfrm>
           <a:prstGeom prst="rect">
             <a:avLst/>
@@ -6625,8 +6470,8 @@
         </p:nvSpPr>
         <p:spPr>
           <a:xfrm>
-            <a:off x="731520" y="365760"/>
-            <a:ext cx="10698480" cy="1005840"/>
+            <a:off x="731520" y="274320"/>
+            <a:ext cx="10698480" cy="822960"/>
           </a:xfrm>
           <a:prstGeom prst="rect">
             <a:avLst/>
@@ -6640,191 +6485,36 @@
           <a:lstStyle/>
           <a:p>
             <a:pPr>
-              <a:defRPr sz="2600" b="1">
+              <a:defRPr sz="2400" b="1">
                 <a:solidFill>
                   <a:srgbClr val="38BDF8"/>
                 </a:solidFill>
               </a:defRPr>
             </a:pPr>
             <a:r>
-              <a:t>System Flow (Part 2 of 3): Feature Store &amp; AI Scoring Core</a:t>
-            </a:r>
-          </a:p>
-          <a:p>
-            <a:pPr>
-              <a:spcBef>
-                <a:spcPts val="400"/>
-              </a:spcBef>
-              <a:defRPr sz="1300">
+              <a:t>System Flow (Part 2 of 3): Feature Store &amp; AI Decisioning Core</a:t>
+            </a:r>
+          </a:p>
+          <a:p>
+            <a:pPr>
+              <a:spcBef>
+                <a:spcPts val="300"/>
+              </a:spcBef>
+              <a:defRPr sz="1200">
                 <a:solidFill>
                   <a:srgbClr val="94A3B8"/>
                 </a:solidFill>
               </a:defRPr>
             </a:pPr>
             <a:r>
-              <a:t>Point-in-Time Correctness, Redis Online Features, and 12 Sub-Pillar Execution</a:t>
-            </a:r>
-          </a:p>
-        </p:txBody>
-      </p:sp>
-      <p:sp>
-        <p:nvSpPr>
-          <p:cNvPr id="4" name="Rounded Rectangle 3"/>
-          <p:cNvSpPr/>
-          <p:nvPr/>
-        </p:nvSpPr>
-        <p:spPr>
-          <a:xfrm>
-            <a:off x="731520" y="1645920"/>
-            <a:ext cx="4572000" cy="4754880"/>
-          </a:xfrm>
-          <a:prstGeom prst="roundRect">
-            <a:avLst/>
-          </a:prstGeom>
-          <a:solidFill>
-            <a:srgbClr val="131E36"/>
-          </a:solidFill>
-          <a:ln w="19050">
-            <a:solidFill>
-              <a:srgbClr val="FBBF24"/>
-            </a:solidFill>
-          </a:ln>
-        </p:spPr>
-        <p:style>
-          <a:lnRef idx="1">
-            <a:schemeClr val="accent1"/>
-          </a:lnRef>
-          <a:fillRef idx="3">
-            <a:schemeClr val="accent1"/>
-          </a:fillRef>
-          <a:effectRef idx="2">
-            <a:schemeClr val="accent1"/>
-          </a:effectRef>
-          <a:fontRef idx="minor">
-            <a:schemeClr val="lt1"/>
-          </a:fontRef>
-        </p:style>
-        <p:txBody>
-          <a:bodyPr rtlCol="0" anchor="ctr"/>
-          <a:lstStyle/>
-          <a:p>
-            <a:pPr algn="ctr"/>
-          </a:p>
-        </p:txBody>
-      </p:sp>
-      <p:sp>
-        <p:nvSpPr>
-          <p:cNvPr id="5" name="TextBox 4"/>
-          <p:cNvSpPr txBox="1"/>
-          <p:nvPr/>
-        </p:nvSpPr>
-        <p:spPr>
-          <a:xfrm>
-            <a:off x="914400" y="1828800"/>
-            <a:ext cx="4206240" cy="4389120"/>
-          </a:xfrm>
-          <a:prstGeom prst="rect">
-            <a:avLst/>
-          </a:prstGeom>
-          <a:noFill/>
-        </p:spPr>
-        <p:txBody>
-          <a:bodyPr wrap="square">
-            <a:spAutoFit/>
-          </a:bodyPr>
-          <a:lstStyle/>
-          <a:p>
-            <a:pPr>
-              <a:defRPr sz="1600" b="1">
-                <a:solidFill>
-                  <a:srgbClr val="FBBF24"/>
-                </a:solidFill>
-              </a:defRPr>
-            </a:pPr>
-            <a:r>
-              <a:t>Stage 2 Architecture Highlights</a:t>
-            </a:r>
-          </a:p>
-          <a:p>
-            <a:pPr>
-              <a:spcBef>
-                <a:spcPts val="500"/>
-              </a:spcBef>
-              <a:defRPr sz="1150">
-                <a:solidFill>
-                  <a:srgbClr val="F8FAFC"/>
-                </a:solidFill>
-              </a:defRPr>
-            </a:pPr>
-            <a:r>
-              <a:t>• Feature Store: Redis for sub-10ms online retrieval + Parquet for offline training.</a:t>
-            </a:r>
-          </a:p>
-          <a:p>
-            <a:pPr>
-              <a:spcBef>
-                <a:spcPts val="500"/>
-              </a:spcBef>
-              <a:defRPr sz="1150">
-                <a:solidFill>
-                  <a:srgbClr val="F8FAFC"/>
-                </a:solidFill>
-              </a:defRPr>
-            </a:pPr>
-            <a:r>
-              <a:t>• Feature Hydration: Entity alignment joins 27 signals without data leakage.</a:t>
-            </a:r>
-          </a:p>
-          <a:p>
-            <a:pPr>
-              <a:spcBef>
-                <a:spcPts val="500"/>
-              </a:spcBef>
-              <a:defRPr sz="1150">
-                <a:solidFill>
-                  <a:srgbClr val="F8FAFC"/>
-                </a:solidFill>
-              </a:defRPr>
-            </a:pPr>
-            <a:r>
-              <a:t>• Scoring Core: 12 domain sub-pillars execute in parallel (Identity, Fraud, Cash Flow).</a:t>
-            </a:r>
-          </a:p>
-          <a:p>
-            <a:pPr>
-              <a:spcBef>
-                <a:spcPts val="500"/>
-              </a:spcBef>
-              <a:defRPr sz="1150">
-                <a:solidFill>
-                  <a:srgbClr val="F8FAFC"/>
-                </a:solidFill>
-              </a:defRPr>
-            </a:pPr>
-            <a:r>
-              <a:t>• Quantile Income Engine: Machine-learned P10, P50, and P90 income quantiles.</a:t>
-            </a:r>
-          </a:p>
-          <a:p>
-            <a:pPr>
-              <a:spcBef>
-                <a:spcPts val="500"/>
-              </a:spcBef>
-              <a:defRPr sz="1150">
-                <a:solidFill>
-                  <a:srgbClr val="F8FAFC"/>
-                </a:solidFill>
-              </a:defRPr>
-            </a:pPr>
-            <a:r>
-              <a:t>• Meta-Stacking: Logistic + LightGBM + XGBoost outputs calibrated 12-month PD.</a:t>
+              <a:t>Point-in-Time Correctness, Redis Online Features, 12 Sub-Pillars &amp; Stacking Ensemble</a:t>
             </a:r>
           </a:p>
         </p:txBody>
       </p:sp>
       <p:pic>
         <p:nvPicPr>
-          <p:cNvPr id="6" name="Picture 5" descr="flow_part2_decisioning.png"/>
+          <p:cNvPr id="4" name="Picture 3" descr="flow_part2_decisioning.png"/>
           <p:cNvPicPr>
             <a:picLocks noChangeAspect="1"/>
           </p:cNvPicPr>
@@ -6838,8 +6528,8 @@
         </p:blipFill>
         <p:spPr>
           <a:xfrm>
-            <a:off x="5577840" y="1645920"/>
-            <a:ext cx="5852160" cy="4754880"/>
+            <a:off x="1645920" y="1188720"/>
+            <a:ext cx="8869680" cy="5394960"/>
           </a:xfrm>
           <a:prstGeom prst="rect">
             <a:avLst/>
@@ -6915,8 +6605,8 @@
         </p:nvSpPr>
         <p:spPr>
           <a:xfrm>
-            <a:off x="731520" y="365760"/>
-            <a:ext cx="10698480" cy="1005840"/>
+            <a:off x="731520" y="274320"/>
+            <a:ext cx="10698480" cy="822960"/>
           </a:xfrm>
           <a:prstGeom prst="rect">
             <a:avLst/>
@@ -6930,191 +6620,36 @@
           <a:lstStyle/>
           <a:p>
             <a:pPr>
-              <a:defRPr sz="2600" b="1">
+              <a:defRPr sz="2400" b="1">
                 <a:solidFill>
                   <a:srgbClr val="38BDF8"/>
                 </a:solidFill>
               </a:defRPr>
             </a:pPr>
             <a:r>
-              <a:t>System Flow (Part 3 of 3): Limit Policy &amp; Core Ledger</a:t>
-            </a:r>
-          </a:p>
-          <a:p>
-            <a:pPr>
-              <a:spcBef>
-                <a:spcPts val="400"/>
-              </a:spcBef>
-              <a:defRPr sz="1300">
+              <a:t>System Flow (Part 3 of 3): Limit Policy, LMS Core &amp; Ledger Accounting</a:t>
+            </a:r>
+          </a:p>
+          <a:p>
+            <a:pPr>
+              <a:spcBef>
+                <a:spcPts val="300"/>
+              </a:spcBef>
+              <a:defRPr sz="1200">
                 <a:solidFill>
                   <a:srgbClr val="94A3B8"/>
                 </a:solidFill>
               </a:defRPr>
             </a:pPr>
             <a:r>
-              <a:t>4-Bound Constraint Sizing, TreeSHAP Explainability, and Double-Entry LMS Posting</a:t>
-            </a:r>
-          </a:p>
-        </p:txBody>
-      </p:sp>
-      <p:sp>
-        <p:nvSpPr>
-          <p:cNvPr id="4" name="Rounded Rectangle 3"/>
-          <p:cNvSpPr/>
-          <p:nvPr/>
-        </p:nvSpPr>
-        <p:spPr>
-          <a:xfrm>
-            <a:off x="731520" y="1645920"/>
-            <a:ext cx="4572000" cy="4754880"/>
-          </a:xfrm>
-          <a:prstGeom prst="roundRect">
-            <a:avLst/>
-          </a:prstGeom>
-          <a:solidFill>
-            <a:srgbClr val="131E36"/>
-          </a:solidFill>
-          <a:ln w="19050">
-            <a:solidFill>
-              <a:srgbClr val="34D399"/>
-            </a:solidFill>
-          </a:ln>
-        </p:spPr>
-        <p:style>
-          <a:lnRef idx="1">
-            <a:schemeClr val="accent1"/>
-          </a:lnRef>
-          <a:fillRef idx="3">
-            <a:schemeClr val="accent1"/>
-          </a:fillRef>
-          <a:effectRef idx="2">
-            <a:schemeClr val="accent1"/>
-          </a:effectRef>
-          <a:fontRef idx="minor">
-            <a:schemeClr val="lt1"/>
-          </a:fontRef>
-        </p:style>
-        <p:txBody>
-          <a:bodyPr rtlCol="0" anchor="ctr"/>
-          <a:lstStyle/>
-          <a:p>
-            <a:pPr algn="ctr"/>
-          </a:p>
-        </p:txBody>
-      </p:sp>
-      <p:sp>
-        <p:nvSpPr>
-          <p:cNvPr id="5" name="TextBox 4"/>
-          <p:cNvSpPr txBox="1"/>
-          <p:nvPr/>
-        </p:nvSpPr>
-        <p:spPr>
-          <a:xfrm>
-            <a:off x="914400" y="1828800"/>
-            <a:ext cx="4206240" cy="4389120"/>
-          </a:xfrm>
-          <a:prstGeom prst="rect">
-            <a:avLst/>
-          </a:prstGeom>
-          <a:noFill/>
-        </p:spPr>
-        <p:txBody>
-          <a:bodyPr wrap="square">
-            <a:spAutoFit/>
-          </a:bodyPr>
-          <a:lstStyle/>
-          <a:p>
-            <a:pPr>
-              <a:defRPr sz="1600" b="1">
-                <a:solidFill>
-                  <a:srgbClr val="FBBF24"/>
-                </a:solidFill>
-              </a:defRPr>
-            </a:pPr>
-            <a:r>
-              <a:t>Stage 3 Architecture Highlights</a:t>
-            </a:r>
-          </a:p>
-          <a:p>
-            <a:pPr>
-              <a:spcBef>
-                <a:spcPts val="500"/>
-              </a:spcBef>
-              <a:defRPr sz="1150">
-                <a:solidFill>
-                  <a:srgbClr val="F8FAFC"/>
-                </a:solidFill>
-              </a:defRPr>
-            </a:pPr>
-            <a:r>
-              <a:t>• Policy Engine: min(Affordability, Risk Cap, Policy Cap, Clean Cycles Ladder).</a:t>
-            </a:r>
-          </a:p>
-          <a:p>
-            <a:pPr>
-              <a:spcBef>
-                <a:spcPts val="500"/>
-              </a:spcBef>
-              <a:defRPr sz="1150">
-                <a:solidFill>
-                  <a:srgbClr val="F8FAFC"/>
-                </a:solidFill>
-              </a:defRPr>
-            </a:pPr>
-            <a:r>
-              <a:t>• Regulatory APR: Capped at 36.0% statutory ceiling (KIBOR + Grade Risk Spread).</a:t>
-            </a:r>
-          </a:p>
-          <a:p>
-            <a:pPr>
-              <a:spcBef>
-                <a:spcPts val="500"/>
-              </a:spcBef>
-              <a:defRPr sz="1150">
-                <a:solidFill>
-                  <a:srgbClr val="F8FAFC"/>
-                </a:solidFill>
-              </a:defRPr>
-            </a:pPr>
-            <a:r>
-              <a:t>• TreeSHAP Explainer: Computes exact local Shapley feature attributions.</a:t>
-            </a:r>
-          </a:p>
-          <a:p>
-            <a:pPr>
-              <a:spcBef>
-                <a:spcPts val="500"/>
-              </a:spcBef>
-              <a:defRPr sz="1150">
-                <a:solidFill>
-                  <a:srgbClr val="F8FAFC"/>
-                </a:solidFill>
-              </a:defRPr>
-            </a:pPr>
-            <a:r>
-              <a:t>• Ciihive LMS Core: Automated double-entry disbursement and journal postings.</a:t>
-            </a:r>
-          </a:p>
-          <a:p>
-            <a:pPr>
-              <a:spcBef>
-                <a:spcPts val="500"/>
-              </a:spcBef>
-              <a:defRPr sz="1150">
-                <a:solidFill>
-                  <a:srgbClr val="F8FAFC"/>
-                </a:solidFill>
-              </a:defRPr>
-            </a:pPr>
-            <a:r>
-              <a:t>• IFRS 9 Provisioning: Automatic staging (Stage 1, Stage 2 SICR, Stage 3 Default).</a:t>
+              <a:t>4-Bound Constraint Sizing, TreeSHAP Explainability, and Double-Entry Disbursement</a:t>
             </a:r>
           </a:p>
         </p:txBody>
       </p:sp>
       <p:pic>
         <p:nvPicPr>
-          <p:cNvPr id="6" name="Picture 5" descr="flow_part3_ledger.png"/>
+          <p:cNvPr id="4" name="Picture 3" descr="flow_part3_ledger.png"/>
           <p:cNvPicPr>
             <a:picLocks noChangeAspect="1"/>
           </p:cNvPicPr>
@@ -7128,8 +6663,8 @@
         </p:blipFill>
         <p:spPr>
           <a:xfrm>
-            <a:off x="5577840" y="1645920"/>
-            <a:ext cx="5852160" cy="4754880"/>
+            <a:off x="1645920" y="1188720"/>
+            <a:ext cx="8869680" cy="5394960"/>
           </a:xfrm>
           <a:prstGeom prst="rect">
             <a:avLst/>
@@ -7205,8 +6740,8 @@
         </p:nvSpPr>
         <p:spPr>
           <a:xfrm>
-            <a:off x="731520" y="365760"/>
-            <a:ext cx="10698480" cy="1005840"/>
+            <a:off x="731520" y="274320"/>
+            <a:ext cx="10698480" cy="822960"/>
           </a:xfrm>
           <a:prstGeom prst="rect">
             <a:avLst/>
@@ -7220,22 +6755,22 @@
           <a:lstStyle/>
           <a:p>
             <a:pPr>
-              <a:defRPr sz="2600" b="1">
+              <a:defRPr sz="2400" b="1">
                 <a:solidFill>
                   <a:srgbClr val="38BDF8"/>
                 </a:solidFill>
               </a:defRPr>
             </a:pPr>
             <a:r>
-              <a:t>Complete Machine Learning Decision Pipeline</a:t>
-            </a:r>
-          </a:p>
-          <a:p>
-            <a:pPr>
-              <a:spcBef>
-                <a:spcPts val="400"/>
-              </a:spcBef>
-              <a:defRPr sz="1300">
+              <a:t>End-to-End Decisioning Pipeline &amp; Data Flow</a:t>
+            </a:r>
+          </a:p>
+          <a:p>
+            <a:pPr>
+              <a:spcBef>
+                <a:spcPts val="300"/>
+              </a:spcBef>
+              <a:defRPr sz="1200">
                 <a:solidFill>
                   <a:srgbClr val="94A3B8"/>
                 </a:solidFill>
@@ -7263,8 +6798,8 @@
         </p:blipFill>
         <p:spPr>
           <a:xfrm>
-            <a:off x="1371600" y="1645920"/>
-            <a:ext cx="9418320" cy="4754880"/>
+            <a:off x="1371600" y="1280160"/>
+            <a:ext cx="9418320" cy="5212080"/>
           </a:xfrm>
           <a:prstGeom prst="rect">
             <a:avLst/>
@@ -7340,8 +6875,8 @@
         </p:nvSpPr>
         <p:spPr>
           <a:xfrm>
-            <a:off x="731520" y="365760"/>
-            <a:ext cx="10698480" cy="1005840"/>
+            <a:off x="731520" y="274320"/>
+            <a:ext cx="10698480" cy="822960"/>
           </a:xfrm>
           <a:prstGeom prst="rect">
             <a:avLst/>
@@ -7355,7 +6890,7 @@
           <a:lstStyle/>
           <a:p>
             <a:pPr>
-              <a:defRPr sz="2600" b="1">
+              <a:defRPr sz="2400" b="1">
                 <a:solidFill>
                   <a:srgbClr val="38BDF8"/>
                 </a:solidFill>
@@ -7368,9 +6903,9 @@
           <a:p>
             <a:pPr>
               <a:spcBef>
-                <a:spcPts val="400"/>
-              </a:spcBef>
-              <a:defRPr sz="1300">
+                <a:spcPts val="300"/>
+              </a:spcBef>
+              <a:defRPr sz="1200">
                 <a:solidFill>
                   <a:srgbClr val="94A3B8"/>
                 </a:solidFill>
@@ -8006,8 +7541,8 @@
         </p:nvSpPr>
         <p:spPr>
           <a:xfrm>
-            <a:off x="731520" y="365760"/>
-            <a:ext cx="10698480" cy="1005840"/>
+            <a:off x="731520" y="274320"/>
+            <a:ext cx="10698480" cy="822960"/>
           </a:xfrm>
           <a:prstGeom prst="rect">
             <a:avLst/>
@@ -8021,7 +7556,7 @@
           <a:lstStyle/>
           <a:p>
             <a:pPr>
-              <a:defRPr sz="2600" b="1">
+              <a:defRPr sz="2400" b="1">
                 <a:solidFill>
                   <a:srgbClr val="38BDF8"/>
                 </a:solidFill>
@@ -8034,9 +7569,9 @@
           <a:p>
             <a:pPr>
               <a:spcBef>
-                <a:spcPts val="400"/>
-              </a:spcBef>
-              <a:defRPr sz="1300">
+                <a:spcPts val="300"/>
+              </a:spcBef>
+              <a:defRPr sz="1200">
                 <a:solidFill>
                   <a:srgbClr val="94A3B8"/>
                 </a:solidFill>
@@ -8457,8 +7992,8 @@
         </p:nvSpPr>
         <p:spPr>
           <a:xfrm>
-            <a:off x="731520" y="365760"/>
-            <a:ext cx="10698480" cy="1005840"/>
+            <a:off x="731520" y="274320"/>
+            <a:ext cx="10698480" cy="822960"/>
           </a:xfrm>
           <a:prstGeom prst="rect">
             <a:avLst/>
@@ -8472,7 +8007,7 @@
           <a:lstStyle/>
           <a:p>
             <a:pPr>
-              <a:defRPr sz="2600" b="1">
+              <a:defRPr sz="2400" b="1">
                 <a:solidFill>
                   <a:srgbClr val="38BDF8"/>
                 </a:solidFill>
@@ -8485,9 +8020,9 @@
           <a:p>
             <a:pPr>
               <a:spcBef>
-                <a:spcPts val="400"/>
-              </a:spcBef>
-              <a:defRPr sz="1300">
+                <a:spcPts val="300"/>
+              </a:spcBef>
+              <a:defRPr sz="1200">
                 <a:solidFill>
                   <a:srgbClr val="94A3B8"/>
                 </a:solidFill>

</xml_diff>